<commit_message>
Small edits to code comments and more work on presentation
</commit_message>
<xml_diff>
--- a/PizzaSolution Presentation.pptx
+++ b/PizzaSolution Presentation.pptx
@@ -8293,7 +8293,12 @@
             <p:ph type="title"/>
           </p:nvPr>
         </p:nvSpPr>
-        <p:spPr/>
+        <p:spPr>
+          <a:xfrm>
+            <a:off x="1006839" y="22786"/>
+            <a:ext cx="10178322" cy="1492132"/>
+          </a:xfrm>
+        </p:spPr>
         <p:txBody>
           <a:bodyPr/>
           <a:lstStyle/>
@@ -8306,75 +8311,100 @@
           </a:p>
         </p:txBody>
       </p:sp>
-      <p:sp>
-        <p:nvSpPr>
-          <p:cNvPr id="3" name="Pladsholder til indhold 2">
+      <p:pic>
+        <p:nvPicPr>
+          <p:cNvPr id="6" name="Pladsholder til indhold 5">
             <a:extLst>
               <a:ext uri="{FF2B5EF4-FFF2-40B4-BE49-F238E27FC236}">
-                <a16:creationId xmlns:a16="http://schemas.microsoft.com/office/drawing/2014/main" id="{38CED439-0052-153D-E8ED-E39C30D1CFF2}"/>
+                <a16:creationId xmlns:a16="http://schemas.microsoft.com/office/drawing/2014/main" id="{7960B9B7-D567-F571-3BA5-13B710D0B6F5}"/>
               </a:ext>
             </a:extLst>
           </p:cNvPr>
-          <p:cNvSpPr>
-            <a:spLocks noGrp="1"/>
-          </p:cNvSpPr>
+          <p:cNvPicPr>
+            <a:picLocks noGrp="1" noChangeAspect="1"/>
+          </p:cNvPicPr>
           <p:nvPr>
             <p:ph sz="half" idx="1"/>
           </p:nvPr>
-        </p:nvSpPr>
-        <p:spPr/>
-        <p:txBody>
-          <a:bodyPr/>
-          <a:lstStyle/>
-          <a:p>
-            <a:r>
-              <a:rPr lang="da-DK" dirty="0"/>
-              <a:t>Pictures of the </a:t>
-            </a:r>
-            <a:r>
-              <a:rPr lang="da-DK" dirty="0" err="1"/>
-              <a:t>code</a:t>
-            </a:r>
-            <a:r>
-              <a:rPr lang="da-DK" dirty="0"/>
-              <a:t> in </a:t>
-            </a:r>
-            <a:r>
-              <a:rPr lang="da-DK" dirty="0" err="1"/>
-              <a:t>its</a:t>
-            </a:r>
-            <a:r>
-              <a:rPr lang="da-DK" dirty="0"/>
-              <a:t> final form</a:t>
-            </a:r>
-          </a:p>
-        </p:txBody>
-      </p:sp>
-      <p:sp>
-        <p:nvSpPr>
-          <p:cNvPr id="4" name="Pladsholder til indhold 3">
+        </p:nvPicPr>
+        <p:blipFill>
+          <a:blip r:embed="rId3"/>
+          <a:stretch>
+            <a:fillRect/>
+          </a:stretch>
+        </p:blipFill>
+        <p:spPr>
+          <a:xfrm>
+            <a:off x="168011" y="768852"/>
+            <a:ext cx="6437254" cy="2150678"/>
+          </a:xfrm>
+          <a:prstGeom prst="rect">
+            <a:avLst/>
+          </a:prstGeom>
+        </p:spPr>
+      </p:pic>
+      <p:pic>
+        <p:nvPicPr>
+          <p:cNvPr id="10" name="Pladsholder til indhold 9">
             <a:extLst>
               <a:ext uri="{FF2B5EF4-FFF2-40B4-BE49-F238E27FC236}">
-                <a16:creationId xmlns:a16="http://schemas.microsoft.com/office/drawing/2014/main" id="{41D8DE06-E25F-89B7-2785-302FC80E5F0A}"/>
+                <a16:creationId xmlns:a16="http://schemas.microsoft.com/office/drawing/2014/main" id="{ABC519E2-208C-36C1-FDD3-1EFEFFB6A9E6}"/>
               </a:ext>
             </a:extLst>
           </p:cNvPr>
-          <p:cNvSpPr>
-            <a:spLocks noGrp="1"/>
-          </p:cNvSpPr>
+          <p:cNvPicPr>
+            <a:picLocks noGrp="1" noChangeAspect="1"/>
+          </p:cNvPicPr>
           <p:nvPr>
             <p:ph sz="half" idx="2"/>
           </p:nvPr>
-        </p:nvSpPr>
-        <p:spPr/>
-        <p:txBody>
-          <a:bodyPr/>
-          <a:lstStyle/>
-          <a:p>
-            <a:endParaRPr lang="da-DK"/>
-          </a:p>
-        </p:txBody>
-      </p:sp>
+        </p:nvPicPr>
+        <p:blipFill>
+          <a:blip r:embed="rId4"/>
+          <a:stretch>
+            <a:fillRect/>
+          </a:stretch>
+        </p:blipFill>
+        <p:spPr>
+          <a:xfrm>
+            <a:off x="6685497" y="825677"/>
+            <a:ext cx="5432075" cy="2037028"/>
+          </a:xfrm>
+          <a:prstGeom prst="rect">
+            <a:avLst/>
+          </a:prstGeom>
+        </p:spPr>
+      </p:pic>
+      <p:pic>
+        <p:nvPicPr>
+          <p:cNvPr id="8" name="Billede 7">
+            <a:extLst>
+              <a:ext uri="{FF2B5EF4-FFF2-40B4-BE49-F238E27FC236}">
+                <a16:creationId xmlns:a16="http://schemas.microsoft.com/office/drawing/2014/main" id="{3F5DBA51-BD90-BD5A-539D-E38EB69C323B}"/>
+              </a:ext>
+            </a:extLst>
+          </p:cNvPr>
+          <p:cNvPicPr>
+            <a:picLocks noChangeAspect="1"/>
+          </p:cNvPicPr>
+          <p:nvPr/>
+        </p:nvPicPr>
+        <p:blipFill>
+          <a:blip r:embed="rId5"/>
+          <a:stretch>
+            <a:fillRect/>
+          </a:stretch>
+        </p:blipFill>
+        <p:spPr>
+          <a:xfrm>
+            <a:off x="2349223" y="3036489"/>
+            <a:ext cx="7493553" cy="3703461"/>
+          </a:xfrm>
+          <a:prstGeom prst="rect">
+            <a:avLst/>
+          </a:prstGeom>
+        </p:spPr>
+      </p:pic>
     </p:spTree>
     <p:extLst>
       <p:ext uri="{BB962C8B-B14F-4D97-AF65-F5344CB8AC3E}">
@@ -8561,12 +8591,39 @@
             <p:ph sz="half" idx="1"/>
           </p:nvPr>
         </p:nvSpPr>
-        <p:spPr/>
+        <p:spPr>
+          <a:xfrm>
+            <a:off x="1257300" y="1339703"/>
+            <a:ext cx="4800600" cy="4565798"/>
+          </a:xfrm>
+        </p:spPr>
         <p:txBody>
           <a:bodyPr/>
           <a:lstStyle/>
           <a:p>
-            <a:endParaRPr lang="da-DK" dirty="0"/>
+            <a:r>
+              <a:rPr lang="en-US" noProof="0" dirty="0"/>
+              <a:t>Ideal code is written so that it doesn’t need comments (so try to write less of them)</a:t>
+            </a:r>
+          </a:p>
+          <a:p>
+            <a:r>
+              <a:rPr lang="en-US" dirty="0"/>
+              <a:t>Perhaps take the time to learn LINQ</a:t>
+            </a:r>
+          </a:p>
+          <a:p>
+            <a:r>
+              <a:rPr lang="en-US" dirty="0"/>
+              <a:t>The giant revolving pizza oven is terrible to implement, so can move on to other stuff if I want</a:t>
+            </a:r>
+          </a:p>
+          <a:p>
+            <a:r>
+              <a:rPr lang="en-US" noProof="0" dirty="0"/>
+              <a:t>The code is meant to make you pull your hair out</a:t>
+            </a:r>
+            <a:endParaRPr lang="en-DK" noProof="0" dirty="0"/>
           </a:p>
         </p:txBody>
       </p:sp>
@@ -8586,12 +8643,48 @@
             <p:ph sz="half" idx="2"/>
           </p:nvPr>
         </p:nvSpPr>
-        <p:spPr/>
+        <p:spPr>
+          <a:xfrm>
+            <a:off x="6647796" y="2892056"/>
+            <a:ext cx="4800600" cy="3583558"/>
+          </a:xfrm>
+        </p:spPr>
         <p:txBody>
           <a:bodyPr/>
           <a:lstStyle/>
           <a:p>
-            <a:endParaRPr lang="da-DK"/>
+            <a:pPr marL="0" indent="0">
+              <a:buNone/>
+            </a:pPr>
+            <a:r>
+              <a:rPr lang="en-DK" b="1" noProof="0" dirty="0"/>
+              <a:t>What I decided after:</a:t>
+            </a:r>
+          </a:p>
+          <a:p>
+            <a:r>
+              <a:rPr lang="en-US" dirty="0"/>
+              <a:t>Making the giant revolving pizza oven pass the tests will take a long time, so would rather focus on other stuff</a:t>
+            </a:r>
+          </a:p>
+          <a:p>
+            <a:r>
+              <a:rPr lang="en-US" dirty="0"/>
+              <a:t>Want to implement the helper functions into my code</a:t>
+            </a:r>
+          </a:p>
+          <a:p>
+            <a:r>
+              <a:rPr lang="en-US" noProof="0" dirty="0"/>
+              <a:t>Want to learn LINQ and get rid of as many foreaches as possible</a:t>
+            </a:r>
+          </a:p>
+          <a:p>
+            <a:r>
+              <a:rPr lang="en-US" dirty="0"/>
+              <a:t>If I have time, add database</a:t>
+            </a:r>
+            <a:endParaRPr lang="en-DK" noProof="0" dirty="0"/>
           </a:p>
         </p:txBody>
       </p:sp>

</xml_diff>

<commit_message>
GetStock has been LINQ-ified and uses helper function
</commit_message>
<xml_diff>
--- a/PizzaSolution Presentation.pptx
+++ b/PizzaSolution Presentation.pptx
@@ -8598,7 +8598,9 @@
           </a:xfrm>
         </p:spPr>
         <p:txBody>
-          <a:bodyPr/>
+          <a:bodyPr>
+            <a:normAutofit/>
+          </a:bodyPr>
           <a:lstStyle/>
           <a:p>
             <a:r>
@@ -8645,12 +8647,14 @@
         </p:nvSpPr>
         <p:spPr>
           <a:xfrm>
-            <a:off x="6647796" y="2892056"/>
-            <a:ext cx="4800600" cy="3583558"/>
+            <a:off x="6647796" y="2689412"/>
+            <a:ext cx="4800600" cy="3969572"/>
           </a:xfrm>
         </p:spPr>
         <p:txBody>
-          <a:bodyPr/>
+          <a:bodyPr>
+            <a:normAutofit/>
+          </a:bodyPr>
           <a:lstStyle/>
           <a:p>
             <a:pPr marL="0" indent="0">
@@ -8677,6 +8681,12 @@
             <a:r>
               <a:rPr lang="en-US" noProof="0" dirty="0"/>
               <a:t>Want to learn LINQ and get rid of as many foreaches as possible</a:t>
+            </a:r>
+          </a:p>
+          <a:p>
+            <a:r>
+              <a:rPr lang="en-US" noProof="0" dirty="0"/>
+              <a:t>Maybe get back to the oven</a:t>
             </a:r>
           </a:p>
           <a:p>

</xml_diff>

<commit_message>
Decided to not change much in Stock Service and added explanation in presentation
</commit_message>
<xml_diff>
--- a/PizzaSolution Presentation.pptx
+++ b/PizzaSolution Presentation.pptx
@@ -5,7 +5,7 @@
     <p:sldMasterId id="2147483660" r:id="rId1"/>
   </p:sldMasterIdLst>
   <p:notesMasterIdLst>
-    <p:notesMasterId r:id="rId10"/>
+    <p:notesMasterId r:id="rId11"/>
   </p:notesMasterIdLst>
   <p:sldIdLst>
     <p:sldId id="256" r:id="rId2"/>
@@ -13,9 +13,10 @@
     <p:sldId id="262" r:id="rId4"/>
     <p:sldId id="263" r:id="rId5"/>
     <p:sldId id="258" r:id="rId6"/>
-    <p:sldId id="259" r:id="rId7"/>
-    <p:sldId id="261" r:id="rId8"/>
-    <p:sldId id="260" r:id="rId9"/>
+    <p:sldId id="264" r:id="rId7"/>
+    <p:sldId id="259" r:id="rId8"/>
+    <p:sldId id="261" r:id="rId9"/>
+    <p:sldId id="260" r:id="rId10"/>
   </p:sldIdLst>
   <p:sldSz cx="12192000" cy="6858000"/>
   <p:notesSz cx="6858000" cy="9144000"/>
@@ -204,7 +205,7 @@
           <a:p>
             <a:fld id="{0F1AA9B0-0C32-482B-B713-D8137480A8FA}" type="datetimeFigureOut">
               <a:rPr lang="da-DK" smtClean="0"/>
-              <a:t>20-03-2026</a:t>
+              <a:t>23-03-2026</a:t>
             </a:fld>
             <a:endParaRPr lang="da-DK"/>
           </a:p>
@@ -1259,7 +1260,482 @@
           <a:bodyPr/>
           <a:lstStyle/>
           <a:p>
-            <a:endParaRPr lang="da-DK" dirty="0"/>
+            <a:pPr marL="0" marR="0" lvl="0" indent="0" algn="l" defTabSz="914400" rtl="0" eaLnBrk="1" fontAlgn="auto" latinLnBrk="0" hangingPunct="1">
+              <a:lnSpc>
+                <a:spcPct val="100000"/>
+              </a:lnSpc>
+              <a:spcBef>
+                <a:spcPts val="0"/>
+              </a:spcBef>
+              <a:spcAft>
+                <a:spcPts val="0"/>
+              </a:spcAft>
+              <a:buClrTx/>
+              <a:buSzTx/>
+              <a:buFontTx/>
+              <a:buNone/>
+              <a:tabLst/>
+              <a:defRPr/>
+            </a:pPr>
+            <a:r>
+              <a:rPr lang="en-US" dirty="0"/>
+              <a:t>Using the helper functions was worse for </a:t>
+            </a:r>
+            <a:r>
+              <a:rPr lang="en-US" dirty="0" err="1"/>
+              <a:t>GetSufficientStock</a:t>
+            </a:r>
+            <a:r>
+              <a:rPr lang="en-US" dirty="0"/>
+              <a:t> and my helper function </a:t>
+            </a:r>
+            <a:r>
+              <a:rPr lang="en-US" dirty="0" err="1"/>
+              <a:t>GetRecipeTypeAmountsInOrder</a:t>
+            </a:r>
+            <a:r>
+              <a:rPr lang="en-US" dirty="0"/>
+              <a:t>:</a:t>
+            </a:r>
+          </a:p>
+          <a:p>
+            <a:pPr marL="171450" marR="0" lvl="0" indent="-171450" algn="l" defTabSz="914400" rtl="0" eaLnBrk="1" fontAlgn="auto" latinLnBrk="0" hangingPunct="1">
+              <a:lnSpc>
+                <a:spcPct val="100000"/>
+              </a:lnSpc>
+              <a:spcBef>
+                <a:spcPts val="0"/>
+              </a:spcBef>
+              <a:spcAft>
+                <a:spcPts val="0"/>
+              </a:spcAft>
+              <a:buClrTx/>
+              <a:buSzTx/>
+              <a:buFontTx/>
+              <a:buChar char="-"/>
+              <a:tabLst/>
+              <a:defRPr/>
+            </a:pPr>
+            <a:r>
+              <a:rPr lang="da-DK" dirty="0" err="1"/>
+              <a:t>When</a:t>
+            </a:r>
+            <a:r>
+              <a:rPr lang="da-DK" dirty="0"/>
+              <a:t> </a:t>
+            </a:r>
+            <a:r>
+              <a:rPr lang="da-DK" dirty="0" err="1"/>
+              <a:t>trying</a:t>
+            </a:r>
+            <a:r>
+              <a:rPr lang="da-DK" dirty="0"/>
+              <a:t> to give </a:t>
+            </a:r>
+            <a:r>
+              <a:rPr lang="en-US" dirty="0" err="1"/>
+              <a:t>GetRecipeTypeAmountsInOrder</a:t>
+            </a:r>
+            <a:r>
+              <a:rPr lang="en-US" dirty="0"/>
+              <a:t> the </a:t>
+            </a:r>
+            <a:r>
+              <a:rPr lang="en-US" sz="1200" kern="1200" dirty="0" err="1">
+                <a:solidFill>
+                  <a:schemeClr val="tx1"/>
+                </a:solidFill>
+                <a:effectLst/>
+                <a:latin typeface="+mn-lt"/>
+                <a:ea typeface="+mn-ea"/>
+                <a:cs typeface="+mn-cs"/>
+              </a:rPr>
+              <a:t>GatherSameTypeOfStock</a:t>
+            </a:r>
+            <a:r>
+              <a:rPr lang="en-US" sz="1200" kern="1200" dirty="0">
+                <a:solidFill>
+                  <a:schemeClr val="tx1"/>
+                </a:solidFill>
+                <a:effectLst/>
+                <a:latin typeface="+mn-lt"/>
+                <a:ea typeface="+mn-ea"/>
+                <a:cs typeface="+mn-cs"/>
+              </a:rPr>
+              <a:t>-method from </a:t>
+            </a:r>
+            <a:r>
+              <a:rPr lang="da-DK" dirty="0" err="1"/>
+              <a:t>PizzaHelperExtensions</a:t>
+            </a:r>
+            <a:r>
+              <a:rPr lang="da-DK" dirty="0"/>
+              <a:t>, I </a:t>
+            </a:r>
+            <a:r>
+              <a:rPr lang="da-DK" dirty="0" err="1"/>
+              <a:t>ended</a:t>
+            </a:r>
+            <a:r>
+              <a:rPr lang="da-DK" dirty="0"/>
+              <a:t> up with a </a:t>
+            </a:r>
+            <a:r>
+              <a:rPr lang="da-DK" dirty="0" err="1"/>
+              <a:t>triple-nested</a:t>
+            </a:r>
+            <a:r>
+              <a:rPr lang="da-DK" dirty="0"/>
+              <a:t> </a:t>
+            </a:r>
+            <a:r>
+              <a:rPr lang="da-DK" dirty="0" err="1"/>
+              <a:t>foreach</a:t>
+            </a:r>
+            <a:r>
+              <a:rPr lang="da-DK" dirty="0"/>
+              <a:t> loop </a:t>
+            </a:r>
+            <a:r>
+              <a:rPr lang="da-DK" dirty="0" err="1"/>
+              <a:t>that</a:t>
+            </a:r>
+            <a:r>
+              <a:rPr lang="da-DK" dirty="0"/>
+              <a:t> I had to </a:t>
+            </a:r>
+            <a:r>
+              <a:rPr lang="da-DK" dirty="0" err="1"/>
+              <a:t>turn</a:t>
+            </a:r>
+            <a:r>
+              <a:rPr lang="da-DK" dirty="0"/>
+              <a:t> </a:t>
+            </a:r>
+            <a:r>
+              <a:rPr lang="da-DK" dirty="0" err="1"/>
+              <a:t>into</a:t>
+            </a:r>
+            <a:r>
+              <a:rPr lang="da-DK" dirty="0"/>
+              <a:t> a LINQ. </a:t>
+            </a:r>
+            <a:r>
+              <a:rPr lang="da-DK" dirty="0" err="1"/>
+              <a:t>Which</a:t>
+            </a:r>
+            <a:r>
+              <a:rPr lang="da-DK" dirty="0"/>
+              <a:t> </a:t>
+            </a:r>
+            <a:r>
+              <a:rPr lang="da-DK" dirty="0" err="1"/>
+              <a:t>was</a:t>
+            </a:r>
+            <a:r>
+              <a:rPr lang="da-DK" dirty="0"/>
+              <a:t> </a:t>
+            </a:r>
+            <a:r>
+              <a:rPr lang="da-DK" dirty="0" err="1"/>
+              <a:t>way</a:t>
+            </a:r>
+            <a:r>
+              <a:rPr lang="da-DK" dirty="0"/>
+              <a:t> </a:t>
+            </a:r>
+            <a:r>
+              <a:rPr lang="da-DK" dirty="0" err="1"/>
+              <a:t>less</a:t>
+            </a:r>
+            <a:r>
+              <a:rPr lang="da-DK" dirty="0"/>
+              <a:t> </a:t>
+            </a:r>
+            <a:r>
+              <a:rPr lang="da-DK" dirty="0" err="1"/>
+              <a:t>effective</a:t>
+            </a:r>
+            <a:r>
+              <a:rPr lang="da-DK" dirty="0"/>
+              <a:t> </a:t>
+            </a:r>
+            <a:r>
+              <a:rPr lang="da-DK" dirty="0" err="1"/>
+              <a:t>than</a:t>
+            </a:r>
+            <a:r>
+              <a:rPr lang="da-DK" dirty="0"/>
+              <a:t> the </a:t>
+            </a:r>
+            <a:r>
+              <a:rPr lang="da-DK" dirty="0" err="1"/>
+              <a:t>dictionary</a:t>
+            </a:r>
+            <a:r>
+              <a:rPr lang="da-DK" dirty="0"/>
+              <a:t> I had </a:t>
+            </a:r>
+            <a:r>
+              <a:rPr lang="da-DK" dirty="0" err="1"/>
+              <a:t>already</a:t>
+            </a:r>
+            <a:r>
+              <a:rPr lang="da-DK" dirty="0"/>
+              <a:t> made. And </a:t>
+            </a:r>
+            <a:r>
+              <a:rPr lang="da-DK" dirty="0" err="1"/>
+              <a:t>adding</a:t>
+            </a:r>
+            <a:r>
+              <a:rPr lang="da-DK" dirty="0"/>
+              <a:t> </a:t>
+            </a:r>
+            <a:r>
+              <a:rPr lang="da-DK" dirty="0" err="1"/>
+              <a:t>things</a:t>
+            </a:r>
+            <a:r>
+              <a:rPr lang="da-DK" dirty="0"/>
+              <a:t> to a </a:t>
+            </a:r>
+            <a:r>
+              <a:rPr lang="da-DK" dirty="0" err="1"/>
+              <a:t>dictionary</a:t>
+            </a:r>
+            <a:r>
+              <a:rPr lang="da-DK" dirty="0"/>
+              <a:t> with a LINQ </a:t>
+            </a:r>
+            <a:r>
+              <a:rPr lang="da-DK" dirty="0" err="1"/>
+              <a:t>was</a:t>
+            </a:r>
+            <a:r>
+              <a:rPr lang="da-DK" dirty="0"/>
+              <a:t> </a:t>
+            </a:r>
+            <a:r>
+              <a:rPr lang="da-DK" dirty="0" err="1"/>
+              <a:t>apparently</a:t>
+            </a:r>
+            <a:r>
+              <a:rPr lang="da-DK" dirty="0"/>
+              <a:t> </a:t>
+            </a:r>
+            <a:r>
+              <a:rPr lang="da-DK" dirty="0" err="1"/>
+              <a:t>slower</a:t>
+            </a:r>
+            <a:r>
+              <a:rPr lang="da-DK" dirty="0"/>
+              <a:t> </a:t>
+            </a:r>
+            <a:r>
+              <a:rPr lang="da-DK" dirty="0" err="1"/>
+              <a:t>than</a:t>
+            </a:r>
+            <a:r>
+              <a:rPr lang="da-DK" dirty="0"/>
+              <a:t> just </a:t>
+            </a:r>
+            <a:r>
+              <a:rPr lang="da-DK" dirty="0" err="1"/>
+              <a:t>doing</a:t>
+            </a:r>
+            <a:r>
+              <a:rPr lang="da-DK" dirty="0"/>
+              <a:t> it </a:t>
+            </a:r>
+            <a:r>
+              <a:rPr lang="da-DK" dirty="0" err="1"/>
+              <a:t>normally</a:t>
+            </a:r>
+            <a:r>
+              <a:rPr lang="da-DK" dirty="0"/>
+              <a:t>.</a:t>
+            </a:r>
+          </a:p>
+          <a:p>
+            <a:pPr marL="171450" marR="0" lvl="0" indent="-171450" algn="l" defTabSz="914400" rtl="0" eaLnBrk="1" fontAlgn="auto" latinLnBrk="0" hangingPunct="1">
+              <a:lnSpc>
+                <a:spcPct val="100000"/>
+              </a:lnSpc>
+              <a:spcBef>
+                <a:spcPts val="0"/>
+              </a:spcBef>
+              <a:spcAft>
+                <a:spcPts val="0"/>
+              </a:spcAft>
+              <a:buClrTx/>
+              <a:buSzTx/>
+              <a:buFontTx/>
+              <a:buChar char="-"/>
+              <a:tabLst/>
+              <a:defRPr/>
+            </a:pPr>
+            <a:r>
+              <a:rPr lang="da-DK" dirty="0"/>
+              <a:t>My normal </a:t>
+            </a:r>
+            <a:r>
+              <a:rPr lang="da-DK" dirty="0" err="1"/>
+              <a:t>foreaches</a:t>
+            </a:r>
+            <a:r>
+              <a:rPr lang="da-DK" dirty="0"/>
+              <a:t> </a:t>
+            </a:r>
+            <a:r>
+              <a:rPr lang="da-DK" dirty="0" err="1"/>
+              <a:t>were</a:t>
+            </a:r>
+            <a:r>
+              <a:rPr lang="da-DK" dirty="0"/>
+              <a:t> </a:t>
+            </a:r>
+            <a:r>
+              <a:rPr lang="da-DK" dirty="0" err="1"/>
+              <a:t>better</a:t>
+            </a:r>
+            <a:r>
+              <a:rPr lang="da-DK" dirty="0"/>
+              <a:t> </a:t>
+            </a:r>
+            <a:r>
+              <a:rPr lang="da-DK" dirty="0" err="1"/>
+              <a:t>than</a:t>
+            </a:r>
+            <a:r>
+              <a:rPr lang="da-DK" dirty="0"/>
+              <a:t> the alternative </a:t>
+            </a:r>
+            <a:r>
+              <a:rPr lang="da-DK" dirty="0" err="1"/>
+              <a:t>because</a:t>
+            </a:r>
+            <a:r>
+              <a:rPr lang="da-DK" dirty="0"/>
+              <a:t> in </a:t>
+            </a:r>
+            <a:r>
+              <a:rPr lang="da-DK" dirty="0" err="1"/>
+              <a:t>order</a:t>
+            </a:r>
+            <a:r>
+              <a:rPr lang="da-DK" dirty="0"/>
+              <a:t> to </a:t>
+            </a:r>
+            <a:r>
+              <a:rPr lang="da-DK" dirty="0" err="1"/>
+              <a:t>convert</a:t>
+            </a:r>
+            <a:r>
+              <a:rPr lang="da-DK" dirty="0"/>
+              <a:t> </a:t>
+            </a:r>
+            <a:r>
+              <a:rPr lang="da-DK" dirty="0" err="1"/>
+              <a:t>into</a:t>
+            </a:r>
+            <a:r>
+              <a:rPr lang="da-DK" dirty="0"/>
+              <a:t> the format the </a:t>
+            </a:r>
+            <a:r>
+              <a:rPr lang="da-DK" dirty="0" err="1"/>
+              <a:t>helper</a:t>
+            </a:r>
+            <a:r>
+              <a:rPr lang="da-DK" dirty="0"/>
+              <a:t> </a:t>
+            </a:r>
+            <a:r>
+              <a:rPr lang="da-DK" dirty="0" err="1"/>
+              <a:t>functions</a:t>
+            </a:r>
+            <a:r>
+              <a:rPr lang="da-DK" dirty="0"/>
+              <a:t> </a:t>
+            </a:r>
+            <a:r>
+              <a:rPr lang="da-DK" dirty="0" err="1"/>
+              <a:t>wanted</a:t>
+            </a:r>
+            <a:r>
+              <a:rPr lang="da-DK" dirty="0"/>
+              <a:t>, </a:t>
+            </a:r>
+            <a:r>
+              <a:rPr lang="da-DK" dirty="0" err="1"/>
+              <a:t>foreaches</a:t>
+            </a:r>
+            <a:r>
+              <a:rPr lang="da-DK" dirty="0"/>
+              <a:t> </a:t>
+            </a:r>
+            <a:r>
+              <a:rPr lang="da-DK" dirty="0" err="1"/>
+              <a:t>were</a:t>
+            </a:r>
+            <a:r>
+              <a:rPr lang="da-DK" dirty="0"/>
+              <a:t> </a:t>
+            </a:r>
+            <a:r>
+              <a:rPr lang="da-DK" dirty="0" err="1"/>
+              <a:t>needed</a:t>
+            </a:r>
+            <a:endParaRPr lang="en-US" dirty="0"/>
+          </a:p>
+          <a:p>
+            <a:pPr marL="0" marR="0" lvl="0" indent="0" algn="l" defTabSz="914400" rtl="0" eaLnBrk="1" fontAlgn="auto" latinLnBrk="0" hangingPunct="1">
+              <a:lnSpc>
+                <a:spcPct val="100000"/>
+              </a:lnSpc>
+              <a:spcBef>
+                <a:spcPts val="0"/>
+              </a:spcBef>
+              <a:spcAft>
+                <a:spcPts val="0"/>
+              </a:spcAft>
+              <a:buClrTx/>
+              <a:buSzTx/>
+              <a:buFontTx/>
+              <a:buNone/>
+              <a:tabLst/>
+              <a:defRPr/>
+            </a:pPr>
+            <a:endParaRPr lang="en-US" dirty="0"/>
+          </a:p>
+          <a:p>
+            <a:pPr marL="0" marR="0" lvl="0" indent="0" algn="l" defTabSz="914400" rtl="0" eaLnBrk="1" fontAlgn="auto" latinLnBrk="0" hangingPunct="1">
+              <a:lnSpc>
+                <a:spcPct val="100000"/>
+              </a:lnSpc>
+              <a:spcBef>
+                <a:spcPts val="0"/>
+              </a:spcBef>
+              <a:spcAft>
+                <a:spcPts val="0"/>
+              </a:spcAft>
+              <a:buClrTx/>
+              <a:buSzTx/>
+              <a:buFontTx/>
+              <a:buNone/>
+              <a:tabLst/>
+              <a:defRPr/>
+            </a:pPr>
+            <a:r>
+              <a:rPr lang="en-US" dirty="0"/>
+              <a:t>Really cut down </a:t>
+            </a:r>
+            <a:r>
+              <a:rPr lang="en-US" dirty="0" err="1"/>
+              <a:t>GetStock</a:t>
+            </a:r>
+            <a:endParaRPr lang="en-US" dirty="0"/>
           </a:p>
         </p:txBody>
       </p:sp>
@@ -1280,7 +1756,175 @@
           <a:p>
             <a:fld id="{C2B1EF5D-2231-4646-8EED-1BCCADFE16C5}" type="slidenum">
               <a:rPr lang="da-DK" smtClean="0"/>
+              <a:t>6</a:t>
+            </a:fld>
+            <a:endParaRPr lang="da-DK"/>
+          </a:p>
+        </p:txBody>
+      </p:sp>
+    </p:spTree>
+    <p:extLst>
+      <p:ext uri="{BB962C8B-B14F-4D97-AF65-F5344CB8AC3E}">
+        <p14:creationId xmlns:p14="http://schemas.microsoft.com/office/powerpoint/2010/main" val="16619558"/>
+      </p:ext>
+    </p:extLst>
+  </p:cSld>
+  <p:clrMapOvr>
+    <a:masterClrMapping/>
+  </p:clrMapOvr>
+</p:notes>
+</file>
+
+<file path=ppt/notesSlides/notesSlide5.xml><?xml version="1.0" encoding="utf-8"?>
+<p:notes xmlns:a="http://schemas.openxmlformats.org/drawingml/2006/main" xmlns:r="http://schemas.openxmlformats.org/officeDocument/2006/relationships" xmlns:p="http://schemas.openxmlformats.org/presentationml/2006/main">
+  <p:cSld>
+    <p:spTree>
+      <p:nvGrpSpPr>
+        <p:cNvPr id="1" name=""/>
+        <p:cNvGrpSpPr/>
+        <p:nvPr/>
+      </p:nvGrpSpPr>
+      <p:grpSpPr>
+        <a:xfrm>
+          <a:off x="0" y="0"/>
+          <a:ext cx="0" cy="0"/>
+          <a:chOff x="0" y="0"/>
+          <a:chExt cx="0" cy="0"/>
+        </a:xfrm>
+      </p:grpSpPr>
+      <p:sp>
+        <p:nvSpPr>
+          <p:cNvPr id="2" name="Pladsholder til slidebillede 1"/>
+          <p:cNvSpPr>
+            <a:spLocks noGrp="1" noRot="1" noChangeAspect="1"/>
+          </p:cNvSpPr>
+          <p:nvPr>
+            <p:ph type="sldImg"/>
+          </p:nvPr>
+        </p:nvSpPr>
+        <p:spPr/>
+      </p:sp>
+      <p:sp>
+        <p:nvSpPr>
+          <p:cNvPr id="3" name="Pladsholder til noter 2"/>
+          <p:cNvSpPr>
+            <a:spLocks noGrp="1"/>
+          </p:cNvSpPr>
+          <p:nvPr>
+            <p:ph type="body" idx="1"/>
+          </p:nvPr>
+        </p:nvSpPr>
+        <p:spPr/>
+        <p:txBody>
+          <a:bodyPr/>
+          <a:lstStyle/>
+          <a:p>
+            <a:endParaRPr lang="da-DK" dirty="0"/>
+          </a:p>
+        </p:txBody>
+      </p:sp>
+      <p:sp>
+        <p:nvSpPr>
+          <p:cNvPr id="4" name="Pladsholder til slidenummer 3"/>
+          <p:cNvSpPr>
+            <a:spLocks noGrp="1"/>
+          </p:cNvSpPr>
+          <p:nvPr>
+            <p:ph type="sldNum" sz="quarter" idx="5"/>
+          </p:nvPr>
+        </p:nvSpPr>
+        <p:spPr/>
+        <p:txBody>
+          <a:bodyPr/>
+          <a:lstStyle/>
+          <a:p>
+            <a:fld id="{C2B1EF5D-2231-4646-8EED-1BCCADFE16C5}" type="slidenum">
+              <a:rPr lang="da-DK" smtClean="0"/>
               <a:t>7</a:t>
+            </a:fld>
+            <a:endParaRPr lang="da-DK"/>
+          </a:p>
+        </p:txBody>
+      </p:sp>
+    </p:spTree>
+    <p:extLst>
+      <p:ext uri="{BB962C8B-B14F-4D97-AF65-F5344CB8AC3E}">
+        <p14:creationId xmlns:p14="http://schemas.microsoft.com/office/powerpoint/2010/main" val="3668114257"/>
+      </p:ext>
+    </p:extLst>
+  </p:cSld>
+  <p:clrMapOvr>
+    <a:masterClrMapping/>
+  </p:clrMapOvr>
+</p:notes>
+</file>
+
+<file path=ppt/notesSlides/notesSlide6.xml><?xml version="1.0" encoding="utf-8"?>
+<p:notes xmlns:a="http://schemas.openxmlformats.org/drawingml/2006/main" xmlns:r="http://schemas.openxmlformats.org/officeDocument/2006/relationships" xmlns:p="http://schemas.openxmlformats.org/presentationml/2006/main">
+  <p:cSld>
+    <p:spTree>
+      <p:nvGrpSpPr>
+        <p:cNvPr id="1" name=""/>
+        <p:cNvGrpSpPr/>
+        <p:nvPr/>
+      </p:nvGrpSpPr>
+      <p:grpSpPr>
+        <a:xfrm>
+          <a:off x="0" y="0"/>
+          <a:ext cx="0" cy="0"/>
+          <a:chOff x="0" y="0"/>
+          <a:chExt cx="0" cy="0"/>
+        </a:xfrm>
+      </p:grpSpPr>
+      <p:sp>
+        <p:nvSpPr>
+          <p:cNvPr id="2" name="Pladsholder til slidebillede 1"/>
+          <p:cNvSpPr>
+            <a:spLocks noGrp="1" noRot="1" noChangeAspect="1"/>
+          </p:cNvSpPr>
+          <p:nvPr>
+            <p:ph type="sldImg"/>
+          </p:nvPr>
+        </p:nvSpPr>
+        <p:spPr/>
+      </p:sp>
+      <p:sp>
+        <p:nvSpPr>
+          <p:cNvPr id="3" name="Pladsholder til noter 2"/>
+          <p:cNvSpPr>
+            <a:spLocks noGrp="1"/>
+          </p:cNvSpPr>
+          <p:nvPr>
+            <p:ph type="body" idx="1"/>
+          </p:nvPr>
+        </p:nvSpPr>
+        <p:spPr/>
+        <p:txBody>
+          <a:bodyPr/>
+          <a:lstStyle/>
+          <a:p>
+            <a:endParaRPr lang="da-DK" dirty="0"/>
+          </a:p>
+        </p:txBody>
+      </p:sp>
+      <p:sp>
+        <p:nvSpPr>
+          <p:cNvPr id="4" name="Pladsholder til slidenummer 3"/>
+          <p:cNvSpPr>
+            <a:spLocks noGrp="1"/>
+          </p:cNvSpPr>
+          <p:nvPr>
+            <p:ph type="sldNum" sz="quarter" idx="5"/>
+          </p:nvPr>
+        </p:nvSpPr>
+        <p:spPr/>
+        <p:txBody>
+          <a:bodyPr/>
+          <a:lstStyle/>
+          <a:p>
+            <a:fld id="{C2B1EF5D-2231-4646-8EED-1BCCADFE16C5}" type="slidenum">
+              <a:rPr lang="da-DK" smtClean="0"/>
+              <a:t>8</a:t>
             </a:fld>
             <a:endParaRPr lang="da-DK"/>
           </a:p>
@@ -2510,7 +3154,7 @@
           <a:p>
             <a:fld id="{9F2C61E5-4FB9-4B7B-BFC7-89973F7231D0}" type="datetimeFigureOut">
               <a:rPr lang="da-DK" smtClean="0"/>
-              <a:t>20-03-2026</a:t>
+              <a:t>23-03-2026</a:t>
             </a:fld>
             <a:endParaRPr lang="da-DK"/>
           </a:p>
@@ -2748,7 +3392,7 @@
           <a:p>
             <a:fld id="{9F2C61E5-4FB9-4B7B-BFC7-89973F7231D0}" type="datetimeFigureOut">
               <a:rPr lang="da-DK" smtClean="0"/>
-              <a:t>20-03-2026</a:t>
+              <a:t>23-03-2026</a:t>
             </a:fld>
             <a:endParaRPr lang="da-DK"/>
           </a:p>
@@ -2928,7 +3572,7 @@
           <a:p>
             <a:fld id="{9F2C61E5-4FB9-4B7B-BFC7-89973F7231D0}" type="datetimeFigureOut">
               <a:rPr lang="da-DK" smtClean="0"/>
-              <a:t>20-03-2026</a:t>
+              <a:t>23-03-2026</a:t>
             </a:fld>
             <a:endParaRPr lang="da-DK"/>
           </a:p>
@@ -3098,7 +3742,7 @@
           <a:p>
             <a:fld id="{9F2C61E5-4FB9-4B7B-BFC7-89973F7231D0}" type="datetimeFigureOut">
               <a:rPr lang="da-DK" smtClean="0"/>
-              <a:t>20-03-2026</a:t>
+              <a:t>23-03-2026</a:t>
             </a:fld>
             <a:endParaRPr lang="da-DK"/>
           </a:p>
@@ -3374,7 +4018,7 @@
           <a:p>
             <a:fld id="{9F2C61E5-4FB9-4B7B-BFC7-89973F7231D0}" type="datetimeFigureOut">
               <a:rPr lang="da-DK" smtClean="0"/>
-              <a:t>20-03-2026</a:t>
+              <a:t>23-03-2026</a:t>
             </a:fld>
             <a:endParaRPr lang="da-DK"/>
           </a:p>
@@ -4575,7 +5219,7 @@
           <a:p>
             <a:fld id="{9F2C61E5-4FB9-4B7B-BFC7-89973F7231D0}" type="datetimeFigureOut">
               <a:rPr lang="da-DK" smtClean="0"/>
-              <a:t>20-03-2026</a:t>
+              <a:t>23-03-2026</a:t>
             </a:fld>
             <a:endParaRPr lang="da-DK"/>
           </a:p>
@@ -4965,7 +5609,7 @@
           <a:p>
             <a:fld id="{9F2C61E5-4FB9-4B7B-BFC7-89973F7231D0}" type="datetimeFigureOut">
               <a:rPr lang="da-DK" smtClean="0"/>
-              <a:t>20-03-2026</a:t>
+              <a:t>23-03-2026</a:t>
             </a:fld>
             <a:endParaRPr lang="da-DK"/>
           </a:p>
@@ -5088,7 +5732,7 @@
           <a:p>
             <a:fld id="{9F2C61E5-4FB9-4B7B-BFC7-89973F7231D0}" type="datetimeFigureOut">
               <a:rPr lang="da-DK" smtClean="0"/>
-              <a:t>20-03-2026</a:t>
+              <a:t>23-03-2026</a:t>
             </a:fld>
             <a:endParaRPr lang="da-DK"/>
           </a:p>
@@ -5183,7 +5827,7 @@
           <a:p>
             <a:fld id="{9F2C61E5-4FB9-4B7B-BFC7-89973F7231D0}" type="datetimeFigureOut">
               <a:rPr lang="da-DK" smtClean="0"/>
-              <a:t>20-03-2026</a:t>
+              <a:t>23-03-2026</a:t>
             </a:fld>
             <a:endParaRPr lang="da-DK"/>
           </a:p>
@@ -5946,7 +6590,7 @@
           <a:p>
             <a:fld id="{9F2C61E5-4FB9-4B7B-BFC7-89973F7231D0}" type="datetimeFigureOut">
               <a:rPr lang="da-DK" smtClean="0"/>
-              <a:t>20-03-2026</a:t>
+              <a:t>23-03-2026</a:t>
             </a:fld>
             <a:endParaRPr lang="da-DK"/>
           </a:p>
@@ -6786,7 +7430,7 @@
           <a:p>
             <a:fld id="{9F2C61E5-4FB9-4B7B-BFC7-89973F7231D0}" type="datetimeFigureOut">
               <a:rPr lang="da-DK" smtClean="0"/>
-              <a:t>20-03-2026</a:t>
+              <a:t>23-03-2026</a:t>
             </a:fld>
             <a:endParaRPr lang="da-DK"/>
           </a:p>
@@ -7013,7 +7657,7 @@
           <a:p>
             <a:fld id="{9F2C61E5-4FB9-4B7B-BFC7-89973F7231D0}" type="datetimeFigureOut">
               <a:rPr lang="da-DK" smtClean="0"/>
-              <a:t>20-03-2026</a:t>
+              <a:t>23-03-2026</a:t>
             </a:fld>
             <a:endParaRPr lang="da-DK"/>
           </a:p>
@@ -8305,7 +8949,7 @@
           <a:p>
             <a:r>
               <a:rPr lang="da-DK" dirty="0" err="1"/>
-              <a:t>HasInsufficientStock</a:t>
+              <a:t>StockService</a:t>
             </a:r>
             <a:endParaRPr lang="da-DK" dirty="0"/>
           </a:p>
@@ -8733,7 +9377,7 @@
           <p:cNvPr id="2" name="Titel 1">
             <a:extLst>
               <a:ext uri="{FF2B5EF4-FFF2-40B4-BE49-F238E27FC236}">
-                <a16:creationId xmlns:a16="http://schemas.microsoft.com/office/drawing/2014/main" id="{16D6FD49-2DB9-5A7C-B33A-EB8FD60B1770}"/>
+                <a16:creationId xmlns:a16="http://schemas.microsoft.com/office/drawing/2014/main" id="{995A713E-8C92-130A-61FF-0FD30DFFC80C}"/>
               </a:ext>
             </a:extLst>
           </p:cNvPr>
@@ -8750,19 +9394,22 @@
           <a:lstStyle/>
           <a:p>
             <a:r>
-              <a:rPr lang="en-US" noProof="0" dirty="0"/>
-              <a:t>Later problems/thoughts</a:t>
-            </a:r>
-            <a:endParaRPr lang="en-DK" noProof="0" dirty="0"/>
+              <a:rPr lang="en-US" noProof="0" dirty="0" err="1"/>
+              <a:t>StockService</a:t>
+            </a:r>
+            <a:r>
+              <a:rPr lang="en-DK" noProof="0" dirty="0"/>
+              <a:t> 2.0</a:t>
+            </a:r>
           </a:p>
         </p:txBody>
       </p:sp>
       <p:sp>
         <p:nvSpPr>
-          <p:cNvPr id="3" name="Pladsholder til indhold 2">
+          <p:cNvPr id="4" name="Pladsholder til indhold 3">
             <a:extLst>
               <a:ext uri="{FF2B5EF4-FFF2-40B4-BE49-F238E27FC236}">
-                <a16:creationId xmlns:a16="http://schemas.microsoft.com/office/drawing/2014/main" id="{BC1823F3-3FB9-49C5-B880-461F2701AD27}"/>
+                <a16:creationId xmlns:a16="http://schemas.microsoft.com/office/drawing/2014/main" id="{70A43850-0C58-53C7-4371-E14AF5F231AF}"/>
               </a:ext>
             </a:extLst>
           </p:cNvPr>
@@ -8770,7 +9417,7 @@
             <a:spLocks noGrp="1"/>
           </p:cNvSpPr>
           <p:nvPr>
-            <p:ph sz="half" idx="1"/>
+            <p:ph sz="half" idx="2"/>
           </p:nvPr>
         </p:nvSpPr>
         <p:spPr/>
@@ -8778,45 +9425,248 @@
           <a:bodyPr/>
           <a:lstStyle/>
           <a:p>
-            <a:endParaRPr lang="da-DK" dirty="0"/>
+            <a:endParaRPr lang="da-DK"/>
           </a:p>
         </p:txBody>
       </p:sp>
-      <p:sp>
-        <p:nvSpPr>
-          <p:cNvPr id="4" name="Pladsholder til indhold 3">
+      <p:pic>
+        <p:nvPicPr>
+          <p:cNvPr id="5" name="Pladsholder til indhold 4">
             <a:extLst>
               <a:ext uri="{FF2B5EF4-FFF2-40B4-BE49-F238E27FC236}">
-                <a16:creationId xmlns:a16="http://schemas.microsoft.com/office/drawing/2014/main" id="{47C8E8B0-70D6-0E5E-F1F3-83A2F00EB827}"/>
+                <a16:creationId xmlns:a16="http://schemas.microsoft.com/office/drawing/2014/main" id="{6597DF00-55C1-FC3A-A33B-41C32C64AC8F}"/>
               </a:ext>
             </a:extLst>
           </p:cNvPr>
-          <p:cNvSpPr>
-            <a:spLocks noGrp="1"/>
-          </p:cNvSpPr>
-          <p:nvPr>
-            <p:ph sz="half" idx="2"/>
-          </p:nvPr>
-        </p:nvSpPr>
-        <p:spPr/>
-        <p:txBody>
-          <a:bodyPr/>
-          <a:lstStyle/>
-          <a:p>
-            <a:endParaRPr lang="da-DK"/>
-          </a:p>
-        </p:txBody>
-      </p:sp>
+          <p:cNvPicPr>
+            <a:picLocks noGrp="1" noChangeAspect="1"/>
+          </p:cNvPicPr>
+          <p:nvPr>
+            <p:ph sz="half" idx="1"/>
+          </p:nvPr>
+        </p:nvPicPr>
+        <p:blipFill>
+          <a:blip r:embed="rId3"/>
+          <a:stretch>
+            <a:fillRect/>
+          </a:stretch>
+        </p:blipFill>
+        <p:spPr>
+          <a:xfrm>
+            <a:off x="2780207" y="1177962"/>
+            <a:ext cx="6631585" cy="3277458"/>
+          </a:xfrm>
+          <a:prstGeom prst="rect">
+            <a:avLst/>
+          </a:prstGeom>
+        </p:spPr>
+      </p:pic>
+      <p:pic>
+        <p:nvPicPr>
+          <p:cNvPr id="7" name="Billede 6">
+            <a:extLst>
+              <a:ext uri="{FF2B5EF4-FFF2-40B4-BE49-F238E27FC236}">
+                <a16:creationId xmlns:a16="http://schemas.microsoft.com/office/drawing/2014/main" id="{39800786-4F93-F5D6-AE46-588934001C80}"/>
+              </a:ext>
+            </a:extLst>
+          </p:cNvPr>
+          <p:cNvPicPr>
+            <a:picLocks noChangeAspect="1"/>
+          </p:cNvPicPr>
+          <p:nvPr/>
+        </p:nvPicPr>
+        <p:blipFill>
+          <a:blip r:embed="rId4"/>
+          <a:stretch>
+            <a:fillRect/>
+          </a:stretch>
+        </p:blipFill>
+        <p:spPr>
+          <a:xfrm>
+            <a:off x="1134885" y="4727053"/>
+            <a:ext cx="10411908" cy="1450080"/>
+          </a:xfrm>
+          <a:prstGeom prst="rect">
+            <a:avLst/>
+          </a:prstGeom>
+        </p:spPr>
+      </p:pic>
     </p:spTree>
     <p:extLst>
       <p:ext uri="{BB962C8B-B14F-4D97-AF65-F5344CB8AC3E}">
-        <p14:creationId xmlns:p14="http://schemas.microsoft.com/office/powerpoint/2010/main" val="1482066582"/>
+        <p14:creationId xmlns:p14="http://schemas.microsoft.com/office/powerpoint/2010/main" val="270921356"/>
       </p:ext>
     </p:extLst>
   </p:cSld>
   <p:clrMapOvr>
     <a:masterClrMapping/>
   </p:clrMapOvr>
+  <p:timing>
+    <p:tnLst>
+      <p:par>
+        <p:cTn id="1" dur="indefinite" restart="never" nodeType="tmRoot">
+          <p:childTnLst>
+            <p:seq concurrent="1" nextAc="seek">
+              <p:cTn id="2" dur="indefinite" nodeType="mainSeq">
+                <p:childTnLst>
+                  <p:par>
+                    <p:cTn id="3" fill="hold">
+                      <p:stCondLst>
+                        <p:cond delay="indefinite"/>
+                      </p:stCondLst>
+                      <p:childTnLst>
+                        <p:par>
+                          <p:cTn id="4" fill="hold">
+                            <p:stCondLst>
+                              <p:cond delay="0"/>
+                            </p:stCondLst>
+                            <p:childTnLst>
+                              <p:par>
+                                <p:cTn id="5" presetID="1" presetClass="entr" presetSubtype="0" fill="hold" nodeType="clickEffect">
+                                  <p:stCondLst>
+                                    <p:cond delay="0"/>
+                                  </p:stCondLst>
+                                  <p:childTnLst>
+                                    <p:set>
+                                      <p:cBhvr>
+                                        <p:cTn id="6" dur="1" fill="hold">
+                                          <p:stCondLst>
+                                            <p:cond delay="0"/>
+                                          </p:stCondLst>
+                                        </p:cTn>
+                                        <p:tgtEl>
+                                          <p:spTgt spid="5"/>
+                                        </p:tgtEl>
+                                        <p:attrNameLst>
+                                          <p:attrName>style.visibility</p:attrName>
+                                        </p:attrNameLst>
+                                      </p:cBhvr>
+                                      <p:to>
+                                        <p:strVal val="visible"/>
+                                      </p:to>
+                                    </p:set>
+                                  </p:childTnLst>
+                                </p:cTn>
+                              </p:par>
+                            </p:childTnLst>
+                          </p:cTn>
+                        </p:par>
+                      </p:childTnLst>
+                    </p:cTn>
+                  </p:par>
+                  <p:par>
+                    <p:cTn id="7" fill="hold">
+                      <p:stCondLst>
+                        <p:cond delay="indefinite"/>
+                      </p:stCondLst>
+                      <p:childTnLst>
+                        <p:par>
+                          <p:cTn id="8" fill="hold">
+                            <p:stCondLst>
+                              <p:cond delay="0"/>
+                            </p:stCondLst>
+                            <p:childTnLst>
+                              <p:par>
+                                <p:cTn id="9" presetID="2" presetClass="entr" presetSubtype="8" fill="hold" nodeType="clickEffect">
+                                  <p:stCondLst>
+                                    <p:cond delay="0"/>
+                                  </p:stCondLst>
+                                  <p:childTnLst>
+                                    <p:set>
+                                      <p:cBhvr>
+                                        <p:cTn id="10" dur="1" fill="hold">
+                                          <p:stCondLst>
+                                            <p:cond delay="0"/>
+                                          </p:stCondLst>
+                                        </p:cTn>
+                                        <p:tgtEl>
+                                          <p:spTgt spid="7"/>
+                                        </p:tgtEl>
+                                        <p:attrNameLst>
+                                          <p:attrName>style.visibility</p:attrName>
+                                        </p:attrNameLst>
+                                      </p:cBhvr>
+                                      <p:to>
+                                        <p:strVal val="visible"/>
+                                      </p:to>
+                                    </p:set>
+                                    <p:anim calcmode="lin" valueType="num">
+                                      <p:cBhvr additive="base">
+                                        <p:cTn id="11" dur="500" fill="hold"/>
+                                        <p:tgtEl>
+                                          <p:spTgt spid="7"/>
+                                        </p:tgtEl>
+                                        <p:attrNameLst>
+                                          <p:attrName>ppt_x</p:attrName>
+                                        </p:attrNameLst>
+                                      </p:cBhvr>
+                                      <p:tavLst>
+                                        <p:tav tm="0">
+                                          <p:val>
+                                            <p:strVal val="0-#ppt_w/2"/>
+                                          </p:val>
+                                        </p:tav>
+                                        <p:tav tm="100000">
+                                          <p:val>
+                                            <p:strVal val="#ppt_x"/>
+                                          </p:val>
+                                        </p:tav>
+                                      </p:tavLst>
+                                    </p:anim>
+                                    <p:anim calcmode="lin" valueType="num">
+                                      <p:cBhvr additive="base">
+                                        <p:cTn id="12" dur="500" fill="hold"/>
+                                        <p:tgtEl>
+                                          <p:spTgt spid="7"/>
+                                        </p:tgtEl>
+                                        <p:attrNameLst>
+                                          <p:attrName>ppt_y</p:attrName>
+                                        </p:attrNameLst>
+                                      </p:cBhvr>
+                                      <p:tavLst>
+                                        <p:tav tm="0">
+                                          <p:val>
+                                            <p:strVal val="#ppt_y"/>
+                                          </p:val>
+                                        </p:tav>
+                                        <p:tav tm="100000">
+                                          <p:val>
+                                            <p:strVal val="#ppt_y"/>
+                                          </p:val>
+                                        </p:tav>
+                                      </p:tavLst>
+                                    </p:anim>
+                                  </p:childTnLst>
+                                </p:cTn>
+                              </p:par>
+                            </p:childTnLst>
+                          </p:cTn>
+                        </p:par>
+                      </p:childTnLst>
+                    </p:cTn>
+                  </p:par>
+                </p:childTnLst>
+              </p:cTn>
+              <p:prevCondLst>
+                <p:cond evt="onPrev" delay="0">
+                  <p:tgtEl>
+                    <p:sldTgt/>
+                  </p:tgtEl>
+                </p:cond>
+              </p:prevCondLst>
+              <p:nextCondLst>
+                <p:cond evt="onNext" delay="0">
+                  <p:tgtEl>
+                    <p:sldTgt/>
+                  </p:tgtEl>
+                </p:cond>
+              </p:nextCondLst>
+            </p:seq>
+          </p:childTnLst>
+        </p:cTn>
+      </p:par>
+    </p:tnLst>
+  </p:timing>
 </p:sld>
 </file>
 
@@ -8842,6 +9692,115 @@
           <p:cNvPr id="2" name="Titel 1">
             <a:extLst>
               <a:ext uri="{FF2B5EF4-FFF2-40B4-BE49-F238E27FC236}">
+                <a16:creationId xmlns:a16="http://schemas.microsoft.com/office/drawing/2014/main" id="{16D6FD49-2DB9-5A7C-B33A-EB8FD60B1770}"/>
+              </a:ext>
+            </a:extLst>
+          </p:cNvPr>
+          <p:cNvSpPr>
+            <a:spLocks noGrp="1"/>
+          </p:cNvSpPr>
+          <p:nvPr>
+            <p:ph type="title"/>
+          </p:nvPr>
+        </p:nvSpPr>
+        <p:spPr/>
+        <p:txBody>
+          <a:bodyPr/>
+          <a:lstStyle/>
+          <a:p>
+            <a:r>
+              <a:rPr lang="en-US" noProof="0" dirty="0"/>
+              <a:t>Later problems/thoughts</a:t>
+            </a:r>
+            <a:endParaRPr lang="en-DK" noProof="0" dirty="0"/>
+          </a:p>
+        </p:txBody>
+      </p:sp>
+      <p:sp>
+        <p:nvSpPr>
+          <p:cNvPr id="3" name="Pladsholder til indhold 2">
+            <a:extLst>
+              <a:ext uri="{FF2B5EF4-FFF2-40B4-BE49-F238E27FC236}">
+                <a16:creationId xmlns:a16="http://schemas.microsoft.com/office/drawing/2014/main" id="{BC1823F3-3FB9-49C5-B880-461F2701AD27}"/>
+              </a:ext>
+            </a:extLst>
+          </p:cNvPr>
+          <p:cNvSpPr>
+            <a:spLocks noGrp="1"/>
+          </p:cNvSpPr>
+          <p:nvPr>
+            <p:ph sz="half" idx="1"/>
+          </p:nvPr>
+        </p:nvSpPr>
+        <p:spPr/>
+        <p:txBody>
+          <a:bodyPr/>
+          <a:lstStyle/>
+          <a:p>
+            <a:endParaRPr lang="en-DK" noProof="0" dirty="0"/>
+          </a:p>
+        </p:txBody>
+      </p:sp>
+      <p:sp>
+        <p:nvSpPr>
+          <p:cNvPr id="4" name="Pladsholder til indhold 3">
+            <a:extLst>
+              <a:ext uri="{FF2B5EF4-FFF2-40B4-BE49-F238E27FC236}">
+                <a16:creationId xmlns:a16="http://schemas.microsoft.com/office/drawing/2014/main" id="{47C8E8B0-70D6-0E5E-F1F3-83A2F00EB827}"/>
+              </a:ext>
+            </a:extLst>
+          </p:cNvPr>
+          <p:cNvSpPr>
+            <a:spLocks noGrp="1"/>
+          </p:cNvSpPr>
+          <p:nvPr>
+            <p:ph sz="half" idx="2"/>
+          </p:nvPr>
+        </p:nvSpPr>
+        <p:spPr/>
+        <p:txBody>
+          <a:bodyPr/>
+          <a:lstStyle/>
+          <a:p>
+            <a:endParaRPr lang="da-DK"/>
+          </a:p>
+        </p:txBody>
+      </p:sp>
+    </p:spTree>
+    <p:extLst>
+      <p:ext uri="{BB962C8B-B14F-4D97-AF65-F5344CB8AC3E}">
+        <p14:creationId xmlns:p14="http://schemas.microsoft.com/office/powerpoint/2010/main" val="1482066582"/>
+      </p:ext>
+    </p:extLst>
+  </p:cSld>
+  <p:clrMapOvr>
+    <a:masterClrMapping/>
+  </p:clrMapOvr>
+</p:sld>
+</file>
+
+<file path=ppt/slides/slide8.xml><?xml version="1.0" encoding="utf-8"?>
+<p:sld xmlns:a="http://schemas.openxmlformats.org/drawingml/2006/main" xmlns:r="http://schemas.openxmlformats.org/officeDocument/2006/relationships" xmlns:p="http://schemas.openxmlformats.org/presentationml/2006/main">
+  <p:cSld>
+    <p:spTree>
+      <p:nvGrpSpPr>
+        <p:cNvPr id="1" name=""/>
+        <p:cNvGrpSpPr/>
+        <p:nvPr/>
+      </p:nvGrpSpPr>
+      <p:grpSpPr>
+        <a:xfrm>
+          <a:off x="0" y="0"/>
+          <a:ext cx="0" cy="0"/>
+          <a:chOff x="0" y="0"/>
+          <a:chExt cx="0" cy="0"/>
+        </a:xfrm>
+      </p:grpSpPr>
+      <p:sp>
+        <p:nvSpPr>
+          <p:cNvPr id="2" name="Titel 1">
+            <a:extLst>
+              <a:ext uri="{FF2B5EF4-FFF2-40B4-BE49-F238E27FC236}">
                 <a16:creationId xmlns:a16="http://schemas.microsoft.com/office/drawing/2014/main" id="{6ACDFDA2-DBC4-31F5-4D86-13F3D8C2D1E4}"/>
               </a:ext>
             </a:extLst>
@@ -8932,7 +9891,7 @@
 </p:sld>
 </file>
 
-<file path=ppt/slides/slide8.xml><?xml version="1.0" encoding="utf-8"?>
+<file path=ppt/slides/slide9.xml><?xml version="1.0" encoding="utf-8"?>
 <p:sld xmlns:a="http://schemas.openxmlformats.org/drawingml/2006/main" xmlns:r="http://schemas.openxmlformats.org/officeDocument/2006/relationships" xmlns:p="http://schemas.openxmlformats.org/presentationml/2006/main">
   <p:cSld>
     <p:spTree>

</xml_diff>

<commit_message>
More work on the oven and presentation
</commit_message>
<xml_diff>
--- a/PizzaSolution Presentation.pptx
+++ b/PizzaSolution Presentation.pptx
@@ -5,7 +5,7 @@
     <p:sldMasterId id="2147483660" r:id="rId1"/>
   </p:sldMasterIdLst>
   <p:notesMasterIdLst>
-    <p:notesMasterId r:id="rId11"/>
+    <p:notesMasterId r:id="rId13"/>
   </p:notesMasterIdLst>
   <p:sldIdLst>
     <p:sldId id="256" r:id="rId2"/>
@@ -15,8 +15,10 @@
     <p:sldId id="258" r:id="rId6"/>
     <p:sldId id="264" r:id="rId7"/>
     <p:sldId id="259" r:id="rId8"/>
-    <p:sldId id="261" r:id="rId9"/>
-    <p:sldId id="260" r:id="rId10"/>
+    <p:sldId id="266" r:id="rId9"/>
+    <p:sldId id="261" r:id="rId10"/>
+    <p:sldId id="260" r:id="rId11"/>
+    <p:sldId id="268" r:id="rId12"/>
   </p:sldIdLst>
   <p:sldSz cx="12192000" cy="6858000"/>
   <p:notesSz cx="6858000" cy="9144000"/>
@@ -205,7 +207,7 @@
           <a:p>
             <a:fld id="{0F1AA9B0-0C32-482B-B713-D8137480A8FA}" type="datetimeFigureOut">
               <a:rPr lang="da-DK" smtClean="0"/>
-              <a:t>23-03-2026</a:t>
+              <a:t>26-03-2026</a:t>
             </a:fld>
             <a:endParaRPr lang="da-DK"/>
           </a:p>
@@ -1260,65 +1262,45 @@
           <a:bodyPr/>
           <a:lstStyle/>
           <a:p>
-            <a:pPr marL="0" marR="0" lvl="0" indent="0" algn="l" defTabSz="914400" rtl="0" eaLnBrk="1" fontAlgn="auto" latinLnBrk="0" hangingPunct="1">
-              <a:lnSpc>
-                <a:spcPct val="100000"/>
-              </a:lnSpc>
-              <a:spcBef>
-                <a:spcPts val="0"/>
-              </a:spcBef>
-              <a:spcAft>
-                <a:spcPts val="0"/>
-              </a:spcAft>
-              <a:buClrTx/>
-              <a:buSzTx/>
-              <a:buFontTx/>
-              <a:buNone/>
-              <a:tabLst/>
-              <a:defRPr/>
-            </a:pPr>
-            <a:r>
-              <a:rPr lang="en-US" dirty="0"/>
-              <a:t>Using the helper functions was worse for </a:t>
-            </a:r>
-            <a:r>
-              <a:rPr lang="en-US" dirty="0" err="1"/>
-              <a:t>GetSufficientStock</a:t>
-            </a:r>
-            <a:r>
-              <a:rPr lang="en-US" dirty="0"/>
-              <a:t> and my helper function </a:t>
-            </a:r>
-            <a:r>
-              <a:rPr lang="en-US" dirty="0" err="1"/>
-              <a:t>GetRecipeTypeAmountsInOrder</a:t>
-            </a:r>
-            <a:r>
-              <a:rPr lang="en-US" dirty="0"/>
-              <a:t>:</a:t>
-            </a:r>
-          </a:p>
-          <a:p>
-            <a:pPr marL="171450" marR="0" lvl="0" indent="-171450" algn="l" defTabSz="914400" rtl="0" eaLnBrk="1" fontAlgn="auto" latinLnBrk="0" hangingPunct="1">
-              <a:lnSpc>
-                <a:spcPct val="100000"/>
-              </a:lnSpc>
-              <a:spcBef>
-                <a:spcPts val="0"/>
-              </a:spcBef>
-              <a:spcAft>
-                <a:spcPts val="0"/>
-              </a:spcAft>
-              <a:buClrTx/>
-              <a:buSzTx/>
-              <a:buFontTx/>
-              <a:buChar char="-"/>
-              <a:tabLst/>
-              <a:defRPr/>
-            </a:pPr>
+            <a:r>
+              <a:rPr lang="da-DK" dirty="0"/>
+              <a:t>Had </a:t>
+            </a:r>
             <a:r>
               <a:rPr lang="da-DK" dirty="0" err="1"/>
-              <a:t>When</a:t>
+              <a:t>reached</a:t>
+            </a:r>
+            <a:r>
+              <a:rPr lang="da-DK" dirty="0"/>
+              <a:t> part 4 of the </a:t>
+            </a:r>
+            <a:r>
+              <a:rPr lang="da-DK" dirty="0" err="1"/>
+              <a:t>assignment</a:t>
+            </a:r>
+            <a:r>
+              <a:rPr lang="da-DK" dirty="0"/>
+              <a:t>, i.e. the </a:t>
+            </a:r>
+            <a:r>
+              <a:rPr lang="da-DK" dirty="0" err="1"/>
+              <a:t>ovens</a:t>
+            </a:r>
+            <a:r>
+              <a:rPr lang="da-DK" dirty="0"/>
+              <a:t>, </a:t>
+            </a:r>
+            <a:r>
+              <a:rPr lang="da-DK" dirty="0" err="1"/>
+              <a:t>when</a:t>
+            </a:r>
+            <a:r>
+              <a:rPr lang="da-DK" dirty="0"/>
+              <a:t> I had </a:t>
+            </a:r>
+            <a:r>
+              <a:rPr lang="da-DK" dirty="0" err="1"/>
+              <a:t>my</a:t>
             </a:r>
             <a:r>
               <a:rPr lang="da-DK" dirty="0"/>
@@ -1326,416 +1308,17 @@
             </a:r>
             <a:r>
               <a:rPr lang="da-DK" dirty="0" err="1"/>
-              <a:t>trying</a:t>
+              <a:t>conversation</a:t>
             </a:r>
             <a:r>
               <a:rPr lang="da-DK" dirty="0"/>
-              <a:t> to give </a:t>
-            </a:r>
-            <a:r>
-              <a:rPr lang="en-US" dirty="0" err="1"/>
-              <a:t>GetRecipeTypeAmountsInOrder</a:t>
-            </a:r>
-            <a:r>
-              <a:rPr lang="en-US" dirty="0"/>
-              <a:t> the </a:t>
-            </a:r>
-            <a:r>
-              <a:rPr lang="en-US" sz="1200" kern="1200" dirty="0" err="1">
-                <a:solidFill>
-                  <a:schemeClr val="tx1"/>
-                </a:solidFill>
-                <a:effectLst/>
-                <a:latin typeface="+mn-lt"/>
-                <a:ea typeface="+mn-ea"/>
-                <a:cs typeface="+mn-cs"/>
-              </a:rPr>
-              <a:t>GatherSameTypeOfStock</a:t>
-            </a:r>
-            <a:r>
-              <a:rPr lang="en-US" sz="1200" kern="1200" dirty="0">
-                <a:solidFill>
-                  <a:schemeClr val="tx1"/>
-                </a:solidFill>
-                <a:effectLst/>
-                <a:latin typeface="+mn-lt"/>
-                <a:ea typeface="+mn-ea"/>
-                <a:cs typeface="+mn-cs"/>
-              </a:rPr>
-              <a:t>-method from </a:t>
+              <a:t> with </a:t>
             </a:r>
             <a:r>
               <a:rPr lang="da-DK" dirty="0" err="1"/>
-              <a:t>PizzaHelperExtensions</a:t>
-            </a:r>
-            <a:r>
-              <a:rPr lang="da-DK" dirty="0"/>
-              <a:t>, I </a:t>
-            </a:r>
-            <a:r>
-              <a:rPr lang="da-DK" dirty="0" err="1"/>
-              <a:t>ended</a:t>
-            </a:r>
-            <a:r>
-              <a:rPr lang="da-DK" dirty="0"/>
-              <a:t> up with a </a:t>
-            </a:r>
-            <a:r>
-              <a:rPr lang="da-DK" dirty="0" err="1"/>
-              <a:t>triple-nested</a:t>
-            </a:r>
-            <a:r>
-              <a:rPr lang="da-DK" dirty="0"/>
-              <a:t> </a:t>
-            </a:r>
-            <a:r>
-              <a:rPr lang="da-DK" dirty="0" err="1"/>
-              <a:t>foreach</a:t>
-            </a:r>
-            <a:r>
-              <a:rPr lang="da-DK" dirty="0"/>
-              <a:t> loop </a:t>
-            </a:r>
-            <a:r>
-              <a:rPr lang="da-DK" dirty="0" err="1"/>
-              <a:t>that</a:t>
-            </a:r>
-            <a:r>
-              <a:rPr lang="da-DK" dirty="0"/>
-              <a:t> I had to </a:t>
-            </a:r>
-            <a:r>
-              <a:rPr lang="da-DK" dirty="0" err="1"/>
-              <a:t>turn</a:t>
-            </a:r>
-            <a:r>
-              <a:rPr lang="da-DK" dirty="0"/>
-              <a:t> </a:t>
-            </a:r>
-            <a:r>
-              <a:rPr lang="da-DK" dirty="0" err="1"/>
-              <a:t>into</a:t>
-            </a:r>
-            <a:r>
-              <a:rPr lang="da-DK" dirty="0"/>
-              <a:t> a LINQ. </a:t>
-            </a:r>
-            <a:r>
-              <a:rPr lang="da-DK" dirty="0" err="1"/>
-              <a:t>Which</a:t>
-            </a:r>
-            <a:r>
-              <a:rPr lang="da-DK" dirty="0"/>
-              <a:t> </a:t>
-            </a:r>
-            <a:r>
-              <a:rPr lang="da-DK" dirty="0" err="1"/>
-              <a:t>was</a:t>
-            </a:r>
-            <a:r>
-              <a:rPr lang="da-DK" dirty="0"/>
-              <a:t> </a:t>
-            </a:r>
-            <a:r>
-              <a:rPr lang="da-DK" dirty="0" err="1"/>
-              <a:t>way</a:t>
-            </a:r>
-            <a:r>
-              <a:rPr lang="da-DK" dirty="0"/>
-              <a:t> </a:t>
-            </a:r>
-            <a:r>
-              <a:rPr lang="da-DK" dirty="0" err="1"/>
-              <a:t>less</a:t>
-            </a:r>
-            <a:r>
-              <a:rPr lang="da-DK" dirty="0"/>
-              <a:t> </a:t>
-            </a:r>
-            <a:r>
-              <a:rPr lang="da-DK" dirty="0" err="1"/>
-              <a:t>effective</a:t>
-            </a:r>
-            <a:r>
-              <a:rPr lang="da-DK" dirty="0"/>
-              <a:t> </a:t>
-            </a:r>
-            <a:r>
-              <a:rPr lang="da-DK" dirty="0" err="1"/>
-              <a:t>than</a:t>
-            </a:r>
-            <a:r>
-              <a:rPr lang="da-DK" dirty="0"/>
-              <a:t> the </a:t>
-            </a:r>
-            <a:r>
-              <a:rPr lang="da-DK" dirty="0" err="1"/>
-              <a:t>dictionary</a:t>
-            </a:r>
-            <a:r>
-              <a:rPr lang="da-DK" dirty="0"/>
-              <a:t> I had </a:t>
-            </a:r>
-            <a:r>
-              <a:rPr lang="da-DK" dirty="0" err="1"/>
-              <a:t>already</a:t>
-            </a:r>
-            <a:r>
-              <a:rPr lang="da-DK" dirty="0"/>
-              <a:t> made. And </a:t>
-            </a:r>
-            <a:r>
-              <a:rPr lang="da-DK" dirty="0" err="1"/>
-              <a:t>adding</a:t>
-            </a:r>
-            <a:r>
-              <a:rPr lang="da-DK" dirty="0"/>
-              <a:t> </a:t>
-            </a:r>
-            <a:r>
-              <a:rPr lang="da-DK" dirty="0" err="1"/>
-              <a:t>things</a:t>
-            </a:r>
-            <a:r>
-              <a:rPr lang="da-DK" dirty="0"/>
-              <a:t> to a </a:t>
-            </a:r>
-            <a:r>
-              <a:rPr lang="da-DK" dirty="0" err="1"/>
-              <a:t>dictionary</a:t>
-            </a:r>
-            <a:r>
-              <a:rPr lang="da-DK" dirty="0"/>
-              <a:t> with a LINQ </a:t>
-            </a:r>
-            <a:r>
-              <a:rPr lang="da-DK" dirty="0" err="1"/>
-              <a:t>was</a:t>
-            </a:r>
-            <a:r>
-              <a:rPr lang="da-DK" dirty="0"/>
-              <a:t> </a:t>
-            </a:r>
-            <a:r>
-              <a:rPr lang="da-DK" dirty="0" err="1"/>
-              <a:t>apparently</a:t>
-            </a:r>
-            <a:r>
-              <a:rPr lang="da-DK" dirty="0"/>
-              <a:t> </a:t>
-            </a:r>
-            <a:r>
-              <a:rPr lang="da-DK" dirty="0" err="1"/>
-              <a:t>slower</a:t>
-            </a:r>
-            <a:r>
-              <a:rPr lang="da-DK" dirty="0"/>
-              <a:t> </a:t>
-            </a:r>
-            <a:r>
-              <a:rPr lang="da-DK" dirty="0" err="1"/>
-              <a:t>than</a:t>
-            </a:r>
-            <a:r>
-              <a:rPr lang="da-DK" dirty="0"/>
-              <a:t> just </a:t>
-            </a:r>
-            <a:r>
-              <a:rPr lang="da-DK" dirty="0" err="1"/>
-              <a:t>doing</a:t>
-            </a:r>
-            <a:r>
-              <a:rPr lang="da-DK" dirty="0"/>
-              <a:t> it </a:t>
-            </a:r>
-            <a:r>
-              <a:rPr lang="da-DK" dirty="0" err="1"/>
-              <a:t>normally</a:t>
-            </a:r>
-            <a:r>
-              <a:rPr lang="da-DK" dirty="0"/>
-              <a:t>.</a:t>
-            </a:r>
-          </a:p>
-          <a:p>
-            <a:pPr marL="171450" marR="0" lvl="0" indent="-171450" algn="l" defTabSz="914400" rtl="0" eaLnBrk="1" fontAlgn="auto" latinLnBrk="0" hangingPunct="1">
-              <a:lnSpc>
-                <a:spcPct val="100000"/>
-              </a:lnSpc>
-              <a:spcBef>
-                <a:spcPts val="0"/>
-              </a:spcBef>
-              <a:spcAft>
-                <a:spcPts val="0"/>
-              </a:spcAft>
-              <a:buClrTx/>
-              <a:buSzTx/>
-              <a:buFontTx/>
-              <a:buChar char="-"/>
-              <a:tabLst/>
-              <a:defRPr/>
-            </a:pPr>
-            <a:r>
-              <a:rPr lang="da-DK" dirty="0"/>
-              <a:t>My normal </a:t>
-            </a:r>
-            <a:r>
-              <a:rPr lang="da-DK" dirty="0" err="1"/>
-              <a:t>foreaches</a:t>
-            </a:r>
-            <a:r>
-              <a:rPr lang="da-DK" dirty="0"/>
-              <a:t> </a:t>
-            </a:r>
-            <a:r>
-              <a:rPr lang="da-DK" dirty="0" err="1"/>
-              <a:t>were</a:t>
-            </a:r>
-            <a:r>
-              <a:rPr lang="da-DK" dirty="0"/>
-              <a:t> </a:t>
-            </a:r>
-            <a:r>
-              <a:rPr lang="da-DK" dirty="0" err="1"/>
-              <a:t>better</a:t>
-            </a:r>
-            <a:r>
-              <a:rPr lang="da-DK" dirty="0"/>
-              <a:t> </a:t>
-            </a:r>
-            <a:r>
-              <a:rPr lang="da-DK" dirty="0" err="1"/>
-              <a:t>than</a:t>
-            </a:r>
-            <a:r>
-              <a:rPr lang="da-DK" dirty="0"/>
-              <a:t> the alternative </a:t>
-            </a:r>
-            <a:r>
-              <a:rPr lang="da-DK" dirty="0" err="1"/>
-              <a:t>because</a:t>
-            </a:r>
-            <a:r>
-              <a:rPr lang="da-DK" dirty="0"/>
-              <a:t> in </a:t>
-            </a:r>
-            <a:r>
-              <a:rPr lang="da-DK" dirty="0" err="1"/>
-              <a:t>order</a:t>
-            </a:r>
-            <a:r>
-              <a:rPr lang="da-DK" dirty="0"/>
-              <a:t> to </a:t>
-            </a:r>
-            <a:r>
-              <a:rPr lang="da-DK" dirty="0" err="1"/>
-              <a:t>convert</a:t>
-            </a:r>
-            <a:r>
-              <a:rPr lang="da-DK" dirty="0"/>
-              <a:t> </a:t>
-            </a:r>
-            <a:r>
-              <a:rPr lang="da-DK" dirty="0" err="1"/>
-              <a:t>into</a:t>
-            </a:r>
-            <a:r>
-              <a:rPr lang="da-DK" dirty="0"/>
-              <a:t> the format the </a:t>
-            </a:r>
-            <a:r>
-              <a:rPr lang="da-DK" dirty="0" err="1"/>
-              <a:t>helper</a:t>
-            </a:r>
-            <a:r>
-              <a:rPr lang="da-DK" dirty="0"/>
-              <a:t> </a:t>
-            </a:r>
-            <a:r>
-              <a:rPr lang="da-DK" dirty="0" err="1"/>
-              <a:t>functions</a:t>
-            </a:r>
-            <a:r>
-              <a:rPr lang="da-DK" dirty="0"/>
-              <a:t> </a:t>
-            </a:r>
-            <a:r>
-              <a:rPr lang="da-DK" dirty="0" err="1"/>
-              <a:t>wanted</a:t>
-            </a:r>
-            <a:r>
-              <a:rPr lang="da-DK" dirty="0"/>
-              <a:t>, </a:t>
-            </a:r>
-            <a:r>
-              <a:rPr lang="da-DK" dirty="0" err="1"/>
-              <a:t>foreaches</a:t>
-            </a:r>
-            <a:r>
-              <a:rPr lang="da-DK" dirty="0"/>
-              <a:t> </a:t>
-            </a:r>
-            <a:r>
-              <a:rPr lang="da-DK" dirty="0" err="1"/>
-              <a:t>were</a:t>
-            </a:r>
-            <a:r>
-              <a:rPr lang="da-DK" dirty="0"/>
-              <a:t> </a:t>
-            </a:r>
-            <a:r>
-              <a:rPr lang="da-DK" dirty="0" err="1"/>
-              <a:t>needed</a:t>
-            </a:r>
-            <a:endParaRPr lang="en-US" dirty="0"/>
-          </a:p>
-          <a:p>
-            <a:pPr marL="0" marR="0" lvl="0" indent="0" algn="l" defTabSz="914400" rtl="0" eaLnBrk="1" fontAlgn="auto" latinLnBrk="0" hangingPunct="1">
-              <a:lnSpc>
-                <a:spcPct val="100000"/>
-              </a:lnSpc>
-              <a:spcBef>
-                <a:spcPts val="0"/>
-              </a:spcBef>
-              <a:spcAft>
-                <a:spcPts val="0"/>
-              </a:spcAft>
-              <a:buClrTx/>
-              <a:buSzTx/>
-              <a:buFontTx/>
-              <a:buNone/>
-              <a:tabLst/>
-              <a:defRPr/>
-            </a:pPr>
-            <a:endParaRPr lang="en-US" dirty="0"/>
-          </a:p>
-          <a:p>
-            <a:pPr marL="0" marR="0" lvl="0" indent="0" algn="l" defTabSz="914400" rtl="0" eaLnBrk="1" fontAlgn="auto" latinLnBrk="0" hangingPunct="1">
-              <a:lnSpc>
-                <a:spcPct val="100000"/>
-              </a:lnSpc>
-              <a:spcBef>
-                <a:spcPts val="0"/>
-              </a:spcBef>
-              <a:spcAft>
-                <a:spcPts val="0"/>
-              </a:spcAft>
-              <a:buClrTx/>
-              <a:buSzTx/>
-              <a:buFontTx/>
-              <a:buNone/>
-              <a:tabLst/>
-              <a:defRPr/>
-            </a:pPr>
-            <a:r>
-              <a:rPr lang="en-US" dirty="0"/>
-              <a:t>Really cut down </a:t>
-            </a:r>
-            <a:r>
-              <a:rPr lang="en-US" dirty="0" err="1"/>
-              <a:t>GetStock</a:t>
-            </a:r>
-            <a:endParaRPr lang="en-US" dirty="0"/>
+              <a:t>him</a:t>
+            </a:r>
+            <a:endParaRPr lang="da-DK" dirty="0"/>
           </a:p>
         </p:txBody>
       </p:sp>
@@ -1756,7 +1339,7 @@
           <a:p>
             <a:fld id="{C2B1EF5D-2231-4646-8EED-1BCCADFE16C5}" type="slidenum">
               <a:rPr lang="da-DK" smtClean="0"/>
-              <a:t>6</a:t>
+              <a:t>5</a:t>
             </a:fld>
             <a:endParaRPr lang="da-DK"/>
           </a:p>
@@ -1765,7 +1348,7 @@
     </p:spTree>
     <p:extLst>
       <p:ext uri="{BB962C8B-B14F-4D97-AF65-F5344CB8AC3E}">
-        <p14:creationId xmlns:p14="http://schemas.microsoft.com/office/powerpoint/2010/main" val="16619558"/>
+        <p14:creationId xmlns:p14="http://schemas.microsoft.com/office/powerpoint/2010/main" val="329431416"/>
       </p:ext>
     </p:extLst>
   </p:cSld>
@@ -1819,7 +1402,525 @@
           <a:bodyPr/>
           <a:lstStyle/>
           <a:p>
-            <a:endParaRPr lang="da-DK" dirty="0"/>
+            <a:pPr marL="0" marR="0" lvl="0" indent="0" algn="l" defTabSz="914400" rtl="0" eaLnBrk="1" fontAlgn="auto" latinLnBrk="0" hangingPunct="1">
+              <a:lnSpc>
+                <a:spcPct val="100000"/>
+              </a:lnSpc>
+              <a:spcBef>
+                <a:spcPts val="0"/>
+              </a:spcBef>
+              <a:spcAft>
+                <a:spcPts val="0"/>
+              </a:spcAft>
+              <a:buClrTx/>
+              <a:buSzTx/>
+              <a:buFontTx/>
+              <a:buNone/>
+              <a:tabLst/>
+              <a:defRPr/>
+            </a:pPr>
+            <a:r>
+              <a:rPr lang="en-US" dirty="0"/>
+              <a:t>Using the helper functions was worse for </a:t>
+            </a:r>
+            <a:r>
+              <a:rPr lang="en-US" dirty="0" err="1"/>
+              <a:t>GetSufficientStock</a:t>
+            </a:r>
+            <a:r>
+              <a:rPr lang="en-US" dirty="0"/>
+              <a:t> and my helper function </a:t>
+            </a:r>
+            <a:r>
+              <a:rPr lang="en-US" dirty="0" err="1"/>
+              <a:t>GetRecipeTypeAmountsInOrder</a:t>
+            </a:r>
+            <a:r>
+              <a:rPr lang="en-US" dirty="0"/>
+              <a:t>:</a:t>
+            </a:r>
+          </a:p>
+          <a:p>
+            <a:pPr marL="171450" marR="0" lvl="0" indent="-171450" algn="l" defTabSz="914400" rtl="0" eaLnBrk="1" fontAlgn="auto" latinLnBrk="0" hangingPunct="1">
+              <a:lnSpc>
+                <a:spcPct val="100000"/>
+              </a:lnSpc>
+              <a:spcBef>
+                <a:spcPts val="0"/>
+              </a:spcBef>
+              <a:spcAft>
+                <a:spcPts val="0"/>
+              </a:spcAft>
+              <a:buClrTx/>
+              <a:buSzTx/>
+              <a:buFontTx/>
+              <a:buChar char="-"/>
+              <a:tabLst/>
+              <a:defRPr/>
+            </a:pPr>
+            <a:r>
+              <a:rPr lang="da-DK" dirty="0" err="1"/>
+              <a:t>When</a:t>
+            </a:r>
+            <a:r>
+              <a:rPr lang="da-DK" dirty="0"/>
+              <a:t> </a:t>
+            </a:r>
+            <a:r>
+              <a:rPr lang="da-DK" dirty="0" err="1"/>
+              <a:t>trying</a:t>
+            </a:r>
+            <a:r>
+              <a:rPr lang="da-DK" dirty="0"/>
+              <a:t> to give </a:t>
+            </a:r>
+            <a:r>
+              <a:rPr lang="en-US" dirty="0" err="1"/>
+              <a:t>GetRecipeTypeAmountsInOrder</a:t>
+            </a:r>
+            <a:r>
+              <a:rPr lang="en-US" dirty="0"/>
+              <a:t> the </a:t>
+            </a:r>
+            <a:r>
+              <a:rPr lang="en-US" sz="1200" kern="1200" dirty="0" err="1">
+                <a:solidFill>
+                  <a:schemeClr val="tx1"/>
+                </a:solidFill>
+                <a:effectLst/>
+                <a:latin typeface="+mn-lt"/>
+                <a:ea typeface="+mn-ea"/>
+                <a:cs typeface="+mn-cs"/>
+              </a:rPr>
+              <a:t>GatherSameTypeOfStock</a:t>
+            </a:r>
+            <a:r>
+              <a:rPr lang="en-US" sz="1200" kern="1200" dirty="0">
+                <a:solidFill>
+                  <a:schemeClr val="tx1"/>
+                </a:solidFill>
+                <a:effectLst/>
+                <a:latin typeface="+mn-lt"/>
+                <a:ea typeface="+mn-ea"/>
+                <a:cs typeface="+mn-cs"/>
+              </a:rPr>
+              <a:t>-method from </a:t>
+            </a:r>
+            <a:r>
+              <a:rPr lang="da-DK" dirty="0" err="1"/>
+              <a:t>PizzaHelperExtensions</a:t>
+            </a:r>
+            <a:r>
+              <a:rPr lang="da-DK" dirty="0"/>
+              <a:t>, I </a:t>
+            </a:r>
+            <a:r>
+              <a:rPr lang="da-DK" dirty="0" err="1"/>
+              <a:t>ended</a:t>
+            </a:r>
+            <a:r>
+              <a:rPr lang="da-DK" dirty="0"/>
+              <a:t> up with a </a:t>
+            </a:r>
+            <a:r>
+              <a:rPr lang="da-DK" dirty="0" err="1"/>
+              <a:t>triple-nested</a:t>
+            </a:r>
+            <a:r>
+              <a:rPr lang="da-DK" dirty="0"/>
+              <a:t> </a:t>
+            </a:r>
+            <a:r>
+              <a:rPr lang="da-DK" dirty="0" err="1"/>
+              <a:t>foreach</a:t>
+            </a:r>
+            <a:r>
+              <a:rPr lang="da-DK" dirty="0"/>
+              <a:t> loop </a:t>
+            </a:r>
+            <a:r>
+              <a:rPr lang="da-DK" dirty="0" err="1"/>
+              <a:t>that</a:t>
+            </a:r>
+            <a:r>
+              <a:rPr lang="da-DK" dirty="0"/>
+              <a:t> I had to </a:t>
+            </a:r>
+            <a:r>
+              <a:rPr lang="da-DK" dirty="0" err="1"/>
+              <a:t>turn</a:t>
+            </a:r>
+            <a:r>
+              <a:rPr lang="da-DK" dirty="0"/>
+              <a:t> </a:t>
+            </a:r>
+            <a:r>
+              <a:rPr lang="da-DK" dirty="0" err="1"/>
+              <a:t>into</a:t>
+            </a:r>
+            <a:r>
+              <a:rPr lang="da-DK" dirty="0"/>
+              <a:t> a LINQ. </a:t>
+            </a:r>
+            <a:r>
+              <a:rPr lang="da-DK" dirty="0" err="1"/>
+              <a:t>Which</a:t>
+            </a:r>
+            <a:r>
+              <a:rPr lang="da-DK" dirty="0"/>
+              <a:t> </a:t>
+            </a:r>
+            <a:r>
+              <a:rPr lang="da-DK" dirty="0" err="1"/>
+              <a:t>was</a:t>
+            </a:r>
+            <a:r>
+              <a:rPr lang="da-DK" dirty="0"/>
+              <a:t> </a:t>
+            </a:r>
+            <a:r>
+              <a:rPr lang="da-DK" dirty="0" err="1"/>
+              <a:t>way</a:t>
+            </a:r>
+            <a:r>
+              <a:rPr lang="da-DK" dirty="0"/>
+              <a:t> </a:t>
+            </a:r>
+            <a:r>
+              <a:rPr lang="da-DK" dirty="0" err="1"/>
+              <a:t>less</a:t>
+            </a:r>
+            <a:r>
+              <a:rPr lang="da-DK" dirty="0"/>
+              <a:t> </a:t>
+            </a:r>
+            <a:r>
+              <a:rPr lang="da-DK" dirty="0" err="1"/>
+              <a:t>effective</a:t>
+            </a:r>
+            <a:r>
+              <a:rPr lang="da-DK" dirty="0"/>
+              <a:t> </a:t>
+            </a:r>
+            <a:r>
+              <a:rPr lang="da-DK" dirty="0" err="1"/>
+              <a:t>than</a:t>
+            </a:r>
+            <a:r>
+              <a:rPr lang="da-DK" dirty="0"/>
+              <a:t> the </a:t>
+            </a:r>
+            <a:r>
+              <a:rPr lang="da-DK" dirty="0" err="1"/>
+              <a:t>dictionary</a:t>
+            </a:r>
+            <a:r>
+              <a:rPr lang="da-DK" dirty="0"/>
+              <a:t> I had </a:t>
+            </a:r>
+            <a:r>
+              <a:rPr lang="da-DK" dirty="0" err="1"/>
+              <a:t>already</a:t>
+            </a:r>
+            <a:r>
+              <a:rPr lang="da-DK" dirty="0"/>
+              <a:t> made. And </a:t>
+            </a:r>
+            <a:r>
+              <a:rPr lang="da-DK" dirty="0" err="1"/>
+              <a:t>adding</a:t>
+            </a:r>
+            <a:r>
+              <a:rPr lang="da-DK" dirty="0"/>
+              <a:t> </a:t>
+            </a:r>
+            <a:r>
+              <a:rPr lang="da-DK" dirty="0" err="1"/>
+              <a:t>things</a:t>
+            </a:r>
+            <a:r>
+              <a:rPr lang="da-DK" dirty="0"/>
+              <a:t> to a </a:t>
+            </a:r>
+            <a:r>
+              <a:rPr lang="da-DK" dirty="0" err="1"/>
+              <a:t>dictionary</a:t>
+            </a:r>
+            <a:r>
+              <a:rPr lang="da-DK" dirty="0"/>
+              <a:t> with a LINQ </a:t>
+            </a:r>
+            <a:r>
+              <a:rPr lang="da-DK" dirty="0" err="1"/>
+              <a:t>was</a:t>
+            </a:r>
+            <a:r>
+              <a:rPr lang="da-DK" dirty="0"/>
+              <a:t> </a:t>
+            </a:r>
+            <a:r>
+              <a:rPr lang="da-DK" dirty="0" err="1"/>
+              <a:t>apparently</a:t>
+            </a:r>
+            <a:r>
+              <a:rPr lang="da-DK" dirty="0"/>
+              <a:t> </a:t>
+            </a:r>
+            <a:r>
+              <a:rPr lang="da-DK" dirty="0" err="1"/>
+              <a:t>slower</a:t>
+            </a:r>
+            <a:r>
+              <a:rPr lang="da-DK" dirty="0"/>
+              <a:t> </a:t>
+            </a:r>
+            <a:r>
+              <a:rPr lang="da-DK" dirty="0" err="1"/>
+              <a:t>than</a:t>
+            </a:r>
+            <a:r>
+              <a:rPr lang="da-DK" dirty="0"/>
+              <a:t> just </a:t>
+            </a:r>
+            <a:r>
+              <a:rPr lang="da-DK" dirty="0" err="1"/>
+              <a:t>doing</a:t>
+            </a:r>
+            <a:r>
+              <a:rPr lang="da-DK" dirty="0"/>
+              <a:t> it </a:t>
+            </a:r>
+            <a:r>
+              <a:rPr lang="da-DK" dirty="0" err="1"/>
+              <a:t>normally</a:t>
+            </a:r>
+            <a:r>
+              <a:rPr lang="da-DK" dirty="0"/>
+              <a:t>.</a:t>
+            </a:r>
+          </a:p>
+          <a:p>
+            <a:pPr marL="171450" marR="0" lvl="0" indent="-171450" algn="l" defTabSz="914400" rtl="0" eaLnBrk="1" fontAlgn="auto" latinLnBrk="0" hangingPunct="1">
+              <a:lnSpc>
+                <a:spcPct val="100000"/>
+              </a:lnSpc>
+              <a:spcBef>
+                <a:spcPts val="0"/>
+              </a:spcBef>
+              <a:spcAft>
+                <a:spcPts val="0"/>
+              </a:spcAft>
+              <a:buClrTx/>
+              <a:buSzTx/>
+              <a:buFontTx/>
+              <a:buChar char="-"/>
+              <a:tabLst/>
+              <a:defRPr/>
+            </a:pPr>
+            <a:r>
+              <a:rPr lang="da-DK" dirty="0"/>
+              <a:t>My normal </a:t>
+            </a:r>
+            <a:r>
+              <a:rPr lang="da-DK" dirty="0" err="1"/>
+              <a:t>foreaches</a:t>
+            </a:r>
+            <a:r>
+              <a:rPr lang="da-DK" dirty="0"/>
+              <a:t> </a:t>
+            </a:r>
+            <a:r>
+              <a:rPr lang="da-DK" dirty="0" err="1"/>
+              <a:t>were</a:t>
+            </a:r>
+            <a:r>
+              <a:rPr lang="da-DK" dirty="0"/>
+              <a:t> </a:t>
+            </a:r>
+            <a:r>
+              <a:rPr lang="da-DK" dirty="0" err="1"/>
+              <a:t>better</a:t>
+            </a:r>
+            <a:r>
+              <a:rPr lang="da-DK" dirty="0"/>
+              <a:t> </a:t>
+            </a:r>
+            <a:r>
+              <a:rPr lang="da-DK" dirty="0" err="1"/>
+              <a:t>than</a:t>
+            </a:r>
+            <a:r>
+              <a:rPr lang="da-DK" dirty="0"/>
+              <a:t> the alternative </a:t>
+            </a:r>
+            <a:r>
+              <a:rPr lang="da-DK" dirty="0" err="1"/>
+              <a:t>because</a:t>
+            </a:r>
+            <a:r>
+              <a:rPr lang="da-DK" dirty="0"/>
+              <a:t> in </a:t>
+            </a:r>
+            <a:r>
+              <a:rPr lang="da-DK" dirty="0" err="1"/>
+              <a:t>order</a:t>
+            </a:r>
+            <a:r>
+              <a:rPr lang="da-DK" dirty="0"/>
+              <a:t> to </a:t>
+            </a:r>
+            <a:r>
+              <a:rPr lang="da-DK" dirty="0" err="1"/>
+              <a:t>convert</a:t>
+            </a:r>
+            <a:r>
+              <a:rPr lang="da-DK" dirty="0"/>
+              <a:t> </a:t>
+            </a:r>
+            <a:r>
+              <a:rPr lang="da-DK" dirty="0" err="1"/>
+              <a:t>into</a:t>
+            </a:r>
+            <a:r>
+              <a:rPr lang="da-DK" dirty="0"/>
+              <a:t> the format the </a:t>
+            </a:r>
+            <a:r>
+              <a:rPr lang="da-DK" dirty="0" err="1"/>
+              <a:t>helper</a:t>
+            </a:r>
+            <a:r>
+              <a:rPr lang="da-DK" dirty="0"/>
+              <a:t> </a:t>
+            </a:r>
+            <a:r>
+              <a:rPr lang="da-DK" dirty="0" err="1"/>
+              <a:t>functions</a:t>
+            </a:r>
+            <a:r>
+              <a:rPr lang="da-DK" dirty="0"/>
+              <a:t> </a:t>
+            </a:r>
+            <a:r>
+              <a:rPr lang="da-DK" dirty="0" err="1"/>
+              <a:t>wanted</a:t>
+            </a:r>
+            <a:r>
+              <a:rPr lang="da-DK" dirty="0"/>
+              <a:t>, </a:t>
+            </a:r>
+            <a:r>
+              <a:rPr lang="da-DK" dirty="0" err="1"/>
+              <a:t>foreaches</a:t>
+            </a:r>
+            <a:r>
+              <a:rPr lang="da-DK" dirty="0"/>
+              <a:t> </a:t>
+            </a:r>
+            <a:r>
+              <a:rPr lang="da-DK" dirty="0" err="1"/>
+              <a:t>were</a:t>
+            </a:r>
+            <a:r>
+              <a:rPr lang="da-DK" dirty="0"/>
+              <a:t> </a:t>
+            </a:r>
+            <a:r>
+              <a:rPr lang="da-DK" dirty="0" err="1"/>
+              <a:t>needed</a:t>
+            </a:r>
+            <a:endParaRPr lang="en-US" dirty="0"/>
+          </a:p>
+          <a:p>
+            <a:pPr marL="0" marR="0" lvl="0" indent="0" algn="l" defTabSz="914400" rtl="0" eaLnBrk="1" fontAlgn="auto" latinLnBrk="0" hangingPunct="1">
+              <a:lnSpc>
+                <a:spcPct val="100000"/>
+              </a:lnSpc>
+              <a:spcBef>
+                <a:spcPts val="0"/>
+              </a:spcBef>
+              <a:spcAft>
+                <a:spcPts val="0"/>
+              </a:spcAft>
+              <a:buClrTx/>
+              <a:buSzTx/>
+              <a:buFontTx/>
+              <a:buNone/>
+              <a:tabLst/>
+              <a:defRPr/>
+            </a:pPr>
+            <a:endParaRPr lang="en-US" dirty="0"/>
+          </a:p>
+          <a:p>
+            <a:pPr marL="0" marR="0" lvl="0" indent="0" algn="l" defTabSz="914400" rtl="0" eaLnBrk="1" fontAlgn="auto" latinLnBrk="0" hangingPunct="1">
+              <a:lnSpc>
+                <a:spcPct val="100000"/>
+              </a:lnSpc>
+              <a:spcBef>
+                <a:spcPts val="0"/>
+              </a:spcBef>
+              <a:spcAft>
+                <a:spcPts val="0"/>
+              </a:spcAft>
+              <a:buClrTx/>
+              <a:buSzTx/>
+              <a:buFontTx/>
+              <a:buNone/>
+              <a:tabLst/>
+              <a:defRPr/>
+            </a:pPr>
+            <a:r>
+              <a:rPr lang="en-US" dirty="0"/>
+              <a:t>Really cut down </a:t>
+            </a:r>
+            <a:r>
+              <a:rPr lang="en-US" dirty="0" err="1"/>
+              <a:t>GetStock</a:t>
+            </a:r>
+            <a:endParaRPr lang="en-US" dirty="0"/>
+          </a:p>
+          <a:p>
+            <a:pPr marL="0" marR="0" lvl="0" indent="0" algn="l" defTabSz="914400" rtl="0" eaLnBrk="1" fontAlgn="auto" latinLnBrk="0" hangingPunct="1">
+              <a:lnSpc>
+                <a:spcPct val="100000"/>
+              </a:lnSpc>
+              <a:spcBef>
+                <a:spcPts val="0"/>
+              </a:spcBef>
+              <a:spcAft>
+                <a:spcPts val="0"/>
+              </a:spcAft>
+              <a:buClrTx/>
+              <a:buSzTx/>
+              <a:buFontTx/>
+              <a:buNone/>
+              <a:tabLst/>
+              <a:defRPr/>
+            </a:pPr>
+            <a:endParaRPr lang="en-US" dirty="0"/>
+          </a:p>
+          <a:p>
+            <a:pPr marL="0" marR="0" lvl="0" indent="0" algn="l" defTabSz="914400" rtl="0" eaLnBrk="1" fontAlgn="auto" latinLnBrk="0" hangingPunct="1">
+              <a:lnSpc>
+                <a:spcPct val="100000"/>
+              </a:lnSpc>
+              <a:spcBef>
+                <a:spcPts val="0"/>
+              </a:spcBef>
+              <a:spcAft>
+                <a:spcPts val="0"/>
+              </a:spcAft>
+              <a:buClrTx/>
+              <a:buSzTx/>
+              <a:buFontTx/>
+              <a:buNone/>
+              <a:tabLst/>
+              <a:defRPr/>
+            </a:pPr>
+            <a:r>
+              <a:rPr lang="en-US" dirty="0"/>
+              <a:t>Didn’t do much LINQ outside this, because…</a:t>
+            </a:r>
           </a:p>
         </p:txBody>
       </p:sp>
@@ -1840,7 +1941,7 @@
           <a:p>
             <a:fld id="{C2B1EF5D-2231-4646-8EED-1BCCADFE16C5}" type="slidenum">
               <a:rPr lang="da-DK" smtClean="0"/>
-              <a:t>7</a:t>
+              <a:t>6</a:t>
             </a:fld>
             <a:endParaRPr lang="da-DK"/>
           </a:p>
@@ -1849,7 +1950,7 @@
     </p:spTree>
     <p:extLst>
       <p:ext uri="{BB962C8B-B14F-4D97-AF65-F5344CB8AC3E}">
-        <p14:creationId xmlns:p14="http://schemas.microsoft.com/office/powerpoint/2010/main" val="3668114257"/>
+        <p14:creationId xmlns:p14="http://schemas.microsoft.com/office/powerpoint/2010/main" val="16619558"/>
       </p:ext>
     </p:extLst>
   </p:cSld>
@@ -1924,7 +2025,151 @@
           <a:p>
             <a:fld id="{C2B1EF5D-2231-4646-8EED-1BCCADFE16C5}" type="slidenum">
               <a:rPr lang="da-DK" smtClean="0"/>
-              <a:t>8</a:t>
+              <a:t>7</a:t>
+            </a:fld>
+            <a:endParaRPr lang="da-DK"/>
+          </a:p>
+        </p:txBody>
+      </p:sp>
+    </p:spTree>
+    <p:extLst>
+      <p:ext uri="{BB962C8B-B14F-4D97-AF65-F5344CB8AC3E}">
+        <p14:creationId xmlns:p14="http://schemas.microsoft.com/office/powerpoint/2010/main" val="3668114257"/>
+      </p:ext>
+    </p:extLst>
+  </p:cSld>
+  <p:clrMapOvr>
+    <a:masterClrMapping/>
+  </p:clrMapOvr>
+</p:notes>
+</file>
+
+<file path=ppt/notesSlides/notesSlide7.xml><?xml version="1.0" encoding="utf-8"?>
+<p:notes xmlns:a="http://schemas.openxmlformats.org/drawingml/2006/main" xmlns:r="http://schemas.openxmlformats.org/officeDocument/2006/relationships" xmlns:p="http://schemas.openxmlformats.org/presentationml/2006/main">
+  <p:cSld>
+    <p:spTree>
+      <p:nvGrpSpPr>
+        <p:cNvPr id="1" name=""/>
+        <p:cNvGrpSpPr/>
+        <p:nvPr/>
+      </p:nvGrpSpPr>
+      <p:grpSpPr>
+        <a:xfrm>
+          <a:off x="0" y="0"/>
+          <a:ext cx="0" cy="0"/>
+          <a:chOff x="0" y="0"/>
+          <a:chExt cx="0" cy="0"/>
+        </a:xfrm>
+      </p:grpSpPr>
+      <p:sp>
+        <p:nvSpPr>
+          <p:cNvPr id="2" name="Pladsholder til slidebillede 1"/>
+          <p:cNvSpPr>
+            <a:spLocks noGrp="1" noRot="1" noChangeAspect="1"/>
+          </p:cNvSpPr>
+          <p:nvPr>
+            <p:ph type="sldImg"/>
+          </p:nvPr>
+        </p:nvSpPr>
+        <p:spPr/>
+      </p:sp>
+      <p:sp>
+        <p:nvSpPr>
+          <p:cNvPr id="3" name="Pladsholder til noter 2"/>
+          <p:cNvSpPr>
+            <a:spLocks noGrp="1"/>
+          </p:cNvSpPr>
+          <p:nvPr>
+            <p:ph type="body" idx="1"/>
+          </p:nvPr>
+        </p:nvSpPr>
+        <p:spPr/>
+        <p:txBody>
+          <a:bodyPr/>
+          <a:lstStyle/>
+          <a:p>
+            <a:r>
+              <a:rPr lang="da-DK" dirty="0" err="1"/>
+              <a:t>Inserting</a:t>
+            </a:r>
+            <a:r>
+              <a:rPr lang="da-DK" dirty="0"/>
+              <a:t> the Normal Pizza </a:t>
+            </a:r>
+            <a:r>
+              <a:rPr lang="da-DK" dirty="0" err="1"/>
+              <a:t>Oven’s</a:t>
+            </a:r>
+            <a:r>
+              <a:rPr lang="da-DK" dirty="0"/>
+              <a:t> </a:t>
+            </a:r>
+            <a:r>
+              <a:rPr lang="da-DK" dirty="0" err="1"/>
+              <a:t>code</a:t>
+            </a:r>
+            <a:r>
+              <a:rPr lang="da-DK" dirty="0"/>
+              <a:t> </a:t>
+            </a:r>
+            <a:r>
+              <a:rPr lang="da-DK" dirty="0" err="1"/>
+              <a:t>makes</a:t>
+            </a:r>
+            <a:r>
+              <a:rPr lang="da-DK" dirty="0"/>
+              <a:t> more tests </a:t>
+            </a:r>
+            <a:r>
+              <a:rPr lang="da-DK" dirty="0" err="1"/>
+              <a:t>pass</a:t>
+            </a:r>
+            <a:r>
+              <a:rPr lang="da-DK" dirty="0"/>
+              <a:t> </a:t>
+            </a:r>
+            <a:r>
+              <a:rPr lang="da-DK" dirty="0" err="1"/>
+              <a:t>than</a:t>
+            </a:r>
+            <a:r>
+              <a:rPr lang="da-DK" dirty="0"/>
+              <a:t> </a:t>
+            </a:r>
+            <a:r>
+              <a:rPr lang="da-DK" dirty="0" err="1"/>
+              <a:t>these</a:t>
+            </a:r>
+            <a:r>
+              <a:rPr lang="da-DK" dirty="0"/>
+              <a:t> </a:t>
+            </a:r>
+            <a:r>
+              <a:rPr lang="da-DK" dirty="0" err="1"/>
+              <a:t>two</a:t>
+            </a:r>
+            <a:endParaRPr lang="da-DK" dirty="0"/>
+          </a:p>
+        </p:txBody>
+      </p:sp>
+      <p:sp>
+        <p:nvSpPr>
+          <p:cNvPr id="4" name="Pladsholder til slidenummer 3"/>
+          <p:cNvSpPr>
+            <a:spLocks noGrp="1"/>
+          </p:cNvSpPr>
+          <p:nvPr>
+            <p:ph type="sldNum" sz="quarter" idx="5"/>
+          </p:nvPr>
+        </p:nvSpPr>
+        <p:spPr/>
+        <p:txBody>
+          <a:bodyPr/>
+          <a:lstStyle/>
+          <a:p>
+            <a:fld id="{C2B1EF5D-2231-4646-8EED-1BCCADFE16C5}" type="slidenum">
+              <a:rPr lang="da-DK" smtClean="0"/>
+              <a:t>9</a:t>
             </a:fld>
             <a:endParaRPr lang="da-DK"/>
           </a:p>
@@ -3013,6 +3258,13 @@
             <a:tailEnd/>
           </a:ln>
         </p:spPr>
+        <p:txBody>
+          <a:bodyPr/>
+          <a:lstStyle/>
+          <a:p>
+            <a:endParaRPr lang="da-DK"/>
+          </a:p>
+        </p:txBody>
       </p:sp>
       <p:sp>
         <p:nvSpPr>
@@ -3154,7 +3406,7 @@
           <a:p>
             <a:fld id="{9F2C61E5-4FB9-4B7B-BFC7-89973F7231D0}" type="datetimeFigureOut">
               <a:rPr lang="da-DK" smtClean="0"/>
-              <a:t>23-03-2026</a:t>
+              <a:t>26-03-2026</a:t>
             </a:fld>
             <a:endParaRPr lang="da-DK"/>
           </a:p>
@@ -3269,6 +3521,13 @@
             <a:schemeClr val="lt1"/>
           </a:fontRef>
         </p:style>
+        <p:txBody>
+          <a:bodyPr/>
+          <a:lstStyle/>
+          <a:p>
+            <a:endParaRPr lang="da-DK"/>
+          </a:p>
+        </p:txBody>
       </p:sp>
     </p:spTree>
     <p:extLst>
@@ -3392,7 +3651,7 @@
           <a:p>
             <a:fld id="{9F2C61E5-4FB9-4B7B-BFC7-89973F7231D0}" type="datetimeFigureOut">
               <a:rPr lang="da-DK" smtClean="0"/>
-              <a:t>23-03-2026</a:t>
+              <a:t>26-03-2026</a:t>
             </a:fld>
             <a:endParaRPr lang="da-DK"/>
           </a:p>
@@ -3572,7 +3831,7 @@
           <a:p>
             <a:fld id="{9F2C61E5-4FB9-4B7B-BFC7-89973F7231D0}" type="datetimeFigureOut">
               <a:rPr lang="da-DK" smtClean="0"/>
-              <a:t>23-03-2026</a:t>
+              <a:t>26-03-2026</a:t>
             </a:fld>
             <a:endParaRPr lang="da-DK"/>
           </a:p>
@@ -3742,7 +4001,7 @@
           <a:p>
             <a:fld id="{9F2C61E5-4FB9-4B7B-BFC7-89973F7231D0}" type="datetimeFigureOut">
               <a:rPr lang="da-DK" smtClean="0"/>
-              <a:t>23-03-2026</a:t>
+              <a:t>26-03-2026</a:t>
             </a:fld>
             <a:endParaRPr lang="da-DK"/>
           </a:p>
@@ -4018,7 +4277,7 @@
           <a:p>
             <a:fld id="{9F2C61E5-4FB9-4B7B-BFC7-89973F7231D0}" type="datetimeFigureOut">
               <a:rPr lang="da-DK" smtClean="0"/>
-              <a:t>23-03-2026</a:t>
+              <a:t>26-03-2026</a:t>
             </a:fld>
             <a:endParaRPr lang="da-DK"/>
           </a:p>
@@ -5219,7 +5478,7 @@
           <a:p>
             <a:fld id="{9F2C61E5-4FB9-4B7B-BFC7-89973F7231D0}" type="datetimeFigureOut">
               <a:rPr lang="da-DK" smtClean="0"/>
-              <a:t>23-03-2026</a:t>
+              <a:t>26-03-2026</a:t>
             </a:fld>
             <a:endParaRPr lang="da-DK"/>
           </a:p>
@@ -5609,7 +5868,7 @@
           <a:p>
             <a:fld id="{9F2C61E5-4FB9-4B7B-BFC7-89973F7231D0}" type="datetimeFigureOut">
               <a:rPr lang="da-DK" smtClean="0"/>
-              <a:t>23-03-2026</a:t>
+              <a:t>26-03-2026</a:t>
             </a:fld>
             <a:endParaRPr lang="da-DK"/>
           </a:p>
@@ -5732,7 +5991,7 @@
           <a:p>
             <a:fld id="{9F2C61E5-4FB9-4B7B-BFC7-89973F7231D0}" type="datetimeFigureOut">
               <a:rPr lang="da-DK" smtClean="0"/>
-              <a:t>23-03-2026</a:t>
+              <a:t>26-03-2026</a:t>
             </a:fld>
             <a:endParaRPr lang="da-DK"/>
           </a:p>
@@ -5827,7 +6086,7 @@
           <a:p>
             <a:fld id="{9F2C61E5-4FB9-4B7B-BFC7-89973F7231D0}" type="datetimeFigureOut">
               <a:rPr lang="da-DK" smtClean="0"/>
-              <a:t>23-03-2026</a:t>
+              <a:t>26-03-2026</a:t>
             </a:fld>
             <a:endParaRPr lang="da-DK"/>
           </a:p>
@@ -6590,7 +6849,7 @@
           <a:p>
             <a:fld id="{9F2C61E5-4FB9-4B7B-BFC7-89973F7231D0}" type="datetimeFigureOut">
               <a:rPr lang="da-DK" smtClean="0"/>
-              <a:t>23-03-2026</a:t>
+              <a:t>26-03-2026</a:t>
             </a:fld>
             <a:endParaRPr lang="da-DK"/>
           </a:p>
@@ -7430,7 +7689,7 @@
           <a:p>
             <a:fld id="{9F2C61E5-4FB9-4B7B-BFC7-89973F7231D0}" type="datetimeFigureOut">
               <a:rPr lang="da-DK" smtClean="0"/>
-              <a:t>23-03-2026</a:t>
+              <a:t>26-03-2026</a:t>
             </a:fld>
             <a:endParaRPr lang="da-DK"/>
           </a:p>
@@ -7657,7 +7916,7 @@
           <a:p>
             <a:fld id="{9F2C61E5-4FB9-4B7B-BFC7-89973F7231D0}" type="datetimeFigureOut">
               <a:rPr lang="da-DK" smtClean="0"/>
-              <a:t>23-03-2026</a:t>
+              <a:t>26-03-2026</a:t>
             </a:fld>
             <a:endParaRPr lang="da-DK"/>
           </a:p>
@@ -8206,6 +8465,13 @@
             <a:tailEnd/>
           </a:ln>
         </p:spPr>
+        <p:txBody>
+          <a:bodyPr/>
+          <a:lstStyle/>
+          <a:p>
+            <a:endParaRPr lang="da-DK"/>
+          </a:p>
+        </p:txBody>
       </p:sp>
       <p:sp>
         <p:nvSpPr>
@@ -8244,6 +8510,13 @@
             <a:schemeClr val="lt1"/>
           </a:fontRef>
         </p:style>
+        <p:txBody>
+          <a:bodyPr/>
+          <a:lstStyle/>
+          <a:p>
+            <a:endParaRPr lang="da-DK"/>
+          </a:p>
+        </p:txBody>
       </p:sp>
     </p:spTree>
     <p:extLst>
@@ -8726,6 +8999,241 @@
 </p:sld>
 </file>
 
+<file path=ppt/slides/slide10.xml><?xml version="1.0" encoding="utf-8"?>
+<p:sld xmlns:a="http://schemas.openxmlformats.org/drawingml/2006/main" xmlns:r="http://schemas.openxmlformats.org/officeDocument/2006/relationships" xmlns:p="http://schemas.openxmlformats.org/presentationml/2006/main">
+  <p:cSld>
+    <p:spTree>
+      <p:nvGrpSpPr>
+        <p:cNvPr id="1" name=""/>
+        <p:cNvGrpSpPr/>
+        <p:nvPr/>
+      </p:nvGrpSpPr>
+      <p:grpSpPr>
+        <a:xfrm>
+          <a:off x="0" y="0"/>
+          <a:ext cx="0" cy="0"/>
+          <a:chOff x="0" y="0"/>
+          <a:chExt cx="0" cy="0"/>
+        </a:xfrm>
+      </p:grpSpPr>
+      <p:sp>
+        <p:nvSpPr>
+          <p:cNvPr id="2" name="Titel 1">
+            <a:extLst>
+              <a:ext uri="{FF2B5EF4-FFF2-40B4-BE49-F238E27FC236}">
+                <a16:creationId xmlns:a16="http://schemas.microsoft.com/office/drawing/2014/main" id="{B726AEE8-C798-4136-E025-F1A260436E52}"/>
+              </a:ext>
+            </a:extLst>
+          </p:cNvPr>
+          <p:cNvSpPr>
+            <a:spLocks noGrp="1"/>
+          </p:cNvSpPr>
+          <p:nvPr>
+            <p:ph type="title"/>
+          </p:nvPr>
+        </p:nvSpPr>
+        <p:spPr/>
+        <p:txBody>
+          <a:bodyPr/>
+          <a:lstStyle/>
+          <a:p>
+            <a:r>
+              <a:rPr lang="en-DK" noProof="0" dirty="0"/>
+              <a:t>Final Thoughts</a:t>
+            </a:r>
+          </a:p>
+        </p:txBody>
+      </p:sp>
+      <p:sp>
+        <p:nvSpPr>
+          <p:cNvPr id="3" name="Pladsholder til indhold 2">
+            <a:extLst>
+              <a:ext uri="{FF2B5EF4-FFF2-40B4-BE49-F238E27FC236}">
+                <a16:creationId xmlns:a16="http://schemas.microsoft.com/office/drawing/2014/main" id="{726D3CD8-F4EE-27A8-6FFC-51B30ACA61B1}"/>
+              </a:ext>
+            </a:extLst>
+          </p:cNvPr>
+          <p:cNvSpPr>
+            <a:spLocks noGrp="1"/>
+          </p:cNvSpPr>
+          <p:nvPr>
+            <p:ph sz="half" idx="1"/>
+          </p:nvPr>
+        </p:nvSpPr>
+        <p:spPr/>
+        <p:txBody>
+          <a:bodyPr/>
+          <a:lstStyle/>
+          <a:p>
+            <a:r>
+              <a:rPr lang="en-GB" noProof="0" dirty="0"/>
+              <a:t>Things were pretty good until the </a:t>
+            </a:r>
+            <a:r>
+              <a:rPr lang="en-GB" dirty="0"/>
+              <a:t>Giant Revolving Pizza Oven </a:t>
+            </a:r>
+            <a:r>
+              <a:rPr lang="en-GB" dirty="0">
+                <a:sym typeface="Wingdings" panose="05000000000000000000" pitchFamily="2" charset="2"/>
+              </a:rPr>
+              <a:t> I should’ve just skipped it</a:t>
+            </a:r>
+          </a:p>
+          <a:p>
+            <a:r>
+              <a:rPr lang="en-GB" dirty="0">
+                <a:sym typeface="Wingdings" panose="05000000000000000000" pitchFamily="2" charset="2"/>
+              </a:rPr>
+              <a:t>Could have studied LINQ some more</a:t>
+            </a:r>
+            <a:endParaRPr lang="en-GB" noProof="0" dirty="0"/>
+          </a:p>
+        </p:txBody>
+      </p:sp>
+      <p:sp>
+        <p:nvSpPr>
+          <p:cNvPr id="4" name="Pladsholder til indhold 3">
+            <a:extLst>
+              <a:ext uri="{FF2B5EF4-FFF2-40B4-BE49-F238E27FC236}">
+                <a16:creationId xmlns:a16="http://schemas.microsoft.com/office/drawing/2014/main" id="{5C2531A8-AFD4-C0F8-51BC-68177D2CD808}"/>
+              </a:ext>
+            </a:extLst>
+          </p:cNvPr>
+          <p:cNvSpPr>
+            <a:spLocks noGrp="1"/>
+          </p:cNvSpPr>
+          <p:nvPr>
+            <p:ph sz="half" idx="2"/>
+          </p:nvPr>
+        </p:nvSpPr>
+        <p:spPr/>
+        <p:txBody>
+          <a:bodyPr/>
+          <a:lstStyle/>
+          <a:p>
+            <a:r>
+              <a:rPr lang="en-GB" noProof="0" dirty="0"/>
+              <a:t>Would’ve like to get have gotten to the database and some frontend</a:t>
+            </a:r>
+          </a:p>
+        </p:txBody>
+      </p:sp>
+    </p:spTree>
+    <p:extLst>
+      <p:ext uri="{BB962C8B-B14F-4D97-AF65-F5344CB8AC3E}">
+        <p14:creationId xmlns:p14="http://schemas.microsoft.com/office/powerpoint/2010/main" val="627090686"/>
+      </p:ext>
+    </p:extLst>
+  </p:cSld>
+  <p:clrMapOvr>
+    <a:masterClrMapping/>
+  </p:clrMapOvr>
+</p:sld>
+</file>
+
+<file path=ppt/slides/slide11.xml><?xml version="1.0" encoding="utf-8"?>
+<p:sld xmlns:a="http://schemas.openxmlformats.org/drawingml/2006/main" xmlns:r="http://schemas.openxmlformats.org/officeDocument/2006/relationships" xmlns:p="http://schemas.openxmlformats.org/presentationml/2006/main">
+  <p:cSld>
+    <p:spTree>
+      <p:nvGrpSpPr>
+        <p:cNvPr id="1" name=""/>
+        <p:cNvGrpSpPr/>
+        <p:nvPr/>
+      </p:nvGrpSpPr>
+      <p:grpSpPr>
+        <a:xfrm>
+          <a:off x="0" y="0"/>
+          <a:ext cx="0" cy="0"/>
+          <a:chOff x="0" y="0"/>
+          <a:chExt cx="0" cy="0"/>
+        </a:xfrm>
+      </p:grpSpPr>
+      <p:sp>
+        <p:nvSpPr>
+          <p:cNvPr id="2" name="Titel 1">
+            <a:extLst>
+              <a:ext uri="{FF2B5EF4-FFF2-40B4-BE49-F238E27FC236}">
+                <a16:creationId xmlns:a16="http://schemas.microsoft.com/office/drawing/2014/main" id="{9B2F1985-FF08-A6D1-747C-F81E5CE98856}"/>
+              </a:ext>
+            </a:extLst>
+          </p:cNvPr>
+          <p:cNvSpPr>
+            <a:spLocks noGrp="1"/>
+          </p:cNvSpPr>
+          <p:nvPr>
+            <p:ph type="ctrTitle"/>
+          </p:nvPr>
+        </p:nvSpPr>
+        <p:spPr/>
+        <p:txBody>
+          <a:bodyPr/>
+          <a:lstStyle/>
+          <a:p>
+            <a:r>
+              <a:rPr lang="en-GB" noProof="0" dirty="0"/>
+              <a:t>Questions</a:t>
+            </a:r>
+            <a:br>
+              <a:rPr lang="da-DK" dirty="0"/>
+            </a:br>
+            <a:r>
+              <a:rPr lang="ja-JP" altLang="da-DK" dirty="0"/>
+              <a:t>質問</a:t>
+            </a:r>
+            <a:endParaRPr lang="da-DK" dirty="0"/>
+          </a:p>
+        </p:txBody>
+      </p:sp>
+      <p:sp>
+        <p:nvSpPr>
+          <p:cNvPr id="3" name="Undertitel 2">
+            <a:extLst>
+              <a:ext uri="{FF2B5EF4-FFF2-40B4-BE49-F238E27FC236}">
+                <a16:creationId xmlns:a16="http://schemas.microsoft.com/office/drawing/2014/main" id="{43F0204D-0539-7534-091A-07925CA2DEE6}"/>
+              </a:ext>
+            </a:extLst>
+          </p:cNvPr>
+          <p:cNvSpPr>
+            <a:spLocks noGrp="1"/>
+          </p:cNvSpPr>
+          <p:nvPr>
+            <p:ph type="subTitle" idx="1"/>
+          </p:nvPr>
+        </p:nvSpPr>
+        <p:spPr/>
+        <p:txBody>
+          <a:bodyPr>
+            <a:normAutofit/>
+          </a:bodyPr>
+          <a:lstStyle/>
+          <a:p>
+            <a:r>
+              <a:rPr lang="en-GB" noProof="0" dirty="0"/>
+              <a:t>Thank you for listening</a:t>
+            </a:r>
+          </a:p>
+          <a:p>
+            <a:r>
+              <a:rPr lang="en-GB" sz="600" noProof="0" dirty="0"/>
+              <a:t>(hopefully I didn’t yap too much)</a:t>
+            </a:r>
+          </a:p>
+        </p:txBody>
+      </p:sp>
+    </p:spTree>
+    <p:extLst>
+      <p:ext uri="{BB962C8B-B14F-4D97-AF65-F5344CB8AC3E}">
+        <p14:creationId xmlns:p14="http://schemas.microsoft.com/office/powerpoint/2010/main" val="2255987726"/>
+      </p:ext>
+    </p:extLst>
+  </p:cSld>
+  <p:clrMapOvr>
+    <a:masterClrMapping/>
+  </p:clrMapOvr>
+</p:sld>
+</file>
+
 <file path=ppt/slides/slide2.xml><?xml version="1.0" encoding="utf-8"?>
 <p:sld xmlns:a="http://schemas.openxmlformats.org/drawingml/2006/main" xmlns:r="http://schemas.openxmlformats.org/officeDocument/2006/relationships" xmlns:p="http://schemas.openxmlformats.org/presentationml/2006/main">
   <p:cSld>
@@ -9710,7 +10218,7 @@
           <a:p>
             <a:r>
               <a:rPr lang="en-US" noProof="0" dirty="0"/>
-              <a:t>Later problems/thoughts</a:t>
+              <a:t>Back to the oven…</a:t>
             </a:r>
             <a:endParaRPr lang="en-DK" noProof="0" dirty="0"/>
           </a:p>
@@ -9732,40 +10240,116 @@
             <p:ph sz="half" idx="1"/>
           </p:nvPr>
         </p:nvSpPr>
-        <p:spPr/>
+        <p:spPr>
+          <a:xfrm>
+            <a:off x="1257300" y="1191718"/>
+            <a:ext cx="4800600" cy="5433934"/>
+          </a:xfrm>
+        </p:spPr>
         <p:txBody>
           <a:bodyPr/>
           <a:lstStyle/>
           <a:p>
-            <a:endParaRPr lang="en-DK" noProof="0" dirty="0"/>
+            <a:r>
+              <a:rPr lang="en-GB" noProof="0" dirty="0"/>
+              <a:t>Idea:</a:t>
+            </a:r>
+          </a:p>
+          <a:p>
+            <a:pPr lvl="1"/>
+            <a:r>
+              <a:rPr lang="en-GB" dirty="0"/>
+              <a:t>Make alternate version of Michael’s</a:t>
+            </a:r>
+          </a:p>
+          <a:p>
+            <a:pPr lvl="1"/>
+            <a:r>
+              <a:rPr lang="en-GB" dirty="0"/>
+              <a:t>Make the first element have the correct cooking type, set rest to 0</a:t>
+            </a:r>
+          </a:p>
+          <a:p>
+            <a:pPr lvl="1"/>
+            <a:r>
+              <a:rPr lang="en-GB" dirty="0"/>
+              <a:t>Manipulating cooking time worked with the Assembly Line Oven, so why not this?</a:t>
+            </a:r>
+          </a:p>
+          <a:p>
+            <a:endParaRPr lang="en-GB" noProof="0" dirty="0"/>
+          </a:p>
+          <a:p>
+            <a:r>
+              <a:rPr lang="en-GB" dirty="0"/>
+              <a:t>Problem:</a:t>
+            </a:r>
+          </a:p>
+          <a:p>
+            <a:pPr lvl="1"/>
+            <a:r>
+              <a:rPr lang="en-GB" noProof="0" dirty="0"/>
+              <a:t>Only works with 100 pizzas testcase</a:t>
+            </a:r>
+          </a:p>
+          <a:p>
+            <a:pPr lvl="1"/>
+            <a:r>
+              <a:rPr lang="en-GB" dirty="0"/>
+              <a:t>Different cooking times</a:t>
+            </a:r>
+            <a:r>
+              <a:rPr lang="en-GB" noProof="0" dirty="0"/>
+              <a:t> can be in the oven at the same time</a:t>
+            </a:r>
+            <a:endParaRPr lang="en-GB" dirty="0"/>
+          </a:p>
+          <a:p>
+            <a:pPr lvl="1"/>
+            <a:r>
+              <a:rPr lang="en-GB" dirty="0"/>
+              <a:t>Feels like I definitely can get rid of that while-loop somehow</a:t>
+            </a:r>
+            <a:endParaRPr lang="en-GB" noProof="0" dirty="0"/>
+          </a:p>
+          <a:p>
+            <a:pPr lvl="1"/>
+            <a:endParaRPr lang="en-GB" noProof="0" dirty="0"/>
           </a:p>
         </p:txBody>
       </p:sp>
-      <p:sp>
-        <p:nvSpPr>
-          <p:cNvPr id="4" name="Pladsholder til indhold 3">
+      <p:pic>
+        <p:nvPicPr>
+          <p:cNvPr id="6" name="Pladsholder til indhold 5">
             <a:extLst>
               <a:ext uri="{FF2B5EF4-FFF2-40B4-BE49-F238E27FC236}">
-                <a16:creationId xmlns:a16="http://schemas.microsoft.com/office/drawing/2014/main" id="{47C8E8B0-70D6-0E5E-F1F3-83A2F00EB827}"/>
+                <a16:creationId xmlns:a16="http://schemas.microsoft.com/office/drawing/2014/main" id="{A9129C86-25D8-BB61-FDBC-050F963302B9}"/>
               </a:ext>
             </a:extLst>
           </p:cNvPr>
-          <p:cNvSpPr>
-            <a:spLocks noGrp="1"/>
-          </p:cNvSpPr>
+          <p:cNvPicPr>
+            <a:picLocks noGrp="1" noChangeAspect="1"/>
+          </p:cNvPicPr>
           <p:nvPr>
             <p:ph sz="half" idx="2"/>
           </p:nvPr>
-        </p:nvSpPr>
-        <p:spPr/>
-        <p:txBody>
-          <a:bodyPr/>
-          <a:lstStyle/>
-          <a:p>
-            <a:endParaRPr lang="da-DK"/>
-          </a:p>
-        </p:txBody>
-      </p:sp>
+        </p:nvPicPr>
+        <p:blipFill>
+          <a:blip r:embed="rId3"/>
+          <a:stretch>
+            <a:fillRect/>
+          </a:stretch>
+        </p:blipFill>
+        <p:spPr>
+          <a:xfrm>
+            <a:off x="6134102" y="1648979"/>
+            <a:ext cx="5576569" cy="4482059"/>
+          </a:xfrm>
+          <a:prstGeom prst="rect">
+            <a:avLst/>
+          </a:prstGeom>
+        </p:spPr>
+      </p:pic>
     </p:spTree>
     <p:extLst>
       <p:ext uri="{BB962C8B-B14F-4D97-AF65-F5344CB8AC3E}">
@@ -9798,10 +10382,10 @@
       </p:grpSpPr>
       <p:sp>
         <p:nvSpPr>
-          <p:cNvPr id="2" name="Titel 1">
+          <p:cNvPr id="3" name="Pladsholder til tekst 2">
             <a:extLst>
               <a:ext uri="{FF2B5EF4-FFF2-40B4-BE49-F238E27FC236}">
-                <a16:creationId xmlns:a16="http://schemas.microsoft.com/office/drawing/2014/main" id="{6ACDFDA2-DBC4-31F5-4D86-13F3D8C2D1E4}"/>
+                <a16:creationId xmlns:a16="http://schemas.microsoft.com/office/drawing/2014/main" id="{1D27ADBE-6C29-E655-6801-3357EE470D93}"/>
               </a:ext>
             </a:extLst>
           </p:cNvPr>
@@ -9809,79 +10393,1240 @@
             <a:spLocks noGrp="1"/>
           </p:cNvSpPr>
           <p:nvPr>
-            <p:ph type="title"/>
+            <p:ph type="body" idx="1"/>
           </p:nvPr>
         </p:nvSpPr>
-        <p:spPr/>
+        <p:spPr>
+          <a:xfrm rot="20344839">
+            <a:off x="1824319" y="5017375"/>
+            <a:ext cx="7017488" cy="951135"/>
+          </a:xfrm>
+        </p:spPr>
         <p:txBody>
           <a:bodyPr/>
           <a:lstStyle/>
           <a:p>
             <a:r>
               <a:rPr lang="en-US" noProof="0" dirty="0"/>
-              <a:t>More </a:t>
-            </a:r>
-            <a:r>
-              <a:rPr lang="en-DK" noProof="0" dirty="0"/>
-              <a:t>Interesting code bits</a:t>
+              <a:t>Give last element cooking time?</a:t>
             </a:r>
           </a:p>
         </p:txBody>
       </p:sp>
       <p:sp>
         <p:nvSpPr>
-          <p:cNvPr id="3" name="Pladsholder til indhold 2">
+          <p:cNvPr id="4" name="Pladsholder til tekst 2">
             <a:extLst>
               <a:ext uri="{FF2B5EF4-FFF2-40B4-BE49-F238E27FC236}">
-                <a16:creationId xmlns:a16="http://schemas.microsoft.com/office/drawing/2014/main" id="{0139D2AC-9FBF-E54A-C1EF-C5B61B08497E}"/>
+                <a16:creationId xmlns:a16="http://schemas.microsoft.com/office/drawing/2014/main" id="{FD5D8786-4C86-82DF-E2B4-DB5658D1CB2C}"/>
               </a:ext>
             </a:extLst>
           </p:cNvPr>
-          <p:cNvSpPr>
-            <a:spLocks noGrp="1"/>
+          <p:cNvSpPr txBox="1">
+            <a:spLocks/>
           </p:cNvSpPr>
-          <p:nvPr>
-            <p:ph sz="half" idx="1"/>
-          </p:nvPr>
-        </p:nvSpPr>
-        <p:spPr/>
+          <p:nvPr/>
+        </p:nvSpPr>
+        <p:spPr>
+          <a:xfrm rot="494728">
+            <a:off x="5359042" y="3492059"/>
+            <a:ext cx="8169581" cy="951135"/>
+          </a:xfrm>
+          <a:prstGeom prst="rect">
+            <a:avLst/>
+          </a:prstGeom>
+        </p:spPr>
         <p:txBody>
-          <a:bodyPr/>
-          <a:lstStyle/>
-          <a:p>
-            <a:endParaRPr lang="da-DK"/>
+          <a:bodyPr vert="horz" lIns="91440" tIns="45720" rIns="91440" bIns="45720" rtlCol="0">
+            <a:normAutofit/>
+          </a:bodyPr>
+          <a:lstStyle>
+            <a:lvl1pPr marL="0" indent="0" algn="l" defTabSz="914400" rtl="0" eaLnBrk="1" latinLnBrk="0" hangingPunct="1">
+              <a:lnSpc>
+                <a:spcPct val="100000"/>
+              </a:lnSpc>
+              <a:spcBef>
+                <a:spcPts val="700"/>
+              </a:spcBef>
+              <a:buClr>
+                <a:schemeClr val="tx2"/>
+              </a:buClr>
+              <a:buFont typeface="Arial" panose="020B0604020202020204" pitchFamily="34" charset="0"/>
+              <a:buNone/>
+              <a:defRPr sz="2000" b="1" i="0" kern="1200" cap="all" spc="400" baseline="0">
+                <a:solidFill>
+                  <a:schemeClr val="accent1"/>
+                </a:solidFill>
+                <a:latin typeface="+mn-lt"/>
+                <a:ea typeface="+mn-ea"/>
+                <a:cs typeface="+mn-cs"/>
+              </a:defRPr>
+            </a:lvl1pPr>
+            <a:lvl2pPr marL="457200" indent="0" algn="l" defTabSz="914400" rtl="0" eaLnBrk="1" latinLnBrk="0" hangingPunct="1">
+              <a:lnSpc>
+                <a:spcPct val="110000"/>
+              </a:lnSpc>
+              <a:spcBef>
+                <a:spcPts val="700"/>
+              </a:spcBef>
+              <a:buClr>
+                <a:schemeClr val="tx2"/>
+              </a:buClr>
+              <a:buFont typeface="Gill Sans MT" panose="020B0502020104020203" pitchFamily="34" charset="0"/>
+              <a:buNone/>
+              <a:defRPr sz="2000" kern="1200">
+                <a:solidFill>
+                  <a:schemeClr val="tx1">
+                    <a:tint val="75000"/>
+                  </a:schemeClr>
+                </a:solidFill>
+                <a:latin typeface="+mn-lt"/>
+                <a:ea typeface="+mn-ea"/>
+                <a:cs typeface="+mn-cs"/>
+              </a:defRPr>
+            </a:lvl2pPr>
+            <a:lvl3pPr marL="914400" indent="0" algn="l" defTabSz="914400" rtl="0" eaLnBrk="1" latinLnBrk="0" hangingPunct="1">
+              <a:lnSpc>
+                <a:spcPct val="110000"/>
+              </a:lnSpc>
+              <a:spcBef>
+                <a:spcPts val="700"/>
+              </a:spcBef>
+              <a:buClr>
+                <a:schemeClr val="tx2"/>
+              </a:buClr>
+              <a:buFont typeface="Arial" panose="020B0604020202020204" pitchFamily="34" charset="0"/>
+              <a:buNone/>
+              <a:defRPr sz="1800" kern="1200">
+                <a:solidFill>
+                  <a:schemeClr val="tx1">
+                    <a:tint val="75000"/>
+                  </a:schemeClr>
+                </a:solidFill>
+                <a:latin typeface="+mn-lt"/>
+                <a:ea typeface="+mn-ea"/>
+                <a:cs typeface="+mn-cs"/>
+              </a:defRPr>
+            </a:lvl3pPr>
+            <a:lvl4pPr marL="1371600" indent="0" algn="l" defTabSz="914400" rtl="0" eaLnBrk="1" latinLnBrk="0" hangingPunct="1">
+              <a:lnSpc>
+                <a:spcPct val="110000"/>
+              </a:lnSpc>
+              <a:spcBef>
+                <a:spcPts val="700"/>
+              </a:spcBef>
+              <a:buClr>
+                <a:schemeClr val="tx2"/>
+              </a:buClr>
+              <a:buFont typeface="Gill Sans MT" panose="020B0502020104020203" pitchFamily="34" charset="0"/>
+              <a:buNone/>
+              <a:defRPr sz="1600" kern="1200">
+                <a:solidFill>
+                  <a:schemeClr val="tx1">
+                    <a:tint val="75000"/>
+                  </a:schemeClr>
+                </a:solidFill>
+                <a:latin typeface="+mn-lt"/>
+                <a:ea typeface="+mn-ea"/>
+                <a:cs typeface="+mn-cs"/>
+              </a:defRPr>
+            </a:lvl4pPr>
+            <a:lvl5pPr marL="1828800" indent="0" algn="l" defTabSz="914400" rtl="0" eaLnBrk="1" latinLnBrk="0" hangingPunct="1">
+              <a:lnSpc>
+                <a:spcPct val="110000"/>
+              </a:lnSpc>
+              <a:spcBef>
+                <a:spcPts val="700"/>
+              </a:spcBef>
+              <a:buClr>
+                <a:schemeClr val="tx2"/>
+              </a:buClr>
+              <a:buFont typeface="Arial" panose="020B0604020202020204" pitchFamily="34" charset="0"/>
+              <a:buNone/>
+              <a:defRPr sz="1600" kern="1200">
+                <a:solidFill>
+                  <a:schemeClr val="tx1">
+                    <a:tint val="75000"/>
+                  </a:schemeClr>
+                </a:solidFill>
+                <a:latin typeface="+mn-lt"/>
+                <a:ea typeface="+mn-ea"/>
+                <a:cs typeface="+mn-cs"/>
+              </a:defRPr>
+            </a:lvl5pPr>
+            <a:lvl6pPr marL="2286000" indent="0" algn="l" defTabSz="914400" rtl="0" eaLnBrk="1" latinLnBrk="0" hangingPunct="1">
+              <a:lnSpc>
+                <a:spcPct val="110000"/>
+              </a:lnSpc>
+              <a:spcBef>
+                <a:spcPts val="700"/>
+              </a:spcBef>
+              <a:buClr>
+                <a:schemeClr val="tx2"/>
+              </a:buClr>
+              <a:buFont typeface="Gill Sans MT" panose="020B0502020104020203" pitchFamily="34" charset="0"/>
+              <a:buNone/>
+              <a:defRPr sz="1600" kern="1200">
+                <a:solidFill>
+                  <a:schemeClr val="tx1">
+                    <a:tint val="75000"/>
+                  </a:schemeClr>
+                </a:solidFill>
+                <a:latin typeface="+mn-lt"/>
+                <a:ea typeface="+mn-ea"/>
+                <a:cs typeface="+mn-cs"/>
+              </a:defRPr>
+            </a:lvl6pPr>
+            <a:lvl7pPr marL="2743200" indent="0" algn="l" defTabSz="914400" rtl="0" eaLnBrk="1" latinLnBrk="0" hangingPunct="1">
+              <a:lnSpc>
+                <a:spcPct val="110000"/>
+              </a:lnSpc>
+              <a:spcBef>
+                <a:spcPts val="700"/>
+              </a:spcBef>
+              <a:buClr>
+                <a:schemeClr val="tx2"/>
+              </a:buClr>
+              <a:buFont typeface="Arial" panose="020B0604020202020204" pitchFamily="34" charset="0"/>
+              <a:buNone/>
+              <a:defRPr sz="1600" kern="1200">
+                <a:solidFill>
+                  <a:schemeClr val="tx1">
+                    <a:tint val="75000"/>
+                  </a:schemeClr>
+                </a:solidFill>
+                <a:latin typeface="+mn-lt"/>
+                <a:ea typeface="+mn-ea"/>
+                <a:cs typeface="+mn-cs"/>
+              </a:defRPr>
+            </a:lvl7pPr>
+            <a:lvl8pPr marL="3200400" indent="0" algn="l" defTabSz="914400" rtl="0" eaLnBrk="1" latinLnBrk="0" hangingPunct="1">
+              <a:lnSpc>
+                <a:spcPct val="110000"/>
+              </a:lnSpc>
+              <a:spcBef>
+                <a:spcPts val="700"/>
+              </a:spcBef>
+              <a:buClr>
+                <a:schemeClr val="tx2"/>
+              </a:buClr>
+              <a:buFont typeface="Gill Sans MT" panose="020B0502020104020203" pitchFamily="34" charset="0"/>
+              <a:buNone/>
+              <a:defRPr sz="1600" kern="1200" baseline="0">
+                <a:solidFill>
+                  <a:schemeClr val="tx1">
+                    <a:tint val="75000"/>
+                  </a:schemeClr>
+                </a:solidFill>
+                <a:latin typeface="+mn-lt"/>
+                <a:ea typeface="+mn-ea"/>
+                <a:cs typeface="+mn-cs"/>
+              </a:defRPr>
+            </a:lvl8pPr>
+            <a:lvl9pPr marL="3657600" indent="0" algn="l" defTabSz="914400" rtl="0" eaLnBrk="1" latinLnBrk="0" hangingPunct="1">
+              <a:lnSpc>
+                <a:spcPct val="110000"/>
+              </a:lnSpc>
+              <a:spcBef>
+                <a:spcPts val="700"/>
+              </a:spcBef>
+              <a:buClr>
+                <a:schemeClr val="tx2"/>
+              </a:buClr>
+              <a:buFont typeface="Arial" panose="020B0604020202020204" pitchFamily="34" charset="0"/>
+              <a:buNone/>
+              <a:defRPr sz="1600" kern="1200" baseline="0">
+                <a:solidFill>
+                  <a:schemeClr val="tx1">
+                    <a:tint val="75000"/>
+                  </a:schemeClr>
+                </a:solidFill>
+                <a:latin typeface="+mn-lt"/>
+                <a:ea typeface="+mn-ea"/>
+                <a:cs typeface="+mn-cs"/>
+              </a:defRPr>
+            </a:lvl9pPr>
+          </a:lstStyle>
+          <a:p>
+            <a:r>
+              <a:rPr lang="en-US" noProof="0" dirty="0"/>
+              <a:t>Insert Empty pizzas with equal cooking time to fill up batch?</a:t>
+            </a:r>
           </a:p>
         </p:txBody>
       </p:sp>
       <p:sp>
         <p:nvSpPr>
-          <p:cNvPr id="4" name="Pladsholder til indhold 3">
+          <p:cNvPr id="5" name="Pladsholder til tekst 2">
             <a:extLst>
               <a:ext uri="{FF2B5EF4-FFF2-40B4-BE49-F238E27FC236}">
-                <a16:creationId xmlns:a16="http://schemas.microsoft.com/office/drawing/2014/main" id="{F9C84B06-3C3A-A31C-FA40-47A33CAEECF2}"/>
+                <a16:creationId xmlns:a16="http://schemas.microsoft.com/office/drawing/2014/main" id="{85E611FE-01EA-BBBF-B9B3-8F11C1B3491F}"/>
               </a:ext>
             </a:extLst>
           </p:cNvPr>
-          <p:cNvSpPr>
-            <a:spLocks noGrp="1"/>
+          <p:cNvSpPr txBox="1">
+            <a:spLocks/>
           </p:cNvSpPr>
-          <p:nvPr>
-            <p:ph sz="half" idx="2"/>
-          </p:nvPr>
-        </p:nvSpPr>
-        <p:spPr/>
+          <p:nvPr/>
+        </p:nvSpPr>
+        <p:spPr>
+          <a:xfrm rot="20931083">
+            <a:off x="2952016" y="2245578"/>
+            <a:ext cx="7017488" cy="504002"/>
+          </a:xfrm>
+          <a:prstGeom prst="rect">
+            <a:avLst/>
+          </a:prstGeom>
+        </p:spPr>
         <p:txBody>
-          <a:bodyPr/>
-          <a:lstStyle/>
-          <a:p>
-            <a:endParaRPr lang="da-DK"/>
+          <a:bodyPr vert="horz" lIns="91440" tIns="45720" rIns="91440" bIns="45720" rtlCol="0">
+            <a:normAutofit/>
+          </a:bodyPr>
+          <a:lstStyle>
+            <a:lvl1pPr marL="0" indent="0" algn="l" defTabSz="914400" rtl="0" eaLnBrk="1" latinLnBrk="0" hangingPunct="1">
+              <a:lnSpc>
+                <a:spcPct val="100000"/>
+              </a:lnSpc>
+              <a:spcBef>
+                <a:spcPts val="700"/>
+              </a:spcBef>
+              <a:buClr>
+                <a:schemeClr val="tx2"/>
+              </a:buClr>
+              <a:buFont typeface="Arial" panose="020B0604020202020204" pitchFamily="34" charset="0"/>
+              <a:buNone/>
+              <a:defRPr sz="2000" b="1" i="0" kern="1200" cap="all" spc="400" baseline="0">
+                <a:solidFill>
+                  <a:schemeClr val="accent1"/>
+                </a:solidFill>
+                <a:latin typeface="+mn-lt"/>
+                <a:ea typeface="+mn-ea"/>
+                <a:cs typeface="+mn-cs"/>
+              </a:defRPr>
+            </a:lvl1pPr>
+            <a:lvl2pPr marL="457200" indent="0" algn="l" defTabSz="914400" rtl="0" eaLnBrk="1" latinLnBrk="0" hangingPunct="1">
+              <a:lnSpc>
+                <a:spcPct val="110000"/>
+              </a:lnSpc>
+              <a:spcBef>
+                <a:spcPts val="700"/>
+              </a:spcBef>
+              <a:buClr>
+                <a:schemeClr val="tx2"/>
+              </a:buClr>
+              <a:buFont typeface="Gill Sans MT" panose="020B0502020104020203" pitchFamily="34" charset="0"/>
+              <a:buNone/>
+              <a:defRPr sz="2000" kern="1200">
+                <a:solidFill>
+                  <a:schemeClr val="tx1">
+                    <a:tint val="75000"/>
+                  </a:schemeClr>
+                </a:solidFill>
+                <a:latin typeface="+mn-lt"/>
+                <a:ea typeface="+mn-ea"/>
+                <a:cs typeface="+mn-cs"/>
+              </a:defRPr>
+            </a:lvl2pPr>
+            <a:lvl3pPr marL="914400" indent="0" algn="l" defTabSz="914400" rtl="0" eaLnBrk="1" latinLnBrk="0" hangingPunct="1">
+              <a:lnSpc>
+                <a:spcPct val="110000"/>
+              </a:lnSpc>
+              <a:spcBef>
+                <a:spcPts val="700"/>
+              </a:spcBef>
+              <a:buClr>
+                <a:schemeClr val="tx2"/>
+              </a:buClr>
+              <a:buFont typeface="Arial" panose="020B0604020202020204" pitchFamily="34" charset="0"/>
+              <a:buNone/>
+              <a:defRPr sz="1800" kern="1200">
+                <a:solidFill>
+                  <a:schemeClr val="tx1">
+                    <a:tint val="75000"/>
+                  </a:schemeClr>
+                </a:solidFill>
+                <a:latin typeface="+mn-lt"/>
+                <a:ea typeface="+mn-ea"/>
+                <a:cs typeface="+mn-cs"/>
+              </a:defRPr>
+            </a:lvl3pPr>
+            <a:lvl4pPr marL="1371600" indent="0" algn="l" defTabSz="914400" rtl="0" eaLnBrk="1" latinLnBrk="0" hangingPunct="1">
+              <a:lnSpc>
+                <a:spcPct val="110000"/>
+              </a:lnSpc>
+              <a:spcBef>
+                <a:spcPts val="700"/>
+              </a:spcBef>
+              <a:buClr>
+                <a:schemeClr val="tx2"/>
+              </a:buClr>
+              <a:buFont typeface="Gill Sans MT" panose="020B0502020104020203" pitchFamily="34" charset="0"/>
+              <a:buNone/>
+              <a:defRPr sz="1600" kern="1200">
+                <a:solidFill>
+                  <a:schemeClr val="tx1">
+                    <a:tint val="75000"/>
+                  </a:schemeClr>
+                </a:solidFill>
+                <a:latin typeface="+mn-lt"/>
+                <a:ea typeface="+mn-ea"/>
+                <a:cs typeface="+mn-cs"/>
+              </a:defRPr>
+            </a:lvl4pPr>
+            <a:lvl5pPr marL="1828800" indent="0" algn="l" defTabSz="914400" rtl="0" eaLnBrk="1" latinLnBrk="0" hangingPunct="1">
+              <a:lnSpc>
+                <a:spcPct val="110000"/>
+              </a:lnSpc>
+              <a:spcBef>
+                <a:spcPts val="700"/>
+              </a:spcBef>
+              <a:buClr>
+                <a:schemeClr val="tx2"/>
+              </a:buClr>
+              <a:buFont typeface="Arial" panose="020B0604020202020204" pitchFamily="34" charset="0"/>
+              <a:buNone/>
+              <a:defRPr sz="1600" kern="1200">
+                <a:solidFill>
+                  <a:schemeClr val="tx1">
+                    <a:tint val="75000"/>
+                  </a:schemeClr>
+                </a:solidFill>
+                <a:latin typeface="+mn-lt"/>
+                <a:ea typeface="+mn-ea"/>
+                <a:cs typeface="+mn-cs"/>
+              </a:defRPr>
+            </a:lvl5pPr>
+            <a:lvl6pPr marL="2286000" indent="0" algn="l" defTabSz="914400" rtl="0" eaLnBrk="1" latinLnBrk="0" hangingPunct="1">
+              <a:lnSpc>
+                <a:spcPct val="110000"/>
+              </a:lnSpc>
+              <a:spcBef>
+                <a:spcPts val="700"/>
+              </a:spcBef>
+              <a:buClr>
+                <a:schemeClr val="tx2"/>
+              </a:buClr>
+              <a:buFont typeface="Gill Sans MT" panose="020B0502020104020203" pitchFamily="34" charset="0"/>
+              <a:buNone/>
+              <a:defRPr sz="1600" kern="1200">
+                <a:solidFill>
+                  <a:schemeClr val="tx1">
+                    <a:tint val="75000"/>
+                  </a:schemeClr>
+                </a:solidFill>
+                <a:latin typeface="+mn-lt"/>
+                <a:ea typeface="+mn-ea"/>
+                <a:cs typeface="+mn-cs"/>
+              </a:defRPr>
+            </a:lvl6pPr>
+            <a:lvl7pPr marL="2743200" indent="0" algn="l" defTabSz="914400" rtl="0" eaLnBrk="1" latinLnBrk="0" hangingPunct="1">
+              <a:lnSpc>
+                <a:spcPct val="110000"/>
+              </a:lnSpc>
+              <a:spcBef>
+                <a:spcPts val="700"/>
+              </a:spcBef>
+              <a:buClr>
+                <a:schemeClr val="tx2"/>
+              </a:buClr>
+              <a:buFont typeface="Arial" panose="020B0604020202020204" pitchFamily="34" charset="0"/>
+              <a:buNone/>
+              <a:defRPr sz="1600" kern="1200">
+                <a:solidFill>
+                  <a:schemeClr val="tx1">
+                    <a:tint val="75000"/>
+                  </a:schemeClr>
+                </a:solidFill>
+                <a:latin typeface="+mn-lt"/>
+                <a:ea typeface="+mn-ea"/>
+                <a:cs typeface="+mn-cs"/>
+              </a:defRPr>
+            </a:lvl7pPr>
+            <a:lvl8pPr marL="3200400" indent="0" algn="l" defTabSz="914400" rtl="0" eaLnBrk="1" latinLnBrk="0" hangingPunct="1">
+              <a:lnSpc>
+                <a:spcPct val="110000"/>
+              </a:lnSpc>
+              <a:spcBef>
+                <a:spcPts val="700"/>
+              </a:spcBef>
+              <a:buClr>
+                <a:schemeClr val="tx2"/>
+              </a:buClr>
+              <a:buFont typeface="Gill Sans MT" panose="020B0502020104020203" pitchFamily="34" charset="0"/>
+              <a:buNone/>
+              <a:defRPr sz="1600" kern="1200" baseline="0">
+                <a:solidFill>
+                  <a:schemeClr val="tx1">
+                    <a:tint val="75000"/>
+                  </a:schemeClr>
+                </a:solidFill>
+                <a:latin typeface="+mn-lt"/>
+                <a:ea typeface="+mn-ea"/>
+                <a:cs typeface="+mn-cs"/>
+              </a:defRPr>
+            </a:lvl8pPr>
+            <a:lvl9pPr marL="3657600" indent="0" algn="l" defTabSz="914400" rtl="0" eaLnBrk="1" latinLnBrk="0" hangingPunct="1">
+              <a:lnSpc>
+                <a:spcPct val="110000"/>
+              </a:lnSpc>
+              <a:spcBef>
+                <a:spcPts val="700"/>
+              </a:spcBef>
+              <a:buClr>
+                <a:schemeClr val="tx2"/>
+              </a:buClr>
+              <a:buFont typeface="Arial" panose="020B0604020202020204" pitchFamily="34" charset="0"/>
+              <a:buNone/>
+              <a:defRPr sz="1600" kern="1200" baseline="0">
+                <a:solidFill>
+                  <a:schemeClr val="tx1">
+                    <a:tint val="75000"/>
+                  </a:schemeClr>
+                </a:solidFill>
+                <a:latin typeface="+mn-lt"/>
+                <a:ea typeface="+mn-ea"/>
+                <a:cs typeface="+mn-cs"/>
+              </a:defRPr>
+            </a:lvl9pPr>
+          </a:lstStyle>
+          <a:p>
+            <a:r>
+              <a:rPr lang="en-US" noProof="0" dirty="0"/>
+              <a:t>Divide into Batches?</a:t>
+            </a:r>
+          </a:p>
+        </p:txBody>
+      </p:sp>
+      <p:sp>
+        <p:nvSpPr>
+          <p:cNvPr id="6" name="Pladsholder til tekst 2">
+            <a:extLst>
+              <a:ext uri="{FF2B5EF4-FFF2-40B4-BE49-F238E27FC236}">
+                <a16:creationId xmlns:a16="http://schemas.microsoft.com/office/drawing/2014/main" id="{A0BC7C3D-647E-B2E9-52DC-A9FFF7206C06}"/>
+              </a:ext>
+            </a:extLst>
+          </p:cNvPr>
+          <p:cNvSpPr txBox="1">
+            <a:spLocks/>
+          </p:cNvSpPr>
+          <p:nvPr/>
+        </p:nvSpPr>
+        <p:spPr>
+          <a:xfrm rot="231659">
+            <a:off x="4664496" y="1096335"/>
+            <a:ext cx="8169581" cy="951135"/>
+          </a:xfrm>
+          <a:prstGeom prst="rect">
+            <a:avLst/>
+          </a:prstGeom>
+        </p:spPr>
+        <p:txBody>
+          <a:bodyPr vert="horz" lIns="91440" tIns="45720" rIns="91440" bIns="45720" rtlCol="0">
+            <a:normAutofit/>
+          </a:bodyPr>
+          <a:lstStyle>
+            <a:lvl1pPr marL="0" indent="0" algn="l" defTabSz="914400" rtl="0" eaLnBrk="1" latinLnBrk="0" hangingPunct="1">
+              <a:lnSpc>
+                <a:spcPct val="100000"/>
+              </a:lnSpc>
+              <a:spcBef>
+                <a:spcPts val="700"/>
+              </a:spcBef>
+              <a:buClr>
+                <a:schemeClr val="tx2"/>
+              </a:buClr>
+              <a:buFont typeface="Arial" panose="020B0604020202020204" pitchFamily="34" charset="0"/>
+              <a:buNone/>
+              <a:defRPr sz="2000" b="1" i="0" kern="1200" cap="all" spc="400" baseline="0">
+                <a:solidFill>
+                  <a:schemeClr val="accent1"/>
+                </a:solidFill>
+                <a:latin typeface="+mn-lt"/>
+                <a:ea typeface="+mn-ea"/>
+                <a:cs typeface="+mn-cs"/>
+              </a:defRPr>
+            </a:lvl1pPr>
+            <a:lvl2pPr marL="457200" indent="0" algn="l" defTabSz="914400" rtl="0" eaLnBrk="1" latinLnBrk="0" hangingPunct="1">
+              <a:lnSpc>
+                <a:spcPct val="110000"/>
+              </a:lnSpc>
+              <a:spcBef>
+                <a:spcPts val="700"/>
+              </a:spcBef>
+              <a:buClr>
+                <a:schemeClr val="tx2"/>
+              </a:buClr>
+              <a:buFont typeface="Gill Sans MT" panose="020B0502020104020203" pitchFamily="34" charset="0"/>
+              <a:buNone/>
+              <a:defRPr sz="2000" kern="1200">
+                <a:solidFill>
+                  <a:schemeClr val="tx1">
+                    <a:tint val="75000"/>
+                  </a:schemeClr>
+                </a:solidFill>
+                <a:latin typeface="+mn-lt"/>
+                <a:ea typeface="+mn-ea"/>
+                <a:cs typeface="+mn-cs"/>
+              </a:defRPr>
+            </a:lvl2pPr>
+            <a:lvl3pPr marL="914400" indent="0" algn="l" defTabSz="914400" rtl="0" eaLnBrk="1" latinLnBrk="0" hangingPunct="1">
+              <a:lnSpc>
+                <a:spcPct val="110000"/>
+              </a:lnSpc>
+              <a:spcBef>
+                <a:spcPts val="700"/>
+              </a:spcBef>
+              <a:buClr>
+                <a:schemeClr val="tx2"/>
+              </a:buClr>
+              <a:buFont typeface="Arial" panose="020B0604020202020204" pitchFamily="34" charset="0"/>
+              <a:buNone/>
+              <a:defRPr sz="1800" kern="1200">
+                <a:solidFill>
+                  <a:schemeClr val="tx1">
+                    <a:tint val="75000"/>
+                  </a:schemeClr>
+                </a:solidFill>
+                <a:latin typeface="+mn-lt"/>
+                <a:ea typeface="+mn-ea"/>
+                <a:cs typeface="+mn-cs"/>
+              </a:defRPr>
+            </a:lvl3pPr>
+            <a:lvl4pPr marL="1371600" indent="0" algn="l" defTabSz="914400" rtl="0" eaLnBrk="1" latinLnBrk="0" hangingPunct="1">
+              <a:lnSpc>
+                <a:spcPct val="110000"/>
+              </a:lnSpc>
+              <a:spcBef>
+                <a:spcPts val="700"/>
+              </a:spcBef>
+              <a:buClr>
+                <a:schemeClr val="tx2"/>
+              </a:buClr>
+              <a:buFont typeface="Gill Sans MT" panose="020B0502020104020203" pitchFamily="34" charset="0"/>
+              <a:buNone/>
+              <a:defRPr sz="1600" kern="1200">
+                <a:solidFill>
+                  <a:schemeClr val="tx1">
+                    <a:tint val="75000"/>
+                  </a:schemeClr>
+                </a:solidFill>
+                <a:latin typeface="+mn-lt"/>
+                <a:ea typeface="+mn-ea"/>
+                <a:cs typeface="+mn-cs"/>
+              </a:defRPr>
+            </a:lvl4pPr>
+            <a:lvl5pPr marL="1828800" indent="0" algn="l" defTabSz="914400" rtl="0" eaLnBrk="1" latinLnBrk="0" hangingPunct="1">
+              <a:lnSpc>
+                <a:spcPct val="110000"/>
+              </a:lnSpc>
+              <a:spcBef>
+                <a:spcPts val="700"/>
+              </a:spcBef>
+              <a:buClr>
+                <a:schemeClr val="tx2"/>
+              </a:buClr>
+              <a:buFont typeface="Arial" panose="020B0604020202020204" pitchFamily="34" charset="0"/>
+              <a:buNone/>
+              <a:defRPr sz="1600" kern="1200">
+                <a:solidFill>
+                  <a:schemeClr val="tx1">
+                    <a:tint val="75000"/>
+                  </a:schemeClr>
+                </a:solidFill>
+                <a:latin typeface="+mn-lt"/>
+                <a:ea typeface="+mn-ea"/>
+                <a:cs typeface="+mn-cs"/>
+              </a:defRPr>
+            </a:lvl5pPr>
+            <a:lvl6pPr marL="2286000" indent="0" algn="l" defTabSz="914400" rtl="0" eaLnBrk="1" latinLnBrk="0" hangingPunct="1">
+              <a:lnSpc>
+                <a:spcPct val="110000"/>
+              </a:lnSpc>
+              <a:spcBef>
+                <a:spcPts val="700"/>
+              </a:spcBef>
+              <a:buClr>
+                <a:schemeClr val="tx2"/>
+              </a:buClr>
+              <a:buFont typeface="Gill Sans MT" panose="020B0502020104020203" pitchFamily="34" charset="0"/>
+              <a:buNone/>
+              <a:defRPr sz="1600" kern="1200">
+                <a:solidFill>
+                  <a:schemeClr val="tx1">
+                    <a:tint val="75000"/>
+                  </a:schemeClr>
+                </a:solidFill>
+                <a:latin typeface="+mn-lt"/>
+                <a:ea typeface="+mn-ea"/>
+                <a:cs typeface="+mn-cs"/>
+              </a:defRPr>
+            </a:lvl6pPr>
+            <a:lvl7pPr marL="2743200" indent="0" algn="l" defTabSz="914400" rtl="0" eaLnBrk="1" latinLnBrk="0" hangingPunct="1">
+              <a:lnSpc>
+                <a:spcPct val="110000"/>
+              </a:lnSpc>
+              <a:spcBef>
+                <a:spcPts val="700"/>
+              </a:spcBef>
+              <a:buClr>
+                <a:schemeClr val="tx2"/>
+              </a:buClr>
+              <a:buFont typeface="Arial" panose="020B0604020202020204" pitchFamily="34" charset="0"/>
+              <a:buNone/>
+              <a:defRPr sz="1600" kern="1200">
+                <a:solidFill>
+                  <a:schemeClr val="tx1">
+                    <a:tint val="75000"/>
+                  </a:schemeClr>
+                </a:solidFill>
+                <a:latin typeface="+mn-lt"/>
+                <a:ea typeface="+mn-ea"/>
+                <a:cs typeface="+mn-cs"/>
+              </a:defRPr>
+            </a:lvl7pPr>
+            <a:lvl8pPr marL="3200400" indent="0" algn="l" defTabSz="914400" rtl="0" eaLnBrk="1" latinLnBrk="0" hangingPunct="1">
+              <a:lnSpc>
+                <a:spcPct val="110000"/>
+              </a:lnSpc>
+              <a:spcBef>
+                <a:spcPts val="700"/>
+              </a:spcBef>
+              <a:buClr>
+                <a:schemeClr val="tx2"/>
+              </a:buClr>
+              <a:buFont typeface="Gill Sans MT" panose="020B0502020104020203" pitchFamily="34" charset="0"/>
+              <a:buNone/>
+              <a:defRPr sz="1600" kern="1200" baseline="0">
+                <a:solidFill>
+                  <a:schemeClr val="tx1">
+                    <a:tint val="75000"/>
+                  </a:schemeClr>
+                </a:solidFill>
+                <a:latin typeface="+mn-lt"/>
+                <a:ea typeface="+mn-ea"/>
+                <a:cs typeface="+mn-cs"/>
+              </a:defRPr>
+            </a:lvl8pPr>
+            <a:lvl9pPr marL="3657600" indent="0" algn="l" defTabSz="914400" rtl="0" eaLnBrk="1" latinLnBrk="0" hangingPunct="1">
+              <a:lnSpc>
+                <a:spcPct val="110000"/>
+              </a:lnSpc>
+              <a:spcBef>
+                <a:spcPts val="700"/>
+              </a:spcBef>
+              <a:buClr>
+                <a:schemeClr val="tx2"/>
+              </a:buClr>
+              <a:buFont typeface="Arial" panose="020B0604020202020204" pitchFamily="34" charset="0"/>
+              <a:buNone/>
+              <a:defRPr sz="1600" kern="1200" baseline="0">
+                <a:solidFill>
+                  <a:schemeClr val="tx1">
+                    <a:tint val="75000"/>
+                  </a:schemeClr>
+                </a:solidFill>
+                <a:latin typeface="+mn-lt"/>
+                <a:ea typeface="+mn-ea"/>
+                <a:cs typeface="+mn-cs"/>
+              </a:defRPr>
+            </a:lvl9pPr>
+          </a:lstStyle>
+          <a:p>
+            <a:r>
+              <a:rPr lang="en-US" noProof="0" dirty="0"/>
+              <a:t>Insert Empty pizzas with 0 cooking time to fill up batch?</a:t>
+            </a:r>
+          </a:p>
+        </p:txBody>
+      </p:sp>
+      <p:sp>
+        <p:nvSpPr>
+          <p:cNvPr id="7" name="Pladsholder til tekst 2">
+            <a:extLst>
+              <a:ext uri="{FF2B5EF4-FFF2-40B4-BE49-F238E27FC236}">
+                <a16:creationId xmlns:a16="http://schemas.microsoft.com/office/drawing/2014/main" id="{822AB52D-885A-0181-A536-6E2EA43CDF88}"/>
+              </a:ext>
+            </a:extLst>
+          </p:cNvPr>
+          <p:cNvSpPr txBox="1">
+            <a:spLocks/>
+          </p:cNvSpPr>
+          <p:nvPr/>
+        </p:nvSpPr>
+        <p:spPr>
+          <a:xfrm rot="21364985">
+            <a:off x="2354907" y="239092"/>
+            <a:ext cx="7017488" cy="504002"/>
+          </a:xfrm>
+          <a:prstGeom prst="rect">
+            <a:avLst/>
+          </a:prstGeom>
+        </p:spPr>
+        <p:txBody>
+          <a:bodyPr vert="horz" lIns="91440" tIns="45720" rIns="91440" bIns="45720" rtlCol="0">
+            <a:normAutofit/>
+          </a:bodyPr>
+          <a:lstStyle>
+            <a:lvl1pPr marL="0" indent="0" algn="l" defTabSz="914400" rtl="0" eaLnBrk="1" latinLnBrk="0" hangingPunct="1">
+              <a:lnSpc>
+                <a:spcPct val="100000"/>
+              </a:lnSpc>
+              <a:spcBef>
+                <a:spcPts val="700"/>
+              </a:spcBef>
+              <a:buClr>
+                <a:schemeClr val="tx2"/>
+              </a:buClr>
+              <a:buFont typeface="Arial" panose="020B0604020202020204" pitchFamily="34" charset="0"/>
+              <a:buNone/>
+              <a:defRPr sz="2000" b="1" i="0" kern="1200" cap="all" spc="400" baseline="0">
+                <a:solidFill>
+                  <a:schemeClr val="accent1"/>
+                </a:solidFill>
+                <a:latin typeface="+mn-lt"/>
+                <a:ea typeface="+mn-ea"/>
+                <a:cs typeface="+mn-cs"/>
+              </a:defRPr>
+            </a:lvl1pPr>
+            <a:lvl2pPr marL="457200" indent="0" algn="l" defTabSz="914400" rtl="0" eaLnBrk="1" latinLnBrk="0" hangingPunct="1">
+              <a:lnSpc>
+                <a:spcPct val="110000"/>
+              </a:lnSpc>
+              <a:spcBef>
+                <a:spcPts val="700"/>
+              </a:spcBef>
+              <a:buClr>
+                <a:schemeClr val="tx2"/>
+              </a:buClr>
+              <a:buFont typeface="Gill Sans MT" panose="020B0502020104020203" pitchFamily="34" charset="0"/>
+              <a:buNone/>
+              <a:defRPr sz="2000" kern="1200">
+                <a:solidFill>
+                  <a:schemeClr val="tx1">
+                    <a:tint val="75000"/>
+                  </a:schemeClr>
+                </a:solidFill>
+                <a:latin typeface="+mn-lt"/>
+                <a:ea typeface="+mn-ea"/>
+                <a:cs typeface="+mn-cs"/>
+              </a:defRPr>
+            </a:lvl2pPr>
+            <a:lvl3pPr marL="914400" indent="0" algn="l" defTabSz="914400" rtl="0" eaLnBrk="1" latinLnBrk="0" hangingPunct="1">
+              <a:lnSpc>
+                <a:spcPct val="110000"/>
+              </a:lnSpc>
+              <a:spcBef>
+                <a:spcPts val="700"/>
+              </a:spcBef>
+              <a:buClr>
+                <a:schemeClr val="tx2"/>
+              </a:buClr>
+              <a:buFont typeface="Arial" panose="020B0604020202020204" pitchFamily="34" charset="0"/>
+              <a:buNone/>
+              <a:defRPr sz="1800" kern="1200">
+                <a:solidFill>
+                  <a:schemeClr val="tx1">
+                    <a:tint val="75000"/>
+                  </a:schemeClr>
+                </a:solidFill>
+                <a:latin typeface="+mn-lt"/>
+                <a:ea typeface="+mn-ea"/>
+                <a:cs typeface="+mn-cs"/>
+              </a:defRPr>
+            </a:lvl3pPr>
+            <a:lvl4pPr marL="1371600" indent="0" algn="l" defTabSz="914400" rtl="0" eaLnBrk="1" latinLnBrk="0" hangingPunct="1">
+              <a:lnSpc>
+                <a:spcPct val="110000"/>
+              </a:lnSpc>
+              <a:spcBef>
+                <a:spcPts val="700"/>
+              </a:spcBef>
+              <a:buClr>
+                <a:schemeClr val="tx2"/>
+              </a:buClr>
+              <a:buFont typeface="Gill Sans MT" panose="020B0502020104020203" pitchFamily="34" charset="0"/>
+              <a:buNone/>
+              <a:defRPr sz="1600" kern="1200">
+                <a:solidFill>
+                  <a:schemeClr val="tx1">
+                    <a:tint val="75000"/>
+                  </a:schemeClr>
+                </a:solidFill>
+                <a:latin typeface="+mn-lt"/>
+                <a:ea typeface="+mn-ea"/>
+                <a:cs typeface="+mn-cs"/>
+              </a:defRPr>
+            </a:lvl4pPr>
+            <a:lvl5pPr marL="1828800" indent="0" algn="l" defTabSz="914400" rtl="0" eaLnBrk="1" latinLnBrk="0" hangingPunct="1">
+              <a:lnSpc>
+                <a:spcPct val="110000"/>
+              </a:lnSpc>
+              <a:spcBef>
+                <a:spcPts val="700"/>
+              </a:spcBef>
+              <a:buClr>
+                <a:schemeClr val="tx2"/>
+              </a:buClr>
+              <a:buFont typeface="Arial" panose="020B0604020202020204" pitchFamily="34" charset="0"/>
+              <a:buNone/>
+              <a:defRPr sz="1600" kern="1200">
+                <a:solidFill>
+                  <a:schemeClr val="tx1">
+                    <a:tint val="75000"/>
+                  </a:schemeClr>
+                </a:solidFill>
+                <a:latin typeface="+mn-lt"/>
+                <a:ea typeface="+mn-ea"/>
+                <a:cs typeface="+mn-cs"/>
+              </a:defRPr>
+            </a:lvl5pPr>
+            <a:lvl6pPr marL="2286000" indent="0" algn="l" defTabSz="914400" rtl="0" eaLnBrk="1" latinLnBrk="0" hangingPunct="1">
+              <a:lnSpc>
+                <a:spcPct val="110000"/>
+              </a:lnSpc>
+              <a:spcBef>
+                <a:spcPts val="700"/>
+              </a:spcBef>
+              <a:buClr>
+                <a:schemeClr val="tx2"/>
+              </a:buClr>
+              <a:buFont typeface="Gill Sans MT" panose="020B0502020104020203" pitchFamily="34" charset="0"/>
+              <a:buNone/>
+              <a:defRPr sz="1600" kern="1200">
+                <a:solidFill>
+                  <a:schemeClr val="tx1">
+                    <a:tint val="75000"/>
+                  </a:schemeClr>
+                </a:solidFill>
+                <a:latin typeface="+mn-lt"/>
+                <a:ea typeface="+mn-ea"/>
+                <a:cs typeface="+mn-cs"/>
+              </a:defRPr>
+            </a:lvl6pPr>
+            <a:lvl7pPr marL="2743200" indent="0" algn="l" defTabSz="914400" rtl="0" eaLnBrk="1" latinLnBrk="0" hangingPunct="1">
+              <a:lnSpc>
+                <a:spcPct val="110000"/>
+              </a:lnSpc>
+              <a:spcBef>
+                <a:spcPts val="700"/>
+              </a:spcBef>
+              <a:buClr>
+                <a:schemeClr val="tx2"/>
+              </a:buClr>
+              <a:buFont typeface="Arial" panose="020B0604020202020204" pitchFamily="34" charset="0"/>
+              <a:buNone/>
+              <a:defRPr sz="1600" kern="1200">
+                <a:solidFill>
+                  <a:schemeClr val="tx1">
+                    <a:tint val="75000"/>
+                  </a:schemeClr>
+                </a:solidFill>
+                <a:latin typeface="+mn-lt"/>
+                <a:ea typeface="+mn-ea"/>
+                <a:cs typeface="+mn-cs"/>
+              </a:defRPr>
+            </a:lvl7pPr>
+            <a:lvl8pPr marL="3200400" indent="0" algn="l" defTabSz="914400" rtl="0" eaLnBrk="1" latinLnBrk="0" hangingPunct="1">
+              <a:lnSpc>
+                <a:spcPct val="110000"/>
+              </a:lnSpc>
+              <a:spcBef>
+                <a:spcPts val="700"/>
+              </a:spcBef>
+              <a:buClr>
+                <a:schemeClr val="tx2"/>
+              </a:buClr>
+              <a:buFont typeface="Gill Sans MT" panose="020B0502020104020203" pitchFamily="34" charset="0"/>
+              <a:buNone/>
+              <a:defRPr sz="1600" kern="1200" baseline="0">
+                <a:solidFill>
+                  <a:schemeClr val="tx1">
+                    <a:tint val="75000"/>
+                  </a:schemeClr>
+                </a:solidFill>
+                <a:latin typeface="+mn-lt"/>
+                <a:ea typeface="+mn-ea"/>
+                <a:cs typeface="+mn-cs"/>
+              </a:defRPr>
+            </a:lvl8pPr>
+            <a:lvl9pPr marL="3657600" indent="0" algn="l" defTabSz="914400" rtl="0" eaLnBrk="1" latinLnBrk="0" hangingPunct="1">
+              <a:lnSpc>
+                <a:spcPct val="110000"/>
+              </a:lnSpc>
+              <a:spcBef>
+                <a:spcPts val="700"/>
+              </a:spcBef>
+              <a:buClr>
+                <a:schemeClr val="tx2"/>
+              </a:buClr>
+              <a:buFont typeface="Arial" panose="020B0604020202020204" pitchFamily="34" charset="0"/>
+              <a:buNone/>
+              <a:defRPr sz="1600" kern="1200" baseline="0">
+                <a:solidFill>
+                  <a:schemeClr val="tx1">
+                    <a:tint val="75000"/>
+                  </a:schemeClr>
+                </a:solidFill>
+                <a:latin typeface="+mn-lt"/>
+                <a:ea typeface="+mn-ea"/>
+                <a:cs typeface="+mn-cs"/>
+              </a:defRPr>
+            </a:lvl9pPr>
+          </a:lstStyle>
+          <a:p>
+            <a:r>
+              <a:rPr lang="en-US" noProof="0" dirty="0"/>
+              <a:t>Perhaps order that list?</a:t>
+            </a:r>
+          </a:p>
+        </p:txBody>
+      </p:sp>
+      <p:sp>
+        <p:nvSpPr>
+          <p:cNvPr id="8" name="Pladsholder til tekst 2">
+            <a:extLst>
+              <a:ext uri="{FF2B5EF4-FFF2-40B4-BE49-F238E27FC236}">
+                <a16:creationId xmlns:a16="http://schemas.microsoft.com/office/drawing/2014/main" id="{57B6532C-0A6F-3E59-5B0C-10ECD94CCC82}"/>
+              </a:ext>
+            </a:extLst>
+          </p:cNvPr>
+          <p:cNvSpPr txBox="1">
+            <a:spLocks/>
+          </p:cNvSpPr>
+          <p:nvPr/>
+        </p:nvSpPr>
+        <p:spPr>
+          <a:xfrm rot="183458">
+            <a:off x="8431965" y="5984980"/>
+            <a:ext cx="4643027" cy="504002"/>
+          </a:xfrm>
+          <a:prstGeom prst="rect">
+            <a:avLst/>
+          </a:prstGeom>
+        </p:spPr>
+        <p:txBody>
+          <a:bodyPr vert="horz" lIns="91440" tIns="45720" rIns="91440" bIns="45720" rtlCol="0">
+            <a:normAutofit/>
+          </a:bodyPr>
+          <a:lstStyle>
+            <a:lvl1pPr marL="0" indent="0" algn="l" defTabSz="914400" rtl="0" eaLnBrk="1" latinLnBrk="0" hangingPunct="1">
+              <a:lnSpc>
+                <a:spcPct val="100000"/>
+              </a:lnSpc>
+              <a:spcBef>
+                <a:spcPts val="700"/>
+              </a:spcBef>
+              <a:buClr>
+                <a:schemeClr val="tx2"/>
+              </a:buClr>
+              <a:buFont typeface="Arial" panose="020B0604020202020204" pitchFamily="34" charset="0"/>
+              <a:buNone/>
+              <a:defRPr sz="2000" b="1" i="0" kern="1200" cap="all" spc="400" baseline="0">
+                <a:solidFill>
+                  <a:schemeClr val="accent1"/>
+                </a:solidFill>
+                <a:latin typeface="+mn-lt"/>
+                <a:ea typeface="+mn-ea"/>
+                <a:cs typeface="+mn-cs"/>
+              </a:defRPr>
+            </a:lvl1pPr>
+            <a:lvl2pPr marL="457200" indent="0" algn="l" defTabSz="914400" rtl="0" eaLnBrk="1" latinLnBrk="0" hangingPunct="1">
+              <a:lnSpc>
+                <a:spcPct val="110000"/>
+              </a:lnSpc>
+              <a:spcBef>
+                <a:spcPts val="700"/>
+              </a:spcBef>
+              <a:buClr>
+                <a:schemeClr val="tx2"/>
+              </a:buClr>
+              <a:buFont typeface="Gill Sans MT" panose="020B0502020104020203" pitchFamily="34" charset="0"/>
+              <a:buNone/>
+              <a:defRPr sz="2000" kern="1200">
+                <a:solidFill>
+                  <a:schemeClr val="tx1">
+                    <a:tint val="75000"/>
+                  </a:schemeClr>
+                </a:solidFill>
+                <a:latin typeface="+mn-lt"/>
+                <a:ea typeface="+mn-ea"/>
+                <a:cs typeface="+mn-cs"/>
+              </a:defRPr>
+            </a:lvl2pPr>
+            <a:lvl3pPr marL="914400" indent="0" algn="l" defTabSz="914400" rtl="0" eaLnBrk="1" latinLnBrk="0" hangingPunct="1">
+              <a:lnSpc>
+                <a:spcPct val="110000"/>
+              </a:lnSpc>
+              <a:spcBef>
+                <a:spcPts val="700"/>
+              </a:spcBef>
+              <a:buClr>
+                <a:schemeClr val="tx2"/>
+              </a:buClr>
+              <a:buFont typeface="Arial" panose="020B0604020202020204" pitchFamily="34" charset="0"/>
+              <a:buNone/>
+              <a:defRPr sz="1800" kern="1200">
+                <a:solidFill>
+                  <a:schemeClr val="tx1">
+                    <a:tint val="75000"/>
+                  </a:schemeClr>
+                </a:solidFill>
+                <a:latin typeface="+mn-lt"/>
+                <a:ea typeface="+mn-ea"/>
+                <a:cs typeface="+mn-cs"/>
+              </a:defRPr>
+            </a:lvl3pPr>
+            <a:lvl4pPr marL="1371600" indent="0" algn="l" defTabSz="914400" rtl="0" eaLnBrk="1" latinLnBrk="0" hangingPunct="1">
+              <a:lnSpc>
+                <a:spcPct val="110000"/>
+              </a:lnSpc>
+              <a:spcBef>
+                <a:spcPts val="700"/>
+              </a:spcBef>
+              <a:buClr>
+                <a:schemeClr val="tx2"/>
+              </a:buClr>
+              <a:buFont typeface="Gill Sans MT" panose="020B0502020104020203" pitchFamily="34" charset="0"/>
+              <a:buNone/>
+              <a:defRPr sz="1600" kern="1200">
+                <a:solidFill>
+                  <a:schemeClr val="tx1">
+                    <a:tint val="75000"/>
+                  </a:schemeClr>
+                </a:solidFill>
+                <a:latin typeface="+mn-lt"/>
+                <a:ea typeface="+mn-ea"/>
+                <a:cs typeface="+mn-cs"/>
+              </a:defRPr>
+            </a:lvl4pPr>
+            <a:lvl5pPr marL="1828800" indent="0" algn="l" defTabSz="914400" rtl="0" eaLnBrk="1" latinLnBrk="0" hangingPunct="1">
+              <a:lnSpc>
+                <a:spcPct val="110000"/>
+              </a:lnSpc>
+              <a:spcBef>
+                <a:spcPts val="700"/>
+              </a:spcBef>
+              <a:buClr>
+                <a:schemeClr val="tx2"/>
+              </a:buClr>
+              <a:buFont typeface="Arial" panose="020B0604020202020204" pitchFamily="34" charset="0"/>
+              <a:buNone/>
+              <a:defRPr sz="1600" kern="1200">
+                <a:solidFill>
+                  <a:schemeClr val="tx1">
+                    <a:tint val="75000"/>
+                  </a:schemeClr>
+                </a:solidFill>
+                <a:latin typeface="+mn-lt"/>
+                <a:ea typeface="+mn-ea"/>
+                <a:cs typeface="+mn-cs"/>
+              </a:defRPr>
+            </a:lvl5pPr>
+            <a:lvl6pPr marL="2286000" indent="0" algn="l" defTabSz="914400" rtl="0" eaLnBrk="1" latinLnBrk="0" hangingPunct="1">
+              <a:lnSpc>
+                <a:spcPct val="110000"/>
+              </a:lnSpc>
+              <a:spcBef>
+                <a:spcPts val="700"/>
+              </a:spcBef>
+              <a:buClr>
+                <a:schemeClr val="tx2"/>
+              </a:buClr>
+              <a:buFont typeface="Gill Sans MT" panose="020B0502020104020203" pitchFamily="34" charset="0"/>
+              <a:buNone/>
+              <a:defRPr sz="1600" kern="1200">
+                <a:solidFill>
+                  <a:schemeClr val="tx1">
+                    <a:tint val="75000"/>
+                  </a:schemeClr>
+                </a:solidFill>
+                <a:latin typeface="+mn-lt"/>
+                <a:ea typeface="+mn-ea"/>
+                <a:cs typeface="+mn-cs"/>
+              </a:defRPr>
+            </a:lvl6pPr>
+            <a:lvl7pPr marL="2743200" indent="0" algn="l" defTabSz="914400" rtl="0" eaLnBrk="1" latinLnBrk="0" hangingPunct="1">
+              <a:lnSpc>
+                <a:spcPct val="110000"/>
+              </a:lnSpc>
+              <a:spcBef>
+                <a:spcPts val="700"/>
+              </a:spcBef>
+              <a:buClr>
+                <a:schemeClr val="tx2"/>
+              </a:buClr>
+              <a:buFont typeface="Arial" panose="020B0604020202020204" pitchFamily="34" charset="0"/>
+              <a:buNone/>
+              <a:defRPr sz="1600" kern="1200">
+                <a:solidFill>
+                  <a:schemeClr val="tx1">
+                    <a:tint val="75000"/>
+                  </a:schemeClr>
+                </a:solidFill>
+                <a:latin typeface="+mn-lt"/>
+                <a:ea typeface="+mn-ea"/>
+                <a:cs typeface="+mn-cs"/>
+              </a:defRPr>
+            </a:lvl7pPr>
+            <a:lvl8pPr marL="3200400" indent="0" algn="l" defTabSz="914400" rtl="0" eaLnBrk="1" latinLnBrk="0" hangingPunct="1">
+              <a:lnSpc>
+                <a:spcPct val="110000"/>
+              </a:lnSpc>
+              <a:spcBef>
+                <a:spcPts val="700"/>
+              </a:spcBef>
+              <a:buClr>
+                <a:schemeClr val="tx2"/>
+              </a:buClr>
+              <a:buFont typeface="Gill Sans MT" panose="020B0502020104020203" pitchFamily="34" charset="0"/>
+              <a:buNone/>
+              <a:defRPr sz="1600" kern="1200" baseline="0">
+                <a:solidFill>
+                  <a:schemeClr val="tx1">
+                    <a:tint val="75000"/>
+                  </a:schemeClr>
+                </a:solidFill>
+                <a:latin typeface="+mn-lt"/>
+                <a:ea typeface="+mn-ea"/>
+                <a:cs typeface="+mn-cs"/>
+              </a:defRPr>
+            </a:lvl8pPr>
+            <a:lvl9pPr marL="3657600" indent="0" algn="l" defTabSz="914400" rtl="0" eaLnBrk="1" latinLnBrk="0" hangingPunct="1">
+              <a:lnSpc>
+                <a:spcPct val="110000"/>
+              </a:lnSpc>
+              <a:spcBef>
+                <a:spcPts val="700"/>
+              </a:spcBef>
+              <a:buClr>
+                <a:schemeClr val="tx2"/>
+              </a:buClr>
+              <a:buFont typeface="Arial" panose="020B0604020202020204" pitchFamily="34" charset="0"/>
+              <a:buNone/>
+              <a:defRPr sz="1600" kern="1200" baseline="0">
+                <a:solidFill>
+                  <a:schemeClr val="tx1">
+                    <a:tint val="75000"/>
+                  </a:schemeClr>
+                </a:solidFill>
+                <a:latin typeface="+mn-lt"/>
+                <a:ea typeface="+mn-ea"/>
+                <a:cs typeface="+mn-cs"/>
+              </a:defRPr>
+            </a:lvl9pPr>
+          </a:lstStyle>
+          <a:p>
+            <a:r>
+              <a:rPr lang="en-US" noProof="0" dirty="0"/>
+              <a:t>A combination???</a:t>
+            </a:r>
           </a:p>
         </p:txBody>
       </p:sp>
     </p:spTree>
     <p:extLst>
       <p:ext uri="{BB962C8B-B14F-4D97-AF65-F5344CB8AC3E}">
-        <p14:creationId xmlns:p14="http://schemas.microsoft.com/office/powerpoint/2010/main" val="3197318811"/>
+        <p14:creationId xmlns:p14="http://schemas.microsoft.com/office/powerpoint/2010/main" val="3147007501"/>
       </p:ext>
     </p:extLst>
   </p:cSld>
@@ -9913,7 +11658,7 @@
           <p:cNvPr id="2" name="Titel 1">
             <a:extLst>
               <a:ext uri="{FF2B5EF4-FFF2-40B4-BE49-F238E27FC236}">
-                <a16:creationId xmlns:a16="http://schemas.microsoft.com/office/drawing/2014/main" id="{B726AEE8-C798-4136-E025-F1A260436E52}"/>
+                <a16:creationId xmlns:a16="http://schemas.microsoft.com/office/drawing/2014/main" id="{6ACDFDA2-DBC4-31F5-4D86-13F3D8C2D1E4}"/>
               </a:ext>
             </a:extLst>
           </p:cNvPr>
@@ -9930,8 +11675,8 @@
           <a:lstStyle/>
           <a:p>
             <a:r>
-              <a:rPr lang="en-DK" noProof="0" dirty="0"/>
-              <a:t>Final Thoughts</a:t>
+              <a:rPr lang="en-GB" noProof="0" dirty="0"/>
+              <a:t>The ones I thought would work</a:t>
             </a:r>
           </a:p>
         </p:txBody>
@@ -9941,7 +11686,7 @@
           <p:cNvPr id="3" name="Pladsholder til indhold 2">
             <a:extLst>
               <a:ext uri="{FF2B5EF4-FFF2-40B4-BE49-F238E27FC236}">
-                <a16:creationId xmlns:a16="http://schemas.microsoft.com/office/drawing/2014/main" id="{726D3CD8-F4EE-27A8-6FFC-51B30ACA61B1}"/>
+                <a16:creationId xmlns:a16="http://schemas.microsoft.com/office/drawing/2014/main" id="{0139D2AC-9FBF-E54A-C1EF-C5B61B08497E}"/>
               </a:ext>
             </a:extLst>
           </p:cNvPr>
@@ -9952,21 +11697,45 @@
             <p:ph sz="half" idx="1"/>
           </p:nvPr>
         </p:nvSpPr>
-        <p:spPr/>
+        <p:spPr>
+          <a:xfrm>
+            <a:off x="1257300" y="4069830"/>
+            <a:ext cx="4800600" cy="2405784"/>
+          </a:xfrm>
+        </p:spPr>
         <p:txBody>
           <a:bodyPr/>
           <a:lstStyle/>
           <a:p>
             <a:r>
-              <a:rPr lang="en-DK" noProof="0" dirty="0"/>
-              <a:t>Think it’s been pretty good overall</a:t>
-            </a:r>
-          </a:p>
-          <a:p>
-            <a:r>
-              <a:rPr lang="en-DK" noProof="0" dirty="0"/>
-              <a:t>Wished I could go back and improve the bits I know aren’t ideal</a:t>
-            </a:r>
+              <a:rPr lang="en-GB" noProof="0" dirty="0"/>
+              <a:t>Kind of epitome of what I could come up with on my own</a:t>
+            </a:r>
+          </a:p>
+          <a:p>
+            <a:r>
+              <a:rPr lang="en-GB" noProof="0" dirty="0"/>
+              <a:t>Doesn’t work </a:t>
+            </a:r>
+            <a:r>
+              <a:rPr lang="en-GB" noProof="0" dirty="0">
+                <a:sym typeface="Wingdings" panose="05000000000000000000" pitchFamily="2" charset="2"/>
+              </a:rPr>
+              <a:t> Still allows for cooking of different cooking times at the </a:t>
+            </a:r>
+            <a:r>
+              <a:rPr lang="en-GB" noProof="0" dirty="0" err="1">
+                <a:sym typeface="Wingdings" panose="05000000000000000000" pitchFamily="2" charset="2"/>
+              </a:rPr>
+              <a:t>sam</a:t>
+            </a:r>
+            <a:r>
+              <a:rPr lang="en-GB" dirty="0">
+                <a:sym typeface="Wingdings" panose="05000000000000000000" pitchFamily="2" charset="2"/>
+              </a:rPr>
+              <a:t>e time</a:t>
+            </a:r>
+            <a:endParaRPr lang="en-GB" noProof="0" dirty="0"/>
           </a:p>
         </p:txBody>
       </p:sp>
@@ -9975,7 +11744,7 @@
           <p:cNvPr id="4" name="Pladsholder til indhold 3">
             <a:extLst>
               <a:ext uri="{FF2B5EF4-FFF2-40B4-BE49-F238E27FC236}">
-                <a16:creationId xmlns:a16="http://schemas.microsoft.com/office/drawing/2014/main" id="{5C2531A8-AFD4-C0F8-51BC-68177D2CD808}"/>
+                <a16:creationId xmlns:a16="http://schemas.microsoft.com/office/drawing/2014/main" id="{F9C84B06-3C3A-A31C-FA40-47A33CAEECF2}"/>
               </a:ext>
             </a:extLst>
           </p:cNvPr>
@@ -9986,19 +11755,111 @@
             <p:ph sz="half" idx="2"/>
           </p:nvPr>
         </p:nvSpPr>
-        <p:spPr/>
+        <p:spPr>
+          <a:xfrm>
+            <a:off x="6647796" y="4069830"/>
+            <a:ext cx="4800600" cy="2548327"/>
+          </a:xfrm>
+        </p:spPr>
         <p:txBody>
           <a:bodyPr/>
           <a:lstStyle/>
           <a:p>
-            <a:endParaRPr lang="da-DK"/>
+            <a:r>
+              <a:rPr lang="en-GB" noProof="0" dirty="0"/>
+              <a:t>Suggested by Copilot</a:t>
+            </a:r>
+          </a:p>
+          <a:p>
+            <a:r>
+              <a:rPr lang="en-GB" dirty="0"/>
+              <a:t>After I remembered Morten’s advice to give it empty pizzas</a:t>
+            </a:r>
+            <a:endParaRPr lang="en-GB" noProof="0" dirty="0"/>
+          </a:p>
+          <a:p>
+            <a:r>
+              <a:rPr lang="en-GB" noProof="0" dirty="0"/>
+              <a:t>Keeps running </a:t>
+            </a:r>
+            <a:r>
+              <a:rPr lang="en-GB" noProof="0" dirty="0">
+                <a:sym typeface="Wingdings" panose="05000000000000000000" pitchFamily="2" charset="2"/>
+              </a:rPr>
+              <a:t> </a:t>
+            </a:r>
+            <a:r>
+              <a:rPr lang="en-GB" dirty="0"/>
+              <a:t>Making all these empty elements for the program to handle makes it weird</a:t>
+            </a:r>
+            <a:endParaRPr lang="en-GB" noProof="0" dirty="0"/>
           </a:p>
         </p:txBody>
       </p:sp>
+      <p:pic>
+        <p:nvPicPr>
+          <p:cNvPr id="8" name="Billede 7">
+            <a:extLst>
+              <a:ext uri="{FF2B5EF4-FFF2-40B4-BE49-F238E27FC236}">
+                <a16:creationId xmlns:a16="http://schemas.microsoft.com/office/drawing/2014/main" id="{F42B9E80-75C5-578C-01C3-537545DDCE26}"/>
+              </a:ext>
+            </a:extLst>
+          </p:cNvPr>
+          <p:cNvPicPr>
+            <a:picLocks noChangeAspect="1"/>
+          </p:cNvPicPr>
+          <p:nvPr/>
+        </p:nvPicPr>
+        <p:blipFill>
+          <a:blip r:embed="rId3"/>
+          <a:stretch>
+            <a:fillRect/>
+          </a:stretch>
+        </p:blipFill>
+        <p:spPr>
+          <a:xfrm>
+            <a:off x="202644" y="1349274"/>
+            <a:ext cx="5896469" cy="2315821"/>
+          </a:xfrm>
+          <a:prstGeom prst="rect">
+            <a:avLst/>
+          </a:prstGeom>
+        </p:spPr>
+      </p:pic>
+      <p:pic>
+        <p:nvPicPr>
+          <p:cNvPr id="10" name="Billede 9">
+            <a:extLst>
+              <a:ext uri="{FF2B5EF4-FFF2-40B4-BE49-F238E27FC236}">
+                <a16:creationId xmlns:a16="http://schemas.microsoft.com/office/drawing/2014/main" id="{9D602B09-08EC-5901-63F3-52E144FE1A60}"/>
+              </a:ext>
+            </a:extLst>
+          </p:cNvPr>
+          <p:cNvPicPr>
+            <a:picLocks noChangeAspect="1"/>
+          </p:cNvPicPr>
+          <p:nvPr/>
+        </p:nvPicPr>
+        <p:blipFill>
+          <a:blip r:embed="rId4"/>
+          <a:stretch>
+            <a:fillRect/>
+          </a:stretch>
+        </p:blipFill>
+        <p:spPr>
+          <a:xfrm>
+            <a:off x="6345905" y="1349274"/>
+            <a:ext cx="5643451" cy="2315821"/>
+          </a:xfrm>
+          <a:prstGeom prst="rect">
+            <a:avLst/>
+          </a:prstGeom>
+        </p:spPr>
+      </p:pic>
     </p:spTree>
     <p:extLst>
       <p:ext uri="{BB962C8B-B14F-4D97-AF65-F5344CB8AC3E}">
-        <p14:creationId xmlns:p14="http://schemas.microsoft.com/office/powerpoint/2010/main" val="627090686"/>
+        <p14:creationId xmlns:p14="http://schemas.microsoft.com/office/powerpoint/2010/main" val="3197318811"/>
       </p:ext>
     </p:extLst>
   </p:cSld>

</xml_diff>

<commit_message>
Final edits to code and perhaps final version of presentation
</commit_message>
<xml_diff>
--- a/PizzaSolution Presentation.pptx
+++ b/PizzaSolution Presentation.pptx
@@ -207,7 +207,7 @@
           <a:p>
             <a:fld id="{0F1AA9B0-0C32-482B-B713-D8137480A8FA}" type="datetimeFigureOut">
               <a:rPr lang="da-DK" smtClean="0"/>
-              <a:t>26-03-2026</a:t>
+              <a:t>27-03-2026</a:t>
             </a:fld>
             <a:endParaRPr lang="da-DK"/>
           </a:p>
@@ -858,6 +858,36 @@
           <a:p>
             <a:r>
               <a:rPr lang="da-DK" dirty="0"/>
+              <a:t>First </a:t>
+            </a:r>
+            <a:r>
+              <a:rPr lang="da-DK" dirty="0" err="1"/>
+              <a:t>finished</a:t>
+            </a:r>
+            <a:r>
+              <a:rPr lang="da-DK" dirty="0"/>
+              <a:t> and </a:t>
+            </a:r>
+            <a:r>
+              <a:rPr lang="da-DK" dirty="0" err="1"/>
+              <a:t>working</a:t>
+            </a:r>
+            <a:r>
+              <a:rPr lang="da-DK" dirty="0"/>
+              <a:t> version of </a:t>
+            </a:r>
+            <a:r>
+              <a:rPr lang="da-DK" dirty="0" err="1"/>
+              <a:t>StockService</a:t>
+            </a:r>
+            <a:endParaRPr lang="da-DK" dirty="0"/>
+          </a:p>
+          <a:p>
+            <a:endParaRPr lang="da-DK" dirty="0"/>
+          </a:p>
+          <a:p>
+            <a:r>
+              <a:rPr lang="da-DK" dirty="0"/>
               <a:t>Order and </a:t>
             </a:r>
             <a:r>
@@ -1425,7 +1455,7 @@
             </a:r>
             <a:r>
               <a:rPr lang="en-US" dirty="0" err="1"/>
-              <a:t>GetSufficientStock</a:t>
+              <a:t>HasInsufficientStock</a:t>
             </a:r>
             <a:r>
               <a:rPr lang="en-US" dirty="0"/>
@@ -2090,6 +2120,120 @@
           <a:p>
             <a:r>
               <a:rPr lang="da-DK" dirty="0" err="1"/>
+              <a:t>They</a:t>
+            </a:r>
+            <a:r>
+              <a:rPr lang="da-DK" dirty="0"/>
+              <a:t> </a:t>
+            </a:r>
+            <a:r>
+              <a:rPr lang="da-DK" dirty="0" err="1"/>
+              <a:t>work</a:t>
+            </a:r>
+            <a:r>
+              <a:rPr lang="da-DK" dirty="0"/>
+              <a:t> as </a:t>
+            </a:r>
+            <a:r>
+              <a:rPr lang="da-DK" dirty="0" err="1"/>
+              <a:t>expected</a:t>
+            </a:r>
+            <a:r>
+              <a:rPr lang="da-DK" dirty="0"/>
+              <a:t> </a:t>
+            </a:r>
+            <a:r>
+              <a:rPr lang="da-DK" dirty="0" err="1"/>
+              <a:t>when</a:t>
+            </a:r>
+            <a:r>
+              <a:rPr lang="da-DK" dirty="0"/>
+              <a:t> </a:t>
+            </a:r>
+            <a:r>
+              <a:rPr lang="da-DK" dirty="0" err="1"/>
+              <a:t>debugging</a:t>
+            </a:r>
+            <a:r>
+              <a:rPr lang="da-DK" dirty="0"/>
+              <a:t>, </a:t>
+            </a:r>
+            <a:r>
+              <a:rPr lang="da-DK" dirty="0" err="1"/>
+              <a:t>meaning</a:t>
+            </a:r>
+            <a:r>
+              <a:rPr lang="da-DK" dirty="0"/>
+              <a:t> </a:t>
+            </a:r>
+            <a:r>
+              <a:rPr lang="da-DK" dirty="0" err="1"/>
+              <a:t>that</a:t>
+            </a:r>
+            <a:r>
+              <a:rPr lang="da-DK" dirty="0"/>
+              <a:t> the problem </a:t>
+            </a:r>
+            <a:r>
+              <a:rPr lang="da-DK" dirty="0" err="1"/>
+              <a:t>arises</a:t>
+            </a:r>
+            <a:r>
+              <a:rPr lang="da-DK" dirty="0"/>
+              <a:t> </a:t>
+            </a:r>
+            <a:r>
+              <a:rPr lang="da-DK" dirty="0" err="1"/>
+              <a:t>somewhere</a:t>
+            </a:r>
+            <a:r>
+              <a:rPr lang="da-DK" dirty="0"/>
+              <a:t> </a:t>
+            </a:r>
+            <a:r>
+              <a:rPr lang="da-DK" dirty="0" err="1"/>
+              <a:t>else</a:t>
+            </a:r>
+            <a:r>
+              <a:rPr lang="da-DK" dirty="0"/>
+              <a:t>, i.e. </a:t>
+            </a:r>
+            <a:r>
+              <a:rPr lang="da-DK" dirty="0" err="1"/>
+              <a:t>when</a:t>
+            </a:r>
+            <a:r>
+              <a:rPr lang="da-DK" dirty="0"/>
+              <a:t> the </a:t>
+            </a:r>
+            <a:r>
+              <a:rPr lang="da-DK" dirty="0" err="1"/>
+              <a:t>queue</a:t>
+            </a:r>
+            <a:r>
+              <a:rPr lang="da-DK" dirty="0"/>
+              <a:t> </a:t>
+            </a:r>
+            <a:r>
+              <a:rPr lang="da-DK" dirty="0" err="1"/>
+              <a:t>gets</a:t>
+            </a:r>
+            <a:r>
+              <a:rPr lang="da-DK" dirty="0"/>
+              <a:t> </a:t>
+            </a:r>
+            <a:r>
+              <a:rPr lang="da-DK" dirty="0" err="1"/>
+              <a:t>dequeued</a:t>
+            </a:r>
+            <a:endParaRPr lang="da-DK" dirty="0"/>
+          </a:p>
+          <a:p>
+            <a:endParaRPr lang="da-DK" dirty="0"/>
+          </a:p>
+          <a:p>
+            <a:r>
+              <a:rPr lang="da-DK" dirty="0" err="1"/>
               <a:t>Inserting</a:t>
             </a:r>
             <a:r>
@@ -2147,6 +2291,120 @@
             <a:r>
               <a:rPr lang="da-DK" dirty="0" err="1"/>
               <a:t>two</a:t>
+            </a:r>
+            <a:endParaRPr lang="da-DK" dirty="0"/>
+          </a:p>
+          <a:p>
+            <a:endParaRPr lang="da-DK" dirty="0"/>
+          </a:p>
+          <a:p>
+            <a:r>
+              <a:rPr lang="da-DK" dirty="0" err="1"/>
+              <a:t>Tried</a:t>
+            </a:r>
+            <a:r>
+              <a:rPr lang="da-DK" dirty="0"/>
+              <a:t> to </a:t>
+            </a:r>
+            <a:r>
+              <a:rPr lang="da-DK" dirty="0" err="1"/>
+              <a:t>make</a:t>
+            </a:r>
+            <a:r>
+              <a:rPr lang="da-DK" dirty="0"/>
+              <a:t> </a:t>
+            </a:r>
+            <a:r>
+              <a:rPr lang="da-DK" dirty="0" err="1"/>
+              <a:t>one</a:t>
+            </a:r>
+            <a:r>
+              <a:rPr lang="da-DK" dirty="0"/>
+              <a:t> </a:t>
+            </a:r>
+            <a:r>
+              <a:rPr lang="da-DK" dirty="0" err="1"/>
+              <a:t>that</a:t>
+            </a:r>
+            <a:r>
+              <a:rPr lang="da-DK" dirty="0"/>
+              <a:t> </a:t>
+            </a:r>
+            <a:r>
+              <a:rPr lang="da-DK" dirty="0" err="1"/>
+              <a:t>would</a:t>
+            </a:r>
+            <a:r>
+              <a:rPr lang="da-DK" dirty="0"/>
+              <a:t> handle </a:t>
+            </a:r>
+            <a:r>
+              <a:rPr lang="da-DK" dirty="0" err="1"/>
+              <a:t>orders</a:t>
+            </a:r>
+            <a:r>
+              <a:rPr lang="da-DK" dirty="0"/>
+              <a:t> in </a:t>
+            </a:r>
+            <a:r>
+              <a:rPr lang="da-DK" dirty="0" err="1"/>
+              <a:t>batches</a:t>
+            </a:r>
+            <a:r>
+              <a:rPr lang="da-DK" dirty="0"/>
+              <a:t> but it </a:t>
+            </a:r>
+            <a:r>
+              <a:rPr lang="da-DK" dirty="0" err="1"/>
+              <a:t>fails</a:t>
+            </a:r>
+            <a:r>
+              <a:rPr lang="da-DK" dirty="0"/>
+              <a:t> all tests, </a:t>
+            </a:r>
+            <a:r>
+              <a:rPr lang="da-DK" dirty="0" err="1"/>
+              <a:t>didn’t</a:t>
+            </a:r>
+            <a:r>
+              <a:rPr lang="da-DK" dirty="0"/>
+              <a:t> have time to </a:t>
+            </a:r>
+            <a:r>
+              <a:rPr lang="da-DK" dirty="0" err="1"/>
+              <a:t>debug</a:t>
+            </a:r>
+            <a:r>
+              <a:rPr lang="da-DK" dirty="0"/>
+              <a:t> and </a:t>
+            </a:r>
+            <a:r>
+              <a:rPr lang="da-DK" dirty="0" err="1"/>
+              <a:t>see</a:t>
+            </a:r>
+            <a:r>
+              <a:rPr lang="da-DK" dirty="0"/>
+              <a:t> </a:t>
+            </a:r>
+            <a:r>
+              <a:rPr lang="da-DK" dirty="0" err="1"/>
+              <a:t>what</a:t>
+            </a:r>
+            <a:r>
+              <a:rPr lang="da-DK" dirty="0"/>
+              <a:t> </a:t>
+            </a:r>
+            <a:r>
+              <a:rPr lang="da-DK" dirty="0" err="1"/>
+              <a:t>goes</a:t>
+            </a:r>
+            <a:r>
+              <a:rPr lang="da-DK" dirty="0"/>
+              <a:t> </a:t>
+            </a:r>
+            <a:r>
+              <a:rPr lang="da-DK" dirty="0" err="1"/>
+              <a:t>wrong</a:t>
             </a:r>
             <a:endParaRPr lang="da-DK" dirty="0"/>
           </a:p>
@@ -2179,6 +2437,210 @@
     <p:extLst>
       <p:ext uri="{BB962C8B-B14F-4D97-AF65-F5344CB8AC3E}">
         <p14:creationId xmlns:p14="http://schemas.microsoft.com/office/powerpoint/2010/main" val="2778589724"/>
+      </p:ext>
+    </p:extLst>
+  </p:cSld>
+  <p:clrMapOvr>
+    <a:masterClrMapping/>
+  </p:clrMapOvr>
+</p:notes>
+</file>
+
+<file path=ppt/notesSlides/notesSlide8.xml><?xml version="1.0" encoding="utf-8"?>
+<p:notes xmlns:a="http://schemas.openxmlformats.org/drawingml/2006/main" xmlns:r="http://schemas.openxmlformats.org/officeDocument/2006/relationships" xmlns:p="http://schemas.openxmlformats.org/presentationml/2006/main">
+  <p:cSld>
+    <p:spTree>
+      <p:nvGrpSpPr>
+        <p:cNvPr id="1" name=""/>
+        <p:cNvGrpSpPr/>
+        <p:nvPr/>
+      </p:nvGrpSpPr>
+      <p:grpSpPr>
+        <a:xfrm>
+          <a:off x="0" y="0"/>
+          <a:ext cx="0" cy="0"/>
+          <a:chOff x="0" y="0"/>
+          <a:chExt cx="0" cy="0"/>
+        </a:xfrm>
+      </p:grpSpPr>
+      <p:sp>
+        <p:nvSpPr>
+          <p:cNvPr id="2" name="Pladsholder til slidebillede 1"/>
+          <p:cNvSpPr>
+            <a:spLocks noGrp="1" noRot="1" noChangeAspect="1"/>
+          </p:cNvSpPr>
+          <p:nvPr>
+            <p:ph type="sldImg"/>
+          </p:nvPr>
+        </p:nvSpPr>
+        <p:spPr/>
+      </p:sp>
+      <p:sp>
+        <p:nvSpPr>
+          <p:cNvPr id="3" name="Pladsholder til noter 2"/>
+          <p:cNvSpPr>
+            <a:spLocks noGrp="1"/>
+          </p:cNvSpPr>
+          <p:nvPr>
+            <p:ph type="body" idx="1"/>
+          </p:nvPr>
+        </p:nvSpPr>
+        <p:spPr/>
+        <p:txBody>
+          <a:bodyPr/>
+          <a:lstStyle/>
+          <a:p>
+            <a:r>
+              <a:rPr lang="da-DK" dirty="0"/>
+              <a:t>I </a:t>
+            </a:r>
+            <a:r>
+              <a:rPr lang="da-DK" dirty="0" err="1"/>
+              <a:t>didn’t</a:t>
+            </a:r>
+            <a:r>
+              <a:rPr lang="da-DK" dirty="0"/>
+              <a:t> </a:t>
+            </a:r>
+            <a:r>
+              <a:rPr lang="da-DK" dirty="0" err="1"/>
+              <a:t>really</a:t>
+            </a:r>
+            <a:r>
+              <a:rPr lang="da-DK" dirty="0"/>
+              <a:t> have time to </a:t>
+            </a:r>
+            <a:r>
+              <a:rPr lang="da-DK" dirty="0" err="1"/>
+              <a:t>seriously</a:t>
+            </a:r>
+            <a:r>
+              <a:rPr lang="da-DK" dirty="0"/>
+              <a:t> </a:t>
+            </a:r>
+            <a:r>
+              <a:rPr lang="da-DK" dirty="0" err="1"/>
+              <a:t>consider</a:t>
+            </a:r>
+            <a:r>
+              <a:rPr lang="da-DK" dirty="0"/>
+              <a:t> </a:t>
+            </a:r>
+            <a:r>
+              <a:rPr lang="da-DK" dirty="0" err="1"/>
+              <a:t>skipping</a:t>
+            </a:r>
+            <a:r>
+              <a:rPr lang="da-DK" dirty="0"/>
+              <a:t> the oven </a:t>
+            </a:r>
+            <a:r>
+              <a:rPr lang="da-DK" dirty="0" err="1"/>
+              <a:t>because</a:t>
+            </a:r>
+            <a:r>
+              <a:rPr lang="da-DK" dirty="0"/>
+              <a:t> of job interview </a:t>
+            </a:r>
+            <a:r>
+              <a:rPr lang="da-DK" dirty="0" err="1"/>
+              <a:t>stuff</a:t>
+            </a:r>
+            <a:r>
+              <a:rPr lang="da-DK" dirty="0"/>
+              <a:t>, so </a:t>
+            </a:r>
+            <a:r>
+              <a:rPr lang="da-DK" dirty="0" err="1"/>
+              <a:t>instead</a:t>
+            </a:r>
+            <a:r>
+              <a:rPr lang="da-DK" dirty="0"/>
+              <a:t> I </a:t>
+            </a:r>
+            <a:r>
+              <a:rPr lang="da-DK" dirty="0" err="1"/>
+              <a:t>worked</a:t>
+            </a:r>
+            <a:r>
+              <a:rPr lang="da-DK" dirty="0"/>
+              <a:t> at it </a:t>
+            </a:r>
+            <a:r>
+              <a:rPr lang="da-DK" dirty="0" err="1"/>
+              <a:t>when</a:t>
+            </a:r>
+            <a:r>
+              <a:rPr lang="da-DK" dirty="0"/>
+              <a:t> I </a:t>
+            </a:r>
+            <a:r>
+              <a:rPr lang="da-DK" dirty="0" err="1"/>
+              <a:t>probably</a:t>
+            </a:r>
+            <a:r>
+              <a:rPr lang="da-DK" dirty="0"/>
+              <a:t> </a:t>
+            </a:r>
+            <a:r>
+              <a:rPr lang="da-DK" dirty="0" err="1"/>
+              <a:t>shouldn’t</a:t>
+            </a:r>
+            <a:r>
+              <a:rPr lang="da-DK" dirty="0"/>
+              <a:t> have or </a:t>
+            </a:r>
+            <a:r>
+              <a:rPr lang="da-DK" dirty="0" err="1"/>
+              <a:t>should’ve</a:t>
+            </a:r>
+            <a:r>
+              <a:rPr lang="da-DK" dirty="0"/>
+              <a:t> </a:t>
+            </a:r>
+            <a:r>
+              <a:rPr lang="da-DK" dirty="0" err="1"/>
+              <a:t>asked</a:t>
+            </a:r>
+            <a:r>
+              <a:rPr lang="da-DK" dirty="0"/>
+              <a:t> for </a:t>
+            </a:r>
+            <a:r>
+              <a:rPr lang="da-DK" dirty="0" err="1"/>
+              <a:t>help</a:t>
+            </a:r>
+            <a:endParaRPr lang="da-DK" dirty="0"/>
+          </a:p>
+        </p:txBody>
+      </p:sp>
+      <p:sp>
+        <p:nvSpPr>
+          <p:cNvPr id="4" name="Pladsholder til slidenummer 3"/>
+          <p:cNvSpPr>
+            <a:spLocks noGrp="1"/>
+          </p:cNvSpPr>
+          <p:nvPr>
+            <p:ph type="sldNum" sz="quarter" idx="5"/>
+          </p:nvPr>
+        </p:nvSpPr>
+        <p:spPr/>
+        <p:txBody>
+          <a:bodyPr/>
+          <a:lstStyle/>
+          <a:p>
+            <a:fld id="{C2B1EF5D-2231-4646-8EED-1BCCADFE16C5}" type="slidenum">
+              <a:rPr lang="da-DK" smtClean="0"/>
+              <a:t>10</a:t>
+            </a:fld>
+            <a:endParaRPr lang="da-DK"/>
+          </a:p>
+        </p:txBody>
+      </p:sp>
+    </p:spTree>
+    <p:extLst>
+      <p:ext uri="{BB962C8B-B14F-4D97-AF65-F5344CB8AC3E}">
+        <p14:creationId xmlns:p14="http://schemas.microsoft.com/office/powerpoint/2010/main" val="2514507924"/>
       </p:ext>
     </p:extLst>
   </p:cSld>
@@ -3406,7 +3868,7 @@
           <a:p>
             <a:fld id="{9F2C61E5-4FB9-4B7B-BFC7-89973F7231D0}" type="datetimeFigureOut">
               <a:rPr lang="da-DK" smtClean="0"/>
-              <a:t>26-03-2026</a:t>
+              <a:t>27-03-2026</a:t>
             </a:fld>
             <a:endParaRPr lang="da-DK"/>
           </a:p>
@@ -3651,7 +4113,7 @@
           <a:p>
             <a:fld id="{9F2C61E5-4FB9-4B7B-BFC7-89973F7231D0}" type="datetimeFigureOut">
               <a:rPr lang="da-DK" smtClean="0"/>
-              <a:t>26-03-2026</a:t>
+              <a:t>27-03-2026</a:t>
             </a:fld>
             <a:endParaRPr lang="da-DK"/>
           </a:p>
@@ -3831,7 +4293,7 @@
           <a:p>
             <a:fld id="{9F2C61E5-4FB9-4B7B-BFC7-89973F7231D0}" type="datetimeFigureOut">
               <a:rPr lang="da-DK" smtClean="0"/>
-              <a:t>26-03-2026</a:t>
+              <a:t>27-03-2026</a:t>
             </a:fld>
             <a:endParaRPr lang="da-DK"/>
           </a:p>
@@ -4001,7 +4463,7 @@
           <a:p>
             <a:fld id="{9F2C61E5-4FB9-4B7B-BFC7-89973F7231D0}" type="datetimeFigureOut">
               <a:rPr lang="da-DK" smtClean="0"/>
-              <a:t>26-03-2026</a:t>
+              <a:t>27-03-2026</a:t>
             </a:fld>
             <a:endParaRPr lang="da-DK"/>
           </a:p>
@@ -4277,7 +4739,7 @@
           <a:p>
             <a:fld id="{9F2C61E5-4FB9-4B7B-BFC7-89973F7231D0}" type="datetimeFigureOut">
               <a:rPr lang="da-DK" smtClean="0"/>
-              <a:t>26-03-2026</a:t>
+              <a:t>27-03-2026</a:t>
             </a:fld>
             <a:endParaRPr lang="da-DK"/>
           </a:p>
@@ -5478,7 +5940,7 @@
           <a:p>
             <a:fld id="{9F2C61E5-4FB9-4B7B-BFC7-89973F7231D0}" type="datetimeFigureOut">
               <a:rPr lang="da-DK" smtClean="0"/>
-              <a:t>26-03-2026</a:t>
+              <a:t>27-03-2026</a:t>
             </a:fld>
             <a:endParaRPr lang="da-DK"/>
           </a:p>
@@ -5868,7 +6330,7 @@
           <a:p>
             <a:fld id="{9F2C61E5-4FB9-4B7B-BFC7-89973F7231D0}" type="datetimeFigureOut">
               <a:rPr lang="da-DK" smtClean="0"/>
-              <a:t>26-03-2026</a:t>
+              <a:t>27-03-2026</a:t>
             </a:fld>
             <a:endParaRPr lang="da-DK"/>
           </a:p>
@@ -5991,7 +6453,7 @@
           <a:p>
             <a:fld id="{9F2C61E5-4FB9-4B7B-BFC7-89973F7231D0}" type="datetimeFigureOut">
               <a:rPr lang="da-DK" smtClean="0"/>
-              <a:t>26-03-2026</a:t>
+              <a:t>27-03-2026</a:t>
             </a:fld>
             <a:endParaRPr lang="da-DK"/>
           </a:p>
@@ -6086,7 +6548,7 @@
           <a:p>
             <a:fld id="{9F2C61E5-4FB9-4B7B-BFC7-89973F7231D0}" type="datetimeFigureOut">
               <a:rPr lang="da-DK" smtClean="0"/>
-              <a:t>26-03-2026</a:t>
+              <a:t>27-03-2026</a:t>
             </a:fld>
             <a:endParaRPr lang="da-DK"/>
           </a:p>
@@ -6849,7 +7311,7 @@
           <a:p>
             <a:fld id="{9F2C61E5-4FB9-4B7B-BFC7-89973F7231D0}" type="datetimeFigureOut">
               <a:rPr lang="da-DK" smtClean="0"/>
-              <a:t>26-03-2026</a:t>
+              <a:t>27-03-2026</a:t>
             </a:fld>
             <a:endParaRPr lang="da-DK"/>
           </a:p>
@@ -7689,7 +8151,7 @@
           <a:p>
             <a:fld id="{9F2C61E5-4FB9-4B7B-BFC7-89973F7231D0}" type="datetimeFigureOut">
               <a:rPr lang="da-DK" smtClean="0"/>
-              <a:t>26-03-2026</a:t>
+              <a:t>27-03-2026</a:t>
             </a:fld>
             <a:endParaRPr lang="da-DK"/>
           </a:p>
@@ -7916,7 +8378,7 @@
           <a:p>
             <a:fld id="{9F2C61E5-4FB9-4B7B-BFC7-89973F7231D0}" type="datetimeFigureOut">
               <a:rPr lang="da-DK" smtClean="0"/>
-              <a:t>26-03-2026</a:t>
+              <a:t>27-03-2026</a:t>
             </a:fld>
             <a:endParaRPr lang="da-DK"/>
           </a:p>
@@ -8954,6 +9416,13 @@
               <a:rPr lang="da-DK" dirty="0" err="1"/>
               <a:t>PizzaSolution</a:t>
             </a:r>
+            <a:br>
+              <a:rPr lang="da-DK" dirty="0"/>
+            </a:br>
+            <a:r>
+              <a:rPr lang="ja-JP" altLang="en-US" sz="4800" dirty="0"/>
+              <a:t>ピザソリューション</a:t>
+            </a:r>
             <a:endParaRPr lang="da-DK" dirty="0"/>
           </a:p>
         </p:txBody>
@@ -9060,7 +9529,12 @@
             <p:ph sz="half" idx="1"/>
           </p:nvPr>
         </p:nvSpPr>
-        <p:spPr/>
+        <p:spPr>
+          <a:xfrm>
+            <a:off x="1257300" y="1452281"/>
+            <a:ext cx="4800600" cy="4797911"/>
+          </a:xfrm>
+        </p:spPr>
         <p:txBody>
           <a:bodyPr/>
           <a:lstStyle/>
@@ -9087,38 +9561,107 @@
               </a:rPr>
               <a:t>Could have studied LINQ some more</a:t>
             </a:r>
-            <a:endParaRPr lang="en-GB" noProof="0" dirty="0"/>
+          </a:p>
+          <a:p>
+            <a:r>
+              <a:rPr lang="en-GB" noProof="0" dirty="0">
+                <a:sym typeface="Wingdings" panose="05000000000000000000" pitchFamily="2" charset="2"/>
+              </a:rPr>
+              <a:t>Working with code m</a:t>
+            </a:r>
+            <a:r>
+              <a:rPr lang="en-GB" dirty="0" err="1">
+                <a:sym typeface="Wingdings" panose="05000000000000000000" pitchFamily="2" charset="2"/>
+              </a:rPr>
+              <a:t>ade</a:t>
+            </a:r>
+            <a:r>
+              <a:rPr lang="en-GB" dirty="0">
+                <a:sym typeface="Wingdings" panose="05000000000000000000" pitchFamily="2" charset="2"/>
+              </a:rPr>
+              <a:t> to be frustrating can be frustrating – but also rewarding</a:t>
+            </a:r>
+          </a:p>
+          <a:p>
+            <a:r>
+              <a:rPr lang="en-GB" dirty="0"/>
+              <a:t>Was good to get back to a debugger – had been a while</a:t>
+            </a:r>
+            <a:endParaRPr lang="en-GB" dirty="0">
+              <a:sym typeface="Wingdings" panose="05000000000000000000" pitchFamily="2" charset="2"/>
+            </a:endParaRPr>
+          </a:p>
+          <a:p>
+            <a:r>
+              <a:rPr lang="en-GB" dirty="0"/>
+              <a:t>Would’ve liked to have gotten to the database and some frontend</a:t>
+            </a:r>
           </a:p>
         </p:txBody>
       </p:sp>
-      <p:sp>
-        <p:nvSpPr>
-          <p:cNvPr id="4" name="Pladsholder til indhold 3">
+      <p:pic>
+        <p:nvPicPr>
+          <p:cNvPr id="6" name="Pladsholder til indhold 5">
             <a:extLst>
               <a:ext uri="{FF2B5EF4-FFF2-40B4-BE49-F238E27FC236}">
-                <a16:creationId xmlns:a16="http://schemas.microsoft.com/office/drawing/2014/main" id="{5C2531A8-AFD4-C0F8-51BC-68177D2CD808}"/>
+                <a16:creationId xmlns:a16="http://schemas.microsoft.com/office/drawing/2014/main" id="{9D68F3D7-30E1-58F0-3504-B0FEA250A5D3}"/>
               </a:ext>
             </a:extLst>
           </p:cNvPr>
-          <p:cNvSpPr>
-            <a:spLocks noGrp="1"/>
-          </p:cNvSpPr>
+          <p:cNvPicPr>
+            <a:picLocks noGrp="1" noChangeAspect="1"/>
+          </p:cNvPicPr>
           <p:nvPr>
             <p:ph sz="half" idx="2"/>
           </p:nvPr>
-        </p:nvSpPr>
-        <p:spPr/>
-        <p:txBody>
-          <a:bodyPr/>
-          <a:lstStyle/>
-          <a:p>
-            <a:r>
-              <a:rPr lang="en-GB" noProof="0" dirty="0"/>
-              <a:t>Would’ve like to get have gotten to the database and some frontend</a:t>
-            </a:r>
-          </a:p>
-        </p:txBody>
-      </p:sp>
+        </p:nvPicPr>
+        <p:blipFill>
+          <a:blip r:embed="rId3"/>
+          <a:srcRect r="14314"/>
+          <a:stretch>
+            <a:fillRect/>
+          </a:stretch>
+        </p:blipFill>
+        <p:spPr>
+          <a:xfrm>
+            <a:off x="6562166" y="3094373"/>
+            <a:ext cx="5515296" cy="3713680"/>
+          </a:xfrm>
+          <a:prstGeom prst="rect">
+            <a:avLst/>
+          </a:prstGeom>
+        </p:spPr>
+      </p:pic>
+      <p:pic>
+        <p:nvPicPr>
+          <p:cNvPr id="8" name="Billede 7">
+            <a:extLst>
+              <a:ext uri="{FF2B5EF4-FFF2-40B4-BE49-F238E27FC236}">
+                <a16:creationId xmlns:a16="http://schemas.microsoft.com/office/drawing/2014/main" id="{3C455580-13A3-6D6B-84FC-7498888220BA}"/>
+              </a:ext>
+            </a:extLst>
+          </p:cNvPr>
+          <p:cNvPicPr>
+            <a:picLocks noChangeAspect="1"/>
+          </p:cNvPicPr>
+          <p:nvPr/>
+        </p:nvPicPr>
+        <p:blipFill>
+          <a:blip r:embed="rId4"/>
+          <a:stretch>
+            <a:fillRect/>
+          </a:stretch>
+        </p:blipFill>
+        <p:spPr>
+          <a:xfrm>
+            <a:off x="7101769" y="46076"/>
+            <a:ext cx="4436090" cy="2994507"/>
+          </a:xfrm>
+          <a:prstGeom prst="rect">
+            <a:avLst/>
+          </a:prstGeom>
+        </p:spPr>
+      </p:pic>
     </p:spTree>
     <p:extLst>
       <p:ext uri="{BB962C8B-B14F-4D97-AF65-F5344CB8AC3E}">
@@ -9274,11 +9817,19 @@
           <a:p>
             <a:r>
               <a:rPr lang="en-DK" noProof="0" dirty="0"/>
-              <a:t>Early problems</a:t>
+              <a:t>Early </a:t>
+            </a:r>
+            <a:r>
+              <a:rPr lang="en-US" dirty="0"/>
+              <a:t>thoughts/</a:t>
+            </a:r>
+            <a:r>
+              <a:rPr lang="en-DK" noProof="0" dirty="0"/>
+              <a:t>problem</a:t>
             </a:r>
             <a:r>
               <a:rPr lang="en-US" noProof="0" dirty="0"/>
-              <a:t>/thoughts</a:t>
+              <a:t>s</a:t>
             </a:r>
             <a:endParaRPr lang="en-DK" noProof="0" dirty="0"/>
           </a:p>
@@ -9447,8 +9998,8 @@
         </p:nvSpPr>
         <p:spPr>
           <a:xfrm>
-            <a:off x="1006839" y="22786"/>
-            <a:ext cx="10178322" cy="1492132"/>
+            <a:off x="1006839" y="55060"/>
+            <a:ext cx="10178322" cy="802891"/>
           </a:xfrm>
         </p:spPr>
         <p:txBody>
@@ -9463,38 +10014,6 @@
           </a:p>
         </p:txBody>
       </p:sp>
-      <p:pic>
-        <p:nvPicPr>
-          <p:cNvPr id="6" name="Pladsholder til indhold 5">
-            <a:extLst>
-              <a:ext uri="{FF2B5EF4-FFF2-40B4-BE49-F238E27FC236}">
-                <a16:creationId xmlns:a16="http://schemas.microsoft.com/office/drawing/2014/main" id="{7960B9B7-D567-F571-3BA5-13B710D0B6F5}"/>
-              </a:ext>
-            </a:extLst>
-          </p:cNvPr>
-          <p:cNvPicPr>
-            <a:picLocks noGrp="1" noChangeAspect="1"/>
-          </p:cNvPicPr>
-          <p:nvPr>
-            <p:ph sz="half" idx="1"/>
-          </p:nvPr>
-        </p:nvPicPr>
-        <p:blipFill>
-          <a:blip r:embed="rId3"/>
-          <a:stretch>
-            <a:fillRect/>
-          </a:stretch>
-        </p:blipFill>
-        <p:spPr>
-          <a:xfrm>
-            <a:off x="168011" y="768852"/>
-            <a:ext cx="6437254" cy="2150678"/>
-          </a:xfrm>
-          <a:prstGeom prst="rect">
-            <a:avLst/>
-          </a:prstGeom>
-        </p:spPr>
-      </p:pic>
       <p:pic>
         <p:nvPicPr>
           <p:cNvPr id="10" name="Pladsholder til indhold 9">
@@ -9512,7 +10031,7 @@
           </p:nvPr>
         </p:nvPicPr>
         <p:blipFill>
-          <a:blip r:embed="rId4"/>
+          <a:blip r:embed="rId3"/>
           <a:stretch>
             <a:fillRect/>
           </a:stretch>
@@ -9542,7 +10061,7 @@
           <p:nvPr/>
         </p:nvPicPr>
         <p:blipFill>
-          <a:blip r:embed="rId5"/>
+          <a:blip r:embed="rId4"/>
           <a:stretch>
             <a:fillRect/>
           </a:stretch>
@@ -9551,6 +10070,38 @@
           <a:xfrm>
             <a:off x="2349223" y="3036489"/>
             <a:ext cx="7493553" cy="3703461"/>
+          </a:xfrm>
+          <a:prstGeom prst="rect">
+            <a:avLst/>
+          </a:prstGeom>
+        </p:spPr>
+      </p:pic>
+      <p:pic>
+        <p:nvPicPr>
+          <p:cNvPr id="11" name="Pladsholder til indhold 10">
+            <a:extLst>
+              <a:ext uri="{FF2B5EF4-FFF2-40B4-BE49-F238E27FC236}">
+                <a16:creationId xmlns:a16="http://schemas.microsoft.com/office/drawing/2014/main" id="{872C4F5D-FBAD-41E8-2A07-51448B42CA6B}"/>
+              </a:ext>
+            </a:extLst>
+          </p:cNvPr>
+          <p:cNvPicPr>
+            <a:picLocks noGrp="1" noChangeAspect="1"/>
+          </p:cNvPicPr>
+          <p:nvPr>
+            <p:ph sz="half" idx="1"/>
+          </p:nvPr>
+        </p:nvPicPr>
+        <p:blipFill>
+          <a:blip r:embed="rId5"/>
+          <a:stretch>
+            <a:fillRect/>
+          </a:stretch>
+        </p:blipFill>
+        <p:spPr>
+          <a:xfrm>
+            <a:off x="673632" y="825676"/>
+            <a:ext cx="5999158" cy="2037027"/>
           </a:xfrm>
           <a:prstGeom prst="rect">
             <a:avLst/>
@@ -9644,31 +10195,6 @@
           </a:prstGeom>
         </p:spPr>
       </p:pic>
-      <p:sp>
-        <p:nvSpPr>
-          <p:cNvPr id="4" name="Pladsholder til indhold 3">
-            <a:extLst>
-              <a:ext uri="{FF2B5EF4-FFF2-40B4-BE49-F238E27FC236}">
-                <a16:creationId xmlns:a16="http://schemas.microsoft.com/office/drawing/2014/main" id="{248C94CB-C527-4CFC-5747-C611C827423C}"/>
-              </a:ext>
-            </a:extLst>
-          </p:cNvPr>
-          <p:cNvSpPr>
-            <a:spLocks noGrp="1"/>
-          </p:cNvSpPr>
-          <p:nvPr>
-            <p:ph sz="half" idx="2"/>
-          </p:nvPr>
-        </p:nvSpPr>
-        <p:spPr/>
-        <p:txBody>
-          <a:bodyPr/>
-          <a:lstStyle/>
-          <a:p>
-            <a:endParaRPr lang="da-DK"/>
-          </a:p>
-        </p:txBody>
-      </p:sp>
     </p:spTree>
     <p:extLst>
       <p:ext uri="{BB962C8B-B14F-4D97-AF65-F5344CB8AC3E}">
@@ -9961,7 +10487,7 @@
         </p:blipFill>
         <p:spPr>
           <a:xfrm>
-            <a:off x="2780207" y="1177962"/>
+            <a:off x="1117955" y="1790271"/>
             <a:ext cx="6631585" cy="3277458"/>
           </a:xfrm>
           <a:prstGeom prst="rect">
@@ -9991,8 +10517,38 @@
         </p:blipFill>
         <p:spPr>
           <a:xfrm>
-            <a:off x="1134885" y="4727053"/>
+            <a:off x="1117955" y="5180460"/>
             <a:ext cx="10411908" cy="1450080"/>
+          </a:xfrm>
+          <a:prstGeom prst="rect">
+            <a:avLst/>
+          </a:prstGeom>
+        </p:spPr>
+      </p:pic>
+      <p:pic>
+        <p:nvPicPr>
+          <p:cNvPr id="3" name="Pladsholder til indhold 5">
+            <a:extLst>
+              <a:ext uri="{FF2B5EF4-FFF2-40B4-BE49-F238E27FC236}">
+                <a16:creationId xmlns:a16="http://schemas.microsoft.com/office/drawing/2014/main" id="{11617E75-1BE1-186A-021C-531D91D88AC1}"/>
+              </a:ext>
+            </a:extLst>
+          </p:cNvPr>
+          <p:cNvPicPr>
+            <a:picLocks noChangeAspect="1"/>
+          </p:cNvPicPr>
+          <p:nvPr/>
+        </p:nvPicPr>
+        <p:blipFill>
+          <a:blip r:embed="rId5"/>
+          <a:stretch>
+            <a:fillRect/>
+          </a:stretch>
+        </p:blipFill>
+        <p:spPr>
+          <a:xfrm>
+            <a:off x="6789699" y="6831"/>
+            <a:ext cx="5402301" cy="1867686"/>
           </a:xfrm>
           <a:prstGeom prst="rect">
             <a:avLst/>
@@ -10030,7 +10586,7 @@
                             </p:stCondLst>
                             <p:childTnLst>
                               <p:par>
-                                <p:cTn id="5" presetID="1" presetClass="entr" presetSubtype="0" fill="hold" nodeType="clickEffect">
+                                <p:cTn id="5" presetID="42" presetClass="entr" presetSubtype="0" fill="hold" nodeType="clickEffect">
                                   <p:stCondLst>
                                     <p:cond delay="0"/>
                                   </p:stCondLst>
@@ -10053,6 +10609,60 @@
                                         <p:strVal val="visible"/>
                                       </p:to>
                                     </p:set>
+                                    <p:animEffect transition="in" filter="fade">
+                                      <p:cBhvr>
+                                        <p:cTn id="7" dur="1000"/>
+                                        <p:tgtEl>
+                                          <p:spTgt spid="5"/>
+                                        </p:tgtEl>
+                                      </p:cBhvr>
+                                    </p:animEffect>
+                                    <p:anim calcmode="lin" valueType="num">
+                                      <p:cBhvr>
+                                        <p:cTn id="8" dur="1000" fill="hold"/>
+                                        <p:tgtEl>
+                                          <p:spTgt spid="5"/>
+                                        </p:tgtEl>
+                                        <p:attrNameLst>
+                                          <p:attrName>ppt_x</p:attrName>
+                                        </p:attrNameLst>
+                                      </p:cBhvr>
+                                      <p:tavLst>
+                                        <p:tav tm="0">
+                                          <p:val>
+                                            <p:strVal val="#ppt_x"/>
+                                          </p:val>
+                                        </p:tav>
+                                        <p:tav tm="100000">
+                                          <p:val>
+                                            <p:strVal val="#ppt_x"/>
+                                          </p:val>
+                                        </p:tav>
+                                      </p:tavLst>
+                                    </p:anim>
+                                    <p:anim calcmode="lin" valueType="num">
+                                      <p:cBhvr>
+                                        <p:cTn id="9" dur="1000" fill="hold"/>
+                                        <p:tgtEl>
+                                          <p:spTgt spid="5"/>
+                                        </p:tgtEl>
+                                        <p:attrNameLst>
+                                          <p:attrName>ppt_y</p:attrName>
+                                        </p:attrNameLst>
+                                      </p:cBhvr>
+                                      <p:tavLst>
+                                        <p:tav tm="0">
+                                          <p:val>
+                                            <p:strVal val="#ppt_y+.1"/>
+                                          </p:val>
+                                        </p:tav>
+                                        <p:tav tm="100000">
+                                          <p:val>
+                                            <p:strVal val="#ppt_y"/>
+                                          </p:val>
+                                        </p:tav>
+                                      </p:tavLst>
+                                    </p:anim>
                                   </p:childTnLst>
                                 </p:cTn>
                               </p:par>
@@ -10063,26 +10673,26 @@
                     </p:cTn>
                   </p:par>
                   <p:par>
-                    <p:cTn id="7" fill="hold">
+                    <p:cTn id="10" fill="hold">
                       <p:stCondLst>
                         <p:cond delay="indefinite"/>
                       </p:stCondLst>
                       <p:childTnLst>
                         <p:par>
-                          <p:cTn id="8" fill="hold">
+                          <p:cTn id="11" fill="hold">
                             <p:stCondLst>
                               <p:cond delay="0"/>
                             </p:stCondLst>
                             <p:childTnLst>
                               <p:par>
-                                <p:cTn id="9" presetID="2" presetClass="entr" presetSubtype="8" fill="hold" nodeType="clickEffect">
+                                <p:cTn id="12" presetID="2" presetClass="entr" presetSubtype="8" fill="hold" nodeType="clickEffect">
                                   <p:stCondLst>
                                     <p:cond delay="0"/>
                                   </p:stCondLst>
                                   <p:childTnLst>
                                     <p:set>
                                       <p:cBhvr>
-                                        <p:cTn id="10" dur="1" fill="hold">
+                                        <p:cTn id="13" dur="1" fill="hold">
                                           <p:stCondLst>
                                             <p:cond delay="0"/>
                                           </p:stCondLst>
@@ -10100,7 +10710,7 @@
                                     </p:set>
                                     <p:anim calcmode="lin" valueType="num">
                                       <p:cBhvr additive="base">
-                                        <p:cTn id="11" dur="500" fill="hold"/>
+                                        <p:cTn id="14" dur="500" fill="hold"/>
                                         <p:tgtEl>
                                           <p:spTgt spid="7"/>
                                         </p:tgtEl>
@@ -10123,7 +10733,7 @@
                                     </p:anim>
                                     <p:anim calcmode="lin" valueType="num">
                                       <p:cBhvr additive="base">
-                                        <p:cTn id="12" dur="500" fill="hold"/>
+                                        <p:cTn id="15" dur="500" fill="hold"/>
                                         <p:tgtEl>
                                           <p:spTgt spid="7"/>
                                         </p:tgtEl>
@@ -10308,7 +10918,7 @@
             <a:pPr lvl="1"/>
             <a:r>
               <a:rPr lang="en-GB" dirty="0"/>
-              <a:t>Feels like I definitely can get rid of that while-loop somehow</a:t>
+              <a:t>Also feel like I definitely can get rid of that while-loop</a:t>
             </a:r>
             <a:endParaRPr lang="en-GB" noProof="0" dirty="0"/>
           </a:p>
@@ -10397,8 +11007,8 @@
           </p:nvPr>
         </p:nvSpPr>
         <p:spPr>
-          <a:xfrm rot="20344839">
-            <a:off x="1824319" y="5017375"/>
+          <a:xfrm rot="21375383">
+            <a:off x="5935088" y="5043434"/>
             <a:ext cx="7017488" cy="951135"/>
           </a:xfrm>
         </p:spPr>
@@ -10408,7 +11018,7 @@
           <a:p>
             <a:r>
               <a:rPr lang="en-US" noProof="0" dirty="0"/>
-              <a:t>Give last element cooking time?</a:t>
+              <a:t>Make it wait for entire batch before proceeding?</a:t>
             </a:r>
           </a:p>
         </p:txBody>
@@ -10429,7 +11039,7 @@
         </p:nvSpPr>
         <p:spPr>
           <a:xfrm rot="494728">
-            <a:off x="5359042" y="3492059"/>
+            <a:off x="5359041" y="3188733"/>
             <a:ext cx="8169581" cy="951135"/>
           </a:xfrm>
           <a:prstGeom prst="rect">
@@ -10671,7 +11281,7 @@
         </p:nvSpPr>
         <p:spPr>
           <a:xfrm rot="20931083">
-            <a:off x="2952016" y="2245578"/>
+            <a:off x="2952015" y="1815316"/>
             <a:ext cx="7017488" cy="504002"/>
           </a:xfrm>
           <a:prstGeom prst="rect">
@@ -10913,8 +11523,8 @@
         </p:nvSpPr>
         <p:spPr>
           <a:xfrm rot="231659">
-            <a:off x="4664496" y="1096335"/>
-            <a:ext cx="8169581" cy="951135"/>
+            <a:off x="5828365" y="969102"/>
+            <a:ext cx="7177582" cy="951135"/>
           </a:xfrm>
           <a:prstGeom prst="rect">
             <a:avLst/>
@@ -11397,7 +12007,7 @@
         </p:nvSpPr>
         <p:spPr>
           <a:xfrm rot="183458">
-            <a:off x="8431965" y="5984980"/>
+            <a:off x="8573266" y="6137381"/>
             <a:ext cx="4643027" cy="504002"/>
           </a:xfrm>
           <a:prstGeom prst="rect">
@@ -11623,6 +12233,248 @@
           </a:p>
         </p:txBody>
       </p:sp>
+      <p:sp>
+        <p:nvSpPr>
+          <p:cNvPr id="2" name="Pladsholder til tekst 2">
+            <a:extLst>
+              <a:ext uri="{FF2B5EF4-FFF2-40B4-BE49-F238E27FC236}">
+                <a16:creationId xmlns:a16="http://schemas.microsoft.com/office/drawing/2014/main" id="{A42F2352-6AB6-1B9A-35DD-421CDFB60C4C}"/>
+              </a:ext>
+            </a:extLst>
+          </p:cNvPr>
+          <p:cNvSpPr txBox="1">
+            <a:spLocks/>
+          </p:cNvSpPr>
+          <p:nvPr/>
+        </p:nvSpPr>
+        <p:spPr>
+          <a:xfrm rot="20651068">
+            <a:off x="2295743" y="4723767"/>
+            <a:ext cx="7017488" cy="606747"/>
+          </a:xfrm>
+          <a:prstGeom prst="rect">
+            <a:avLst/>
+          </a:prstGeom>
+        </p:spPr>
+        <p:txBody>
+          <a:bodyPr vert="horz" lIns="91440" tIns="45720" rIns="91440" bIns="45720" rtlCol="0">
+            <a:normAutofit/>
+          </a:bodyPr>
+          <a:lstStyle>
+            <a:lvl1pPr marL="0" indent="0" algn="l" defTabSz="914400" rtl="0" eaLnBrk="1" latinLnBrk="0" hangingPunct="1">
+              <a:lnSpc>
+                <a:spcPct val="100000"/>
+              </a:lnSpc>
+              <a:spcBef>
+                <a:spcPts val="700"/>
+              </a:spcBef>
+              <a:buClr>
+                <a:schemeClr val="tx2"/>
+              </a:buClr>
+              <a:buFont typeface="Arial" panose="020B0604020202020204" pitchFamily="34" charset="0"/>
+              <a:buNone/>
+              <a:defRPr sz="2000" b="1" i="0" kern="1200" cap="all" spc="400" baseline="0">
+                <a:solidFill>
+                  <a:schemeClr val="accent1"/>
+                </a:solidFill>
+                <a:latin typeface="+mn-lt"/>
+                <a:ea typeface="+mn-ea"/>
+                <a:cs typeface="+mn-cs"/>
+              </a:defRPr>
+            </a:lvl1pPr>
+            <a:lvl2pPr marL="457200" indent="0" algn="l" defTabSz="914400" rtl="0" eaLnBrk="1" latinLnBrk="0" hangingPunct="1">
+              <a:lnSpc>
+                <a:spcPct val="110000"/>
+              </a:lnSpc>
+              <a:spcBef>
+                <a:spcPts val="700"/>
+              </a:spcBef>
+              <a:buClr>
+                <a:schemeClr val="tx2"/>
+              </a:buClr>
+              <a:buFont typeface="Gill Sans MT" panose="020B0502020104020203" pitchFamily="34" charset="0"/>
+              <a:buNone/>
+              <a:defRPr sz="2000" kern="1200">
+                <a:solidFill>
+                  <a:schemeClr val="tx1">
+                    <a:tint val="75000"/>
+                  </a:schemeClr>
+                </a:solidFill>
+                <a:latin typeface="+mn-lt"/>
+                <a:ea typeface="+mn-ea"/>
+                <a:cs typeface="+mn-cs"/>
+              </a:defRPr>
+            </a:lvl2pPr>
+            <a:lvl3pPr marL="914400" indent="0" algn="l" defTabSz="914400" rtl="0" eaLnBrk="1" latinLnBrk="0" hangingPunct="1">
+              <a:lnSpc>
+                <a:spcPct val="110000"/>
+              </a:lnSpc>
+              <a:spcBef>
+                <a:spcPts val="700"/>
+              </a:spcBef>
+              <a:buClr>
+                <a:schemeClr val="tx2"/>
+              </a:buClr>
+              <a:buFont typeface="Arial" panose="020B0604020202020204" pitchFamily="34" charset="0"/>
+              <a:buNone/>
+              <a:defRPr sz="1800" kern="1200">
+                <a:solidFill>
+                  <a:schemeClr val="tx1">
+                    <a:tint val="75000"/>
+                  </a:schemeClr>
+                </a:solidFill>
+                <a:latin typeface="+mn-lt"/>
+                <a:ea typeface="+mn-ea"/>
+                <a:cs typeface="+mn-cs"/>
+              </a:defRPr>
+            </a:lvl3pPr>
+            <a:lvl4pPr marL="1371600" indent="0" algn="l" defTabSz="914400" rtl="0" eaLnBrk="1" latinLnBrk="0" hangingPunct="1">
+              <a:lnSpc>
+                <a:spcPct val="110000"/>
+              </a:lnSpc>
+              <a:spcBef>
+                <a:spcPts val="700"/>
+              </a:spcBef>
+              <a:buClr>
+                <a:schemeClr val="tx2"/>
+              </a:buClr>
+              <a:buFont typeface="Gill Sans MT" panose="020B0502020104020203" pitchFamily="34" charset="0"/>
+              <a:buNone/>
+              <a:defRPr sz="1600" kern="1200">
+                <a:solidFill>
+                  <a:schemeClr val="tx1">
+                    <a:tint val="75000"/>
+                  </a:schemeClr>
+                </a:solidFill>
+                <a:latin typeface="+mn-lt"/>
+                <a:ea typeface="+mn-ea"/>
+                <a:cs typeface="+mn-cs"/>
+              </a:defRPr>
+            </a:lvl4pPr>
+            <a:lvl5pPr marL="1828800" indent="0" algn="l" defTabSz="914400" rtl="0" eaLnBrk="1" latinLnBrk="0" hangingPunct="1">
+              <a:lnSpc>
+                <a:spcPct val="110000"/>
+              </a:lnSpc>
+              <a:spcBef>
+                <a:spcPts val="700"/>
+              </a:spcBef>
+              <a:buClr>
+                <a:schemeClr val="tx2"/>
+              </a:buClr>
+              <a:buFont typeface="Arial" panose="020B0604020202020204" pitchFamily="34" charset="0"/>
+              <a:buNone/>
+              <a:defRPr sz="1600" kern="1200">
+                <a:solidFill>
+                  <a:schemeClr val="tx1">
+                    <a:tint val="75000"/>
+                  </a:schemeClr>
+                </a:solidFill>
+                <a:latin typeface="+mn-lt"/>
+                <a:ea typeface="+mn-ea"/>
+                <a:cs typeface="+mn-cs"/>
+              </a:defRPr>
+            </a:lvl5pPr>
+            <a:lvl6pPr marL="2286000" indent="0" algn="l" defTabSz="914400" rtl="0" eaLnBrk="1" latinLnBrk="0" hangingPunct="1">
+              <a:lnSpc>
+                <a:spcPct val="110000"/>
+              </a:lnSpc>
+              <a:spcBef>
+                <a:spcPts val="700"/>
+              </a:spcBef>
+              <a:buClr>
+                <a:schemeClr val="tx2"/>
+              </a:buClr>
+              <a:buFont typeface="Gill Sans MT" panose="020B0502020104020203" pitchFamily="34" charset="0"/>
+              <a:buNone/>
+              <a:defRPr sz="1600" kern="1200">
+                <a:solidFill>
+                  <a:schemeClr val="tx1">
+                    <a:tint val="75000"/>
+                  </a:schemeClr>
+                </a:solidFill>
+                <a:latin typeface="+mn-lt"/>
+                <a:ea typeface="+mn-ea"/>
+                <a:cs typeface="+mn-cs"/>
+              </a:defRPr>
+            </a:lvl6pPr>
+            <a:lvl7pPr marL="2743200" indent="0" algn="l" defTabSz="914400" rtl="0" eaLnBrk="1" latinLnBrk="0" hangingPunct="1">
+              <a:lnSpc>
+                <a:spcPct val="110000"/>
+              </a:lnSpc>
+              <a:spcBef>
+                <a:spcPts val="700"/>
+              </a:spcBef>
+              <a:buClr>
+                <a:schemeClr val="tx2"/>
+              </a:buClr>
+              <a:buFont typeface="Arial" panose="020B0604020202020204" pitchFamily="34" charset="0"/>
+              <a:buNone/>
+              <a:defRPr sz="1600" kern="1200">
+                <a:solidFill>
+                  <a:schemeClr val="tx1">
+                    <a:tint val="75000"/>
+                  </a:schemeClr>
+                </a:solidFill>
+                <a:latin typeface="+mn-lt"/>
+                <a:ea typeface="+mn-ea"/>
+                <a:cs typeface="+mn-cs"/>
+              </a:defRPr>
+            </a:lvl7pPr>
+            <a:lvl8pPr marL="3200400" indent="0" algn="l" defTabSz="914400" rtl="0" eaLnBrk="1" latinLnBrk="0" hangingPunct="1">
+              <a:lnSpc>
+                <a:spcPct val="110000"/>
+              </a:lnSpc>
+              <a:spcBef>
+                <a:spcPts val="700"/>
+              </a:spcBef>
+              <a:buClr>
+                <a:schemeClr val="tx2"/>
+              </a:buClr>
+              <a:buFont typeface="Gill Sans MT" panose="020B0502020104020203" pitchFamily="34" charset="0"/>
+              <a:buNone/>
+              <a:defRPr sz="1600" kern="1200" baseline="0">
+                <a:solidFill>
+                  <a:schemeClr val="tx1">
+                    <a:tint val="75000"/>
+                  </a:schemeClr>
+                </a:solidFill>
+                <a:latin typeface="+mn-lt"/>
+                <a:ea typeface="+mn-ea"/>
+                <a:cs typeface="+mn-cs"/>
+              </a:defRPr>
+            </a:lvl8pPr>
+            <a:lvl9pPr marL="3657600" indent="0" algn="l" defTabSz="914400" rtl="0" eaLnBrk="1" latinLnBrk="0" hangingPunct="1">
+              <a:lnSpc>
+                <a:spcPct val="110000"/>
+              </a:lnSpc>
+              <a:spcBef>
+                <a:spcPts val="700"/>
+              </a:spcBef>
+              <a:buClr>
+                <a:schemeClr val="tx2"/>
+              </a:buClr>
+              <a:buFont typeface="Arial" panose="020B0604020202020204" pitchFamily="34" charset="0"/>
+              <a:buNone/>
+              <a:defRPr sz="1600" kern="1200" baseline="0">
+                <a:solidFill>
+                  <a:schemeClr val="tx1">
+                    <a:tint val="75000"/>
+                  </a:schemeClr>
+                </a:solidFill>
+                <a:latin typeface="+mn-lt"/>
+                <a:ea typeface="+mn-ea"/>
+                <a:cs typeface="+mn-cs"/>
+              </a:defRPr>
+            </a:lvl9pPr>
+          </a:lstStyle>
+          <a:p>
+            <a:r>
+              <a:rPr lang="en-US" dirty="0"/>
+              <a:t>Give last element cooking time?</a:t>
+            </a:r>
+          </a:p>
+        </p:txBody>
+      </p:sp>
     </p:spTree>
     <p:extLst>
       <p:ext uri="{BB962C8B-B14F-4D97-AF65-F5344CB8AC3E}">
@@ -11633,6 +12485,862 @@
   <p:clrMapOvr>
     <a:masterClrMapping/>
   </p:clrMapOvr>
+  <p:timing>
+    <p:tnLst>
+      <p:par>
+        <p:cTn id="1" dur="indefinite" restart="never" nodeType="tmRoot">
+          <p:childTnLst>
+            <p:seq concurrent="1" nextAc="seek">
+              <p:cTn id="2" dur="indefinite" nodeType="mainSeq">
+                <p:childTnLst>
+                  <p:par>
+                    <p:cTn id="3" fill="hold">
+                      <p:stCondLst>
+                        <p:cond delay="indefinite"/>
+                      </p:stCondLst>
+                      <p:childTnLst>
+                        <p:par>
+                          <p:cTn id="4" fill="hold">
+                            <p:stCondLst>
+                              <p:cond delay="0"/>
+                            </p:stCondLst>
+                            <p:childTnLst>
+                              <p:par>
+                                <p:cTn id="5" presetID="35" presetClass="entr" presetSubtype="0" fill="hold" grpId="0" nodeType="clickEffect">
+                                  <p:stCondLst>
+                                    <p:cond delay="0"/>
+                                  </p:stCondLst>
+                                  <p:childTnLst>
+                                    <p:set>
+                                      <p:cBhvr>
+                                        <p:cTn id="6" dur="1" fill="hold">
+                                          <p:stCondLst>
+                                            <p:cond delay="0"/>
+                                          </p:stCondLst>
+                                        </p:cTn>
+                                        <p:tgtEl>
+                                          <p:spTgt spid="7"/>
+                                        </p:tgtEl>
+                                        <p:attrNameLst>
+                                          <p:attrName>style.visibility</p:attrName>
+                                        </p:attrNameLst>
+                                      </p:cBhvr>
+                                      <p:to>
+                                        <p:strVal val="visible"/>
+                                      </p:to>
+                                    </p:set>
+                                    <p:animEffect transition="in" filter="fade">
+                                      <p:cBhvr>
+                                        <p:cTn id="7" dur="2000"/>
+                                        <p:tgtEl>
+                                          <p:spTgt spid="7"/>
+                                        </p:tgtEl>
+                                      </p:cBhvr>
+                                    </p:animEffect>
+                                    <p:anim calcmode="lin" valueType="num">
+                                      <p:cBhvr>
+                                        <p:cTn id="8" dur="2000" fill="hold"/>
+                                        <p:tgtEl>
+                                          <p:spTgt spid="7"/>
+                                        </p:tgtEl>
+                                        <p:attrNameLst>
+                                          <p:attrName>style.rotation</p:attrName>
+                                        </p:attrNameLst>
+                                      </p:cBhvr>
+                                      <p:tavLst>
+                                        <p:tav tm="0">
+                                          <p:val>
+                                            <p:fltVal val="720"/>
+                                          </p:val>
+                                        </p:tav>
+                                        <p:tav tm="100000">
+                                          <p:val>
+                                            <p:fltVal val="0"/>
+                                          </p:val>
+                                        </p:tav>
+                                      </p:tavLst>
+                                    </p:anim>
+                                    <p:anim calcmode="lin" valueType="num">
+                                      <p:cBhvr>
+                                        <p:cTn id="9" dur="2000" fill="hold"/>
+                                        <p:tgtEl>
+                                          <p:spTgt spid="7"/>
+                                        </p:tgtEl>
+                                        <p:attrNameLst>
+                                          <p:attrName>ppt_h</p:attrName>
+                                        </p:attrNameLst>
+                                      </p:cBhvr>
+                                      <p:tavLst>
+                                        <p:tav tm="0">
+                                          <p:val>
+                                            <p:fltVal val="0"/>
+                                          </p:val>
+                                        </p:tav>
+                                        <p:tav tm="100000">
+                                          <p:val>
+                                            <p:strVal val="#ppt_h"/>
+                                          </p:val>
+                                        </p:tav>
+                                      </p:tavLst>
+                                    </p:anim>
+                                    <p:anim calcmode="lin" valueType="num">
+                                      <p:cBhvr>
+                                        <p:cTn id="10" dur="2000" fill="hold"/>
+                                        <p:tgtEl>
+                                          <p:spTgt spid="7"/>
+                                        </p:tgtEl>
+                                        <p:attrNameLst>
+                                          <p:attrName>ppt_w</p:attrName>
+                                        </p:attrNameLst>
+                                      </p:cBhvr>
+                                      <p:tavLst>
+                                        <p:tav tm="0">
+                                          <p:val>
+                                            <p:fltVal val="0"/>
+                                          </p:val>
+                                        </p:tav>
+                                        <p:tav tm="100000">
+                                          <p:val>
+                                            <p:strVal val="#ppt_w"/>
+                                          </p:val>
+                                        </p:tav>
+                                      </p:tavLst>
+                                    </p:anim>
+                                  </p:childTnLst>
+                                </p:cTn>
+                              </p:par>
+                            </p:childTnLst>
+                          </p:cTn>
+                        </p:par>
+                        <p:par>
+                          <p:cTn id="11" fill="hold">
+                            <p:stCondLst>
+                              <p:cond delay="2000"/>
+                            </p:stCondLst>
+                            <p:childTnLst>
+                              <p:par>
+                                <p:cTn id="12" presetID="35" presetClass="entr" presetSubtype="0" fill="hold" grpId="0" nodeType="afterEffect">
+                                  <p:stCondLst>
+                                    <p:cond delay="0"/>
+                                  </p:stCondLst>
+                                  <p:childTnLst>
+                                    <p:set>
+                                      <p:cBhvr>
+                                        <p:cTn id="13" dur="1" fill="hold">
+                                          <p:stCondLst>
+                                            <p:cond delay="0"/>
+                                          </p:stCondLst>
+                                        </p:cTn>
+                                        <p:tgtEl>
+                                          <p:spTgt spid="6"/>
+                                        </p:tgtEl>
+                                        <p:attrNameLst>
+                                          <p:attrName>style.visibility</p:attrName>
+                                        </p:attrNameLst>
+                                      </p:cBhvr>
+                                      <p:to>
+                                        <p:strVal val="visible"/>
+                                      </p:to>
+                                    </p:set>
+                                    <p:animEffect transition="in" filter="fade">
+                                      <p:cBhvr>
+                                        <p:cTn id="14" dur="2000"/>
+                                        <p:tgtEl>
+                                          <p:spTgt spid="6"/>
+                                        </p:tgtEl>
+                                      </p:cBhvr>
+                                    </p:animEffect>
+                                    <p:anim calcmode="lin" valueType="num">
+                                      <p:cBhvr>
+                                        <p:cTn id="15" dur="2000" fill="hold"/>
+                                        <p:tgtEl>
+                                          <p:spTgt spid="6"/>
+                                        </p:tgtEl>
+                                        <p:attrNameLst>
+                                          <p:attrName>style.rotation</p:attrName>
+                                        </p:attrNameLst>
+                                      </p:cBhvr>
+                                      <p:tavLst>
+                                        <p:tav tm="0">
+                                          <p:val>
+                                            <p:fltVal val="720"/>
+                                          </p:val>
+                                        </p:tav>
+                                        <p:tav tm="100000">
+                                          <p:val>
+                                            <p:fltVal val="0"/>
+                                          </p:val>
+                                        </p:tav>
+                                      </p:tavLst>
+                                    </p:anim>
+                                    <p:anim calcmode="lin" valueType="num">
+                                      <p:cBhvr>
+                                        <p:cTn id="16" dur="2000" fill="hold"/>
+                                        <p:tgtEl>
+                                          <p:spTgt spid="6"/>
+                                        </p:tgtEl>
+                                        <p:attrNameLst>
+                                          <p:attrName>ppt_h</p:attrName>
+                                        </p:attrNameLst>
+                                      </p:cBhvr>
+                                      <p:tavLst>
+                                        <p:tav tm="0">
+                                          <p:val>
+                                            <p:fltVal val="0"/>
+                                          </p:val>
+                                        </p:tav>
+                                        <p:tav tm="100000">
+                                          <p:val>
+                                            <p:strVal val="#ppt_h"/>
+                                          </p:val>
+                                        </p:tav>
+                                      </p:tavLst>
+                                    </p:anim>
+                                    <p:anim calcmode="lin" valueType="num">
+                                      <p:cBhvr>
+                                        <p:cTn id="17" dur="2000" fill="hold"/>
+                                        <p:tgtEl>
+                                          <p:spTgt spid="6"/>
+                                        </p:tgtEl>
+                                        <p:attrNameLst>
+                                          <p:attrName>ppt_w</p:attrName>
+                                        </p:attrNameLst>
+                                      </p:cBhvr>
+                                      <p:tavLst>
+                                        <p:tav tm="0">
+                                          <p:val>
+                                            <p:fltVal val="0"/>
+                                          </p:val>
+                                        </p:tav>
+                                        <p:tav tm="100000">
+                                          <p:val>
+                                            <p:strVal val="#ppt_w"/>
+                                          </p:val>
+                                        </p:tav>
+                                      </p:tavLst>
+                                    </p:anim>
+                                  </p:childTnLst>
+                                </p:cTn>
+                              </p:par>
+                            </p:childTnLst>
+                          </p:cTn>
+                        </p:par>
+                        <p:par>
+                          <p:cTn id="18" fill="hold">
+                            <p:stCondLst>
+                              <p:cond delay="4000"/>
+                            </p:stCondLst>
+                            <p:childTnLst>
+                              <p:par>
+                                <p:cTn id="19" presetID="35" presetClass="entr" presetSubtype="0" fill="hold" grpId="0" nodeType="afterEffect">
+                                  <p:stCondLst>
+                                    <p:cond delay="0"/>
+                                  </p:stCondLst>
+                                  <p:childTnLst>
+                                    <p:set>
+                                      <p:cBhvr>
+                                        <p:cTn id="20" dur="1" fill="hold">
+                                          <p:stCondLst>
+                                            <p:cond delay="0"/>
+                                          </p:stCondLst>
+                                        </p:cTn>
+                                        <p:tgtEl>
+                                          <p:spTgt spid="5"/>
+                                        </p:tgtEl>
+                                        <p:attrNameLst>
+                                          <p:attrName>style.visibility</p:attrName>
+                                        </p:attrNameLst>
+                                      </p:cBhvr>
+                                      <p:to>
+                                        <p:strVal val="visible"/>
+                                      </p:to>
+                                    </p:set>
+                                    <p:animEffect transition="in" filter="fade">
+                                      <p:cBhvr>
+                                        <p:cTn id="21" dur="2000"/>
+                                        <p:tgtEl>
+                                          <p:spTgt spid="5"/>
+                                        </p:tgtEl>
+                                      </p:cBhvr>
+                                    </p:animEffect>
+                                    <p:anim calcmode="lin" valueType="num">
+                                      <p:cBhvr>
+                                        <p:cTn id="22" dur="2000" fill="hold"/>
+                                        <p:tgtEl>
+                                          <p:spTgt spid="5"/>
+                                        </p:tgtEl>
+                                        <p:attrNameLst>
+                                          <p:attrName>style.rotation</p:attrName>
+                                        </p:attrNameLst>
+                                      </p:cBhvr>
+                                      <p:tavLst>
+                                        <p:tav tm="0">
+                                          <p:val>
+                                            <p:fltVal val="720"/>
+                                          </p:val>
+                                        </p:tav>
+                                        <p:tav tm="100000">
+                                          <p:val>
+                                            <p:fltVal val="0"/>
+                                          </p:val>
+                                        </p:tav>
+                                      </p:tavLst>
+                                    </p:anim>
+                                    <p:anim calcmode="lin" valueType="num">
+                                      <p:cBhvr>
+                                        <p:cTn id="23" dur="2000" fill="hold"/>
+                                        <p:tgtEl>
+                                          <p:spTgt spid="5"/>
+                                        </p:tgtEl>
+                                        <p:attrNameLst>
+                                          <p:attrName>ppt_h</p:attrName>
+                                        </p:attrNameLst>
+                                      </p:cBhvr>
+                                      <p:tavLst>
+                                        <p:tav tm="0">
+                                          <p:val>
+                                            <p:fltVal val="0"/>
+                                          </p:val>
+                                        </p:tav>
+                                        <p:tav tm="100000">
+                                          <p:val>
+                                            <p:strVal val="#ppt_h"/>
+                                          </p:val>
+                                        </p:tav>
+                                      </p:tavLst>
+                                    </p:anim>
+                                    <p:anim calcmode="lin" valueType="num">
+                                      <p:cBhvr>
+                                        <p:cTn id="24" dur="2000" fill="hold"/>
+                                        <p:tgtEl>
+                                          <p:spTgt spid="5"/>
+                                        </p:tgtEl>
+                                        <p:attrNameLst>
+                                          <p:attrName>ppt_w</p:attrName>
+                                        </p:attrNameLst>
+                                      </p:cBhvr>
+                                      <p:tavLst>
+                                        <p:tav tm="0">
+                                          <p:val>
+                                            <p:fltVal val="0"/>
+                                          </p:val>
+                                        </p:tav>
+                                        <p:tav tm="100000">
+                                          <p:val>
+                                            <p:strVal val="#ppt_w"/>
+                                          </p:val>
+                                        </p:tav>
+                                      </p:tavLst>
+                                    </p:anim>
+                                  </p:childTnLst>
+                                </p:cTn>
+                              </p:par>
+                            </p:childTnLst>
+                          </p:cTn>
+                        </p:par>
+                        <p:par>
+                          <p:cTn id="25" fill="hold">
+                            <p:stCondLst>
+                              <p:cond delay="6000"/>
+                            </p:stCondLst>
+                            <p:childTnLst>
+                              <p:par>
+                                <p:cTn id="26" presetID="35" presetClass="entr" presetSubtype="0" fill="hold" grpId="0" nodeType="afterEffect">
+                                  <p:stCondLst>
+                                    <p:cond delay="0"/>
+                                  </p:stCondLst>
+                                  <p:childTnLst>
+                                    <p:set>
+                                      <p:cBhvr>
+                                        <p:cTn id="27" dur="1" fill="hold">
+                                          <p:stCondLst>
+                                            <p:cond delay="0"/>
+                                          </p:stCondLst>
+                                        </p:cTn>
+                                        <p:tgtEl>
+                                          <p:spTgt spid="4">
+                                            <p:txEl>
+                                              <p:pRg st="0" end="0"/>
+                                            </p:txEl>
+                                          </p:spTgt>
+                                        </p:tgtEl>
+                                        <p:attrNameLst>
+                                          <p:attrName>style.visibility</p:attrName>
+                                        </p:attrNameLst>
+                                      </p:cBhvr>
+                                      <p:to>
+                                        <p:strVal val="visible"/>
+                                      </p:to>
+                                    </p:set>
+                                    <p:animEffect transition="in" filter="fade">
+                                      <p:cBhvr>
+                                        <p:cTn id="28" dur="2000"/>
+                                        <p:tgtEl>
+                                          <p:spTgt spid="4">
+                                            <p:txEl>
+                                              <p:pRg st="0" end="0"/>
+                                            </p:txEl>
+                                          </p:spTgt>
+                                        </p:tgtEl>
+                                      </p:cBhvr>
+                                    </p:animEffect>
+                                    <p:anim calcmode="lin" valueType="num">
+                                      <p:cBhvr>
+                                        <p:cTn id="29" dur="2000" fill="hold"/>
+                                        <p:tgtEl>
+                                          <p:spTgt spid="4">
+                                            <p:txEl>
+                                              <p:pRg st="0" end="0"/>
+                                            </p:txEl>
+                                          </p:spTgt>
+                                        </p:tgtEl>
+                                        <p:attrNameLst>
+                                          <p:attrName>style.rotation</p:attrName>
+                                        </p:attrNameLst>
+                                      </p:cBhvr>
+                                      <p:tavLst>
+                                        <p:tav tm="0">
+                                          <p:val>
+                                            <p:fltVal val="720"/>
+                                          </p:val>
+                                        </p:tav>
+                                        <p:tav tm="100000">
+                                          <p:val>
+                                            <p:fltVal val="0"/>
+                                          </p:val>
+                                        </p:tav>
+                                      </p:tavLst>
+                                    </p:anim>
+                                    <p:anim calcmode="lin" valueType="num">
+                                      <p:cBhvr>
+                                        <p:cTn id="30" dur="2000" fill="hold"/>
+                                        <p:tgtEl>
+                                          <p:spTgt spid="4">
+                                            <p:txEl>
+                                              <p:pRg st="0" end="0"/>
+                                            </p:txEl>
+                                          </p:spTgt>
+                                        </p:tgtEl>
+                                        <p:attrNameLst>
+                                          <p:attrName>ppt_h</p:attrName>
+                                        </p:attrNameLst>
+                                      </p:cBhvr>
+                                      <p:tavLst>
+                                        <p:tav tm="0">
+                                          <p:val>
+                                            <p:fltVal val="0"/>
+                                          </p:val>
+                                        </p:tav>
+                                        <p:tav tm="100000">
+                                          <p:val>
+                                            <p:strVal val="#ppt_h"/>
+                                          </p:val>
+                                        </p:tav>
+                                      </p:tavLst>
+                                    </p:anim>
+                                    <p:anim calcmode="lin" valueType="num">
+                                      <p:cBhvr>
+                                        <p:cTn id="31" dur="2000" fill="hold"/>
+                                        <p:tgtEl>
+                                          <p:spTgt spid="4">
+                                            <p:txEl>
+                                              <p:pRg st="0" end="0"/>
+                                            </p:txEl>
+                                          </p:spTgt>
+                                        </p:tgtEl>
+                                        <p:attrNameLst>
+                                          <p:attrName>ppt_w</p:attrName>
+                                        </p:attrNameLst>
+                                      </p:cBhvr>
+                                      <p:tavLst>
+                                        <p:tav tm="0">
+                                          <p:val>
+                                            <p:fltVal val="0"/>
+                                          </p:val>
+                                        </p:tav>
+                                        <p:tav tm="100000">
+                                          <p:val>
+                                            <p:strVal val="#ppt_w"/>
+                                          </p:val>
+                                        </p:tav>
+                                      </p:tavLst>
+                                    </p:anim>
+                                  </p:childTnLst>
+                                </p:cTn>
+                              </p:par>
+                            </p:childTnLst>
+                          </p:cTn>
+                        </p:par>
+                        <p:par>
+                          <p:cTn id="32" fill="hold">
+                            <p:stCondLst>
+                              <p:cond delay="8000"/>
+                            </p:stCondLst>
+                            <p:childTnLst>
+                              <p:par>
+                                <p:cTn id="33" presetID="35" presetClass="entr" presetSubtype="0" fill="hold" grpId="0" nodeType="afterEffect">
+                                  <p:stCondLst>
+                                    <p:cond delay="0"/>
+                                  </p:stCondLst>
+                                  <p:childTnLst>
+                                    <p:set>
+                                      <p:cBhvr>
+                                        <p:cTn id="34" dur="1" fill="hold">
+                                          <p:stCondLst>
+                                            <p:cond delay="0"/>
+                                          </p:stCondLst>
+                                        </p:cTn>
+                                        <p:tgtEl>
+                                          <p:spTgt spid="2"/>
+                                        </p:tgtEl>
+                                        <p:attrNameLst>
+                                          <p:attrName>style.visibility</p:attrName>
+                                        </p:attrNameLst>
+                                      </p:cBhvr>
+                                      <p:to>
+                                        <p:strVal val="visible"/>
+                                      </p:to>
+                                    </p:set>
+                                    <p:animEffect transition="in" filter="fade">
+                                      <p:cBhvr>
+                                        <p:cTn id="35" dur="2000"/>
+                                        <p:tgtEl>
+                                          <p:spTgt spid="2"/>
+                                        </p:tgtEl>
+                                      </p:cBhvr>
+                                    </p:animEffect>
+                                    <p:anim calcmode="lin" valueType="num">
+                                      <p:cBhvr>
+                                        <p:cTn id="36" dur="2000" fill="hold"/>
+                                        <p:tgtEl>
+                                          <p:spTgt spid="2"/>
+                                        </p:tgtEl>
+                                        <p:attrNameLst>
+                                          <p:attrName>style.rotation</p:attrName>
+                                        </p:attrNameLst>
+                                      </p:cBhvr>
+                                      <p:tavLst>
+                                        <p:tav tm="0">
+                                          <p:val>
+                                            <p:fltVal val="720"/>
+                                          </p:val>
+                                        </p:tav>
+                                        <p:tav tm="100000">
+                                          <p:val>
+                                            <p:fltVal val="0"/>
+                                          </p:val>
+                                        </p:tav>
+                                      </p:tavLst>
+                                    </p:anim>
+                                    <p:anim calcmode="lin" valueType="num">
+                                      <p:cBhvr>
+                                        <p:cTn id="37" dur="2000" fill="hold"/>
+                                        <p:tgtEl>
+                                          <p:spTgt spid="2"/>
+                                        </p:tgtEl>
+                                        <p:attrNameLst>
+                                          <p:attrName>ppt_h</p:attrName>
+                                        </p:attrNameLst>
+                                      </p:cBhvr>
+                                      <p:tavLst>
+                                        <p:tav tm="0">
+                                          <p:val>
+                                            <p:fltVal val="0"/>
+                                          </p:val>
+                                        </p:tav>
+                                        <p:tav tm="100000">
+                                          <p:val>
+                                            <p:strVal val="#ppt_h"/>
+                                          </p:val>
+                                        </p:tav>
+                                      </p:tavLst>
+                                    </p:anim>
+                                    <p:anim calcmode="lin" valueType="num">
+                                      <p:cBhvr>
+                                        <p:cTn id="38" dur="2000" fill="hold"/>
+                                        <p:tgtEl>
+                                          <p:spTgt spid="2"/>
+                                        </p:tgtEl>
+                                        <p:attrNameLst>
+                                          <p:attrName>ppt_w</p:attrName>
+                                        </p:attrNameLst>
+                                      </p:cBhvr>
+                                      <p:tavLst>
+                                        <p:tav tm="0">
+                                          <p:val>
+                                            <p:fltVal val="0"/>
+                                          </p:val>
+                                        </p:tav>
+                                        <p:tav tm="100000">
+                                          <p:val>
+                                            <p:strVal val="#ppt_w"/>
+                                          </p:val>
+                                        </p:tav>
+                                      </p:tavLst>
+                                    </p:anim>
+                                  </p:childTnLst>
+                                </p:cTn>
+                              </p:par>
+                            </p:childTnLst>
+                          </p:cTn>
+                        </p:par>
+                        <p:par>
+                          <p:cTn id="39" fill="hold">
+                            <p:stCondLst>
+                              <p:cond delay="10000"/>
+                            </p:stCondLst>
+                            <p:childTnLst>
+                              <p:par>
+                                <p:cTn id="40" presetID="35" presetClass="entr" presetSubtype="0" fill="hold" grpId="0" nodeType="afterEffect">
+                                  <p:stCondLst>
+                                    <p:cond delay="0"/>
+                                  </p:stCondLst>
+                                  <p:childTnLst>
+                                    <p:set>
+                                      <p:cBhvr>
+                                        <p:cTn id="41" dur="1" fill="hold">
+                                          <p:stCondLst>
+                                            <p:cond delay="0"/>
+                                          </p:stCondLst>
+                                        </p:cTn>
+                                        <p:tgtEl>
+                                          <p:spTgt spid="3">
+                                            <p:txEl>
+                                              <p:pRg st="0" end="0"/>
+                                            </p:txEl>
+                                          </p:spTgt>
+                                        </p:tgtEl>
+                                        <p:attrNameLst>
+                                          <p:attrName>style.visibility</p:attrName>
+                                        </p:attrNameLst>
+                                      </p:cBhvr>
+                                      <p:to>
+                                        <p:strVal val="visible"/>
+                                      </p:to>
+                                    </p:set>
+                                    <p:animEffect transition="in" filter="fade">
+                                      <p:cBhvr>
+                                        <p:cTn id="42" dur="2000"/>
+                                        <p:tgtEl>
+                                          <p:spTgt spid="3">
+                                            <p:txEl>
+                                              <p:pRg st="0" end="0"/>
+                                            </p:txEl>
+                                          </p:spTgt>
+                                        </p:tgtEl>
+                                      </p:cBhvr>
+                                    </p:animEffect>
+                                    <p:anim calcmode="lin" valueType="num">
+                                      <p:cBhvr>
+                                        <p:cTn id="43" dur="2000" fill="hold"/>
+                                        <p:tgtEl>
+                                          <p:spTgt spid="3">
+                                            <p:txEl>
+                                              <p:pRg st="0" end="0"/>
+                                            </p:txEl>
+                                          </p:spTgt>
+                                        </p:tgtEl>
+                                        <p:attrNameLst>
+                                          <p:attrName>style.rotation</p:attrName>
+                                        </p:attrNameLst>
+                                      </p:cBhvr>
+                                      <p:tavLst>
+                                        <p:tav tm="0">
+                                          <p:val>
+                                            <p:fltVal val="720"/>
+                                          </p:val>
+                                        </p:tav>
+                                        <p:tav tm="100000">
+                                          <p:val>
+                                            <p:fltVal val="0"/>
+                                          </p:val>
+                                        </p:tav>
+                                      </p:tavLst>
+                                    </p:anim>
+                                    <p:anim calcmode="lin" valueType="num">
+                                      <p:cBhvr>
+                                        <p:cTn id="44" dur="2000" fill="hold"/>
+                                        <p:tgtEl>
+                                          <p:spTgt spid="3">
+                                            <p:txEl>
+                                              <p:pRg st="0" end="0"/>
+                                            </p:txEl>
+                                          </p:spTgt>
+                                        </p:tgtEl>
+                                        <p:attrNameLst>
+                                          <p:attrName>ppt_h</p:attrName>
+                                        </p:attrNameLst>
+                                      </p:cBhvr>
+                                      <p:tavLst>
+                                        <p:tav tm="0">
+                                          <p:val>
+                                            <p:fltVal val="0"/>
+                                          </p:val>
+                                        </p:tav>
+                                        <p:tav tm="100000">
+                                          <p:val>
+                                            <p:strVal val="#ppt_h"/>
+                                          </p:val>
+                                        </p:tav>
+                                      </p:tavLst>
+                                    </p:anim>
+                                    <p:anim calcmode="lin" valueType="num">
+                                      <p:cBhvr>
+                                        <p:cTn id="45" dur="2000" fill="hold"/>
+                                        <p:tgtEl>
+                                          <p:spTgt spid="3">
+                                            <p:txEl>
+                                              <p:pRg st="0" end="0"/>
+                                            </p:txEl>
+                                          </p:spTgt>
+                                        </p:tgtEl>
+                                        <p:attrNameLst>
+                                          <p:attrName>ppt_w</p:attrName>
+                                        </p:attrNameLst>
+                                      </p:cBhvr>
+                                      <p:tavLst>
+                                        <p:tav tm="0">
+                                          <p:val>
+                                            <p:fltVal val="0"/>
+                                          </p:val>
+                                        </p:tav>
+                                        <p:tav tm="100000">
+                                          <p:val>
+                                            <p:strVal val="#ppt_w"/>
+                                          </p:val>
+                                        </p:tav>
+                                      </p:tavLst>
+                                    </p:anim>
+                                  </p:childTnLst>
+                                </p:cTn>
+                              </p:par>
+                            </p:childTnLst>
+                          </p:cTn>
+                        </p:par>
+                        <p:par>
+                          <p:cTn id="46" fill="hold">
+                            <p:stCondLst>
+                              <p:cond delay="12000"/>
+                            </p:stCondLst>
+                            <p:childTnLst>
+                              <p:par>
+                                <p:cTn id="47" presetID="53" presetClass="entr" presetSubtype="16" fill="hold" grpId="0" nodeType="afterEffect">
+                                  <p:stCondLst>
+                                    <p:cond delay="0"/>
+                                  </p:stCondLst>
+                                  <p:childTnLst>
+                                    <p:set>
+                                      <p:cBhvr>
+                                        <p:cTn id="48" dur="1" fill="hold">
+                                          <p:stCondLst>
+                                            <p:cond delay="0"/>
+                                          </p:stCondLst>
+                                        </p:cTn>
+                                        <p:tgtEl>
+                                          <p:spTgt spid="8"/>
+                                        </p:tgtEl>
+                                        <p:attrNameLst>
+                                          <p:attrName>style.visibility</p:attrName>
+                                        </p:attrNameLst>
+                                      </p:cBhvr>
+                                      <p:to>
+                                        <p:strVal val="visible"/>
+                                      </p:to>
+                                    </p:set>
+                                    <p:anim calcmode="lin" valueType="num">
+                                      <p:cBhvr>
+                                        <p:cTn id="49" dur="500" fill="hold"/>
+                                        <p:tgtEl>
+                                          <p:spTgt spid="8"/>
+                                        </p:tgtEl>
+                                        <p:attrNameLst>
+                                          <p:attrName>ppt_w</p:attrName>
+                                        </p:attrNameLst>
+                                      </p:cBhvr>
+                                      <p:tavLst>
+                                        <p:tav tm="0">
+                                          <p:val>
+                                            <p:fltVal val="0"/>
+                                          </p:val>
+                                        </p:tav>
+                                        <p:tav tm="100000">
+                                          <p:val>
+                                            <p:strVal val="#ppt_w"/>
+                                          </p:val>
+                                        </p:tav>
+                                      </p:tavLst>
+                                    </p:anim>
+                                    <p:anim calcmode="lin" valueType="num">
+                                      <p:cBhvr>
+                                        <p:cTn id="50" dur="500" fill="hold"/>
+                                        <p:tgtEl>
+                                          <p:spTgt spid="8"/>
+                                        </p:tgtEl>
+                                        <p:attrNameLst>
+                                          <p:attrName>ppt_h</p:attrName>
+                                        </p:attrNameLst>
+                                      </p:cBhvr>
+                                      <p:tavLst>
+                                        <p:tav tm="0">
+                                          <p:val>
+                                            <p:fltVal val="0"/>
+                                          </p:val>
+                                        </p:tav>
+                                        <p:tav tm="100000">
+                                          <p:val>
+                                            <p:strVal val="#ppt_h"/>
+                                          </p:val>
+                                        </p:tav>
+                                      </p:tavLst>
+                                    </p:anim>
+                                    <p:animEffect transition="in" filter="fade">
+                                      <p:cBhvr>
+                                        <p:cTn id="51" dur="500"/>
+                                        <p:tgtEl>
+                                          <p:spTgt spid="8"/>
+                                        </p:tgtEl>
+                                      </p:cBhvr>
+                                    </p:animEffect>
+                                  </p:childTnLst>
+                                </p:cTn>
+                              </p:par>
+                            </p:childTnLst>
+                          </p:cTn>
+                        </p:par>
+                      </p:childTnLst>
+                    </p:cTn>
+                  </p:par>
+                </p:childTnLst>
+              </p:cTn>
+              <p:prevCondLst>
+                <p:cond evt="onPrev" delay="0">
+                  <p:tgtEl>
+                    <p:sldTgt/>
+                  </p:tgtEl>
+                </p:cond>
+              </p:prevCondLst>
+              <p:nextCondLst>
+                <p:cond evt="onNext" delay="0">
+                  <p:tgtEl>
+                    <p:sldTgt/>
+                  </p:tgtEl>
+                </p:cond>
+              </p:nextCondLst>
+            </p:seq>
+          </p:childTnLst>
+        </p:cTn>
+      </p:par>
+    </p:tnLst>
+    <p:bldLst>
+      <p:bldP spid="3" grpId="0" build="p"/>
+      <p:bldP spid="4" grpId="0" build="p"/>
+      <p:bldP spid="5" grpId="0"/>
+      <p:bldP spid="6" grpId="0"/>
+      <p:bldP spid="7" grpId="0"/>
+      <p:bldP spid="8" grpId="0"/>
+      <p:bldP spid="2" grpId="0"/>
+    </p:bldLst>
+  </p:timing>
 </p:sld>
 </file>
 
@@ -11669,15 +13377,39 @@
             <p:ph type="title"/>
           </p:nvPr>
         </p:nvSpPr>
-        <p:spPr/>
+        <p:spPr>
+          <a:xfrm>
+            <a:off x="1251678" y="382385"/>
+            <a:ext cx="10178322" cy="966889"/>
+          </a:xfrm>
+        </p:spPr>
         <p:txBody>
-          <a:bodyPr/>
+          <a:bodyPr>
+            <a:normAutofit/>
+          </a:bodyPr>
           <a:lstStyle/>
           <a:p>
+            <a:pPr algn="ctr"/>
             <a:r>
               <a:rPr lang="en-GB" noProof="0" dirty="0"/>
-              <a:t>The ones I thought would work</a:t>
-            </a:r>
+              <a:t>The ones that </a:t>
+            </a:r>
+            <a:r>
+              <a:rPr lang="en-GB" i="1" noProof="0" dirty="0"/>
+              <a:t>should</a:t>
+            </a:r>
+            <a:r>
+              <a:rPr lang="en-GB" noProof="0" dirty="0"/>
+              <a:t> work</a:t>
+            </a:r>
+            <a:br>
+              <a:rPr lang="en-GB" noProof="0" dirty="0"/>
+            </a:br>
+            <a:r>
+              <a:rPr lang="en-GB" sz="1200" noProof="0" dirty="0"/>
+              <a:t>(both work as expected when debugging)</a:t>
+            </a:r>
+            <a:endParaRPr lang="en-GB" noProof="0" dirty="0"/>
           </a:p>
         </p:txBody>
       </p:sp>
@@ -11704,7 +13436,9 @@
           </a:xfrm>
         </p:spPr>
         <p:txBody>
-          <a:bodyPr/>
+          <a:bodyPr>
+            <a:normAutofit/>
+          </a:bodyPr>
           <a:lstStyle/>
           <a:p>
             <a:r>
@@ -11762,7 +13496,9 @@
           </a:xfrm>
         </p:spPr>
         <p:txBody>
-          <a:bodyPr/>
+          <a:bodyPr>
+            <a:normAutofit/>
+          </a:bodyPr>
           <a:lstStyle/>
           <a:p>
             <a:r>

</xml_diff>

<commit_message>
Final edits to presentation
</commit_message>
<xml_diff>
--- a/PizzaSolution Presentation.pptx
+++ b/PizzaSolution Presentation.pptx
@@ -2034,6 +2034,46 @@
           <a:bodyPr/>
           <a:lstStyle/>
           <a:p>
+            <a:r>
+              <a:rPr lang="da-DK" dirty="0"/>
+              <a:t>Basic </a:t>
+            </a:r>
+            <a:r>
+              <a:rPr lang="da-DK" dirty="0" err="1"/>
+              <a:t>idea</a:t>
+            </a:r>
+            <a:r>
+              <a:rPr lang="da-DK" dirty="0"/>
+              <a:t> is </a:t>
+            </a:r>
+            <a:r>
+              <a:rPr lang="da-DK" dirty="0" err="1"/>
+              <a:t>that</a:t>
+            </a:r>
+            <a:r>
+              <a:rPr lang="da-DK" dirty="0"/>
+              <a:t> it </a:t>
+            </a:r>
+            <a:r>
+              <a:rPr lang="da-DK" dirty="0" err="1"/>
+              <a:t>needs</a:t>
+            </a:r>
+            <a:r>
+              <a:rPr lang="da-DK" dirty="0"/>
+              <a:t> to </a:t>
+            </a:r>
+            <a:r>
+              <a:rPr lang="da-DK" dirty="0" err="1"/>
+              <a:t>add</a:t>
+            </a:r>
+            <a:r>
+              <a:rPr lang="da-DK" dirty="0"/>
+              <a:t> pizzas to the </a:t>
+            </a:r>
+            <a:r>
+              <a:rPr lang="da-DK" dirty="0" err="1"/>
+              <a:t>pizzaQueue</a:t>
+            </a:r>
             <a:endParaRPr lang="da-DK" dirty="0"/>
           </a:p>
         </p:txBody>
@@ -10876,7 +10916,7 @@
             <a:pPr lvl="1"/>
             <a:r>
               <a:rPr lang="en-GB" dirty="0"/>
-              <a:t>Make the first element have the correct cooking type, set rest to 0</a:t>
+              <a:t>Make the first element have the correct cooking time, set rest to 0</a:t>
             </a:r>
           </a:p>
           <a:p>
@@ -10930,10 +10970,10 @@
       </p:sp>
       <p:pic>
         <p:nvPicPr>
-          <p:cNvPr id="6" name="Pladsholder til indhold 5">
+          <p:cNvPr id="8" name="Pladsholder til indhold 7">
             <a:extLst>
               <a:ext uri="{FF2B5EF4-FFF2-40B4-BE49-F238E27FC236}">
-                <a16:creationId xmlns:a16="http://schemas.microsoft.com/office/drawing/2014/main" id="{A9129C86-25D8-BB61-FDBC-050F963302B9}"/>
+                <a16:creationId xmlns:a16="http://schemas.microsoft.com/office/drawing/2014/main" id="{BC4CFAAC-480E-A8A7-E33F-17520E111214}"/>
               </a:ext>
             </a:extLst>
           </p:cNvPr>
@@ -10952,8 +10992,8 @@
         </p:blipFill>
         <p:spPr>
           <a:xfrm>
-            <a:off x="6134102" y="1648979"/>
-            <a:ext cx="5576569" cy="4482059"/>
+            <a:off x="6938684" y="355107"/>
+            <a:ext cx="4896045" cy="6147785"/>
           </a:xfrm>
           <a:prstGeom prst="rect">
             <a:avLst/>

</xml_diff>